<commit_message>
Add deploy web UI, app/automation builders, dark/light theme, and full doc regeneration
- Deploy UI (deploy-ui.js): 10-page wizard with Qlik brand CSS, dark/light theme
  toggle, test connection button, responsive layout, toggle switch fixes
- Build Apps (build-apps.js): Engine API app builder from app-definitions.json
- Build Automations (build-automations.js): automation builder from definitions
- Generators: creation guide, setup guide, generate-all script
- Rename Qlik Sense → Qlik Analytics across all files
- Fix demo overview PPT: 2 apps (10 sheets), corrected GA dates
- Regenerate all documents, demo scripts, policies, SOPs, carrier contracts
- Add CI workflow, LICENSE, README, schema.sql, load scripts
- Remove legacy Python deploy script
- Merge Theme Upload into Build Apps page, remove .qvf app import
- Rename project to MCG Full Stack

Co-Authored-By: Claude Opus 4.6 <noreply@anthropic.com>
</commit_message>
<xml_diff>
--- a/MCG_Technology_Architecture.pptx
+++ b/MCG_Technology_Architecture.pptx
@@ -5896,7 +5896,7 @@
                 <a:ea typeface="Inter" pitchFamily="34" charset="-122"/>
                 <a:cs typeface="Inter" pitchFamily="34" charset="-120"/>
               </a:rPr>
-              <a:t>2 Qlik Sense apps (10 sheets)  •  MCG Dark Theme  •  Streaming IoT  •  Alerts  •  Reports</a:t>
+              <a:t>2 Qlik Analytics apps (10 sheets)  •  MCG Dark Theme  •  Streaming IoT  •  Alerts  •  Reports</a:t>
             </a:r>
             <a:endParaRPr lang="en-US" sz="1100" dirty="0"/>
           </a:p>
@@ -7898,7 +7898,7 @@
                 <a:ea typeface="Inter" pitchFamily="34" charset="-122"/>
                 <a:cs typeface="Inter" pitchFamily="34" charset="-120"/>
               </a:rPr>
-              <a:t>Qlik Sense</a:t>
+              <a:t>Qlik Analytics</a:t>
             </a:r>
             <a:endParaRPr lang="en-US" sz="1200" dirty="0"/>
           </a:p>
@@ -16615,7 +16615,7 @@
                 <a:ea typeface="Inter" pitchFamily="34" charset="-122"/>
                 <a:cs typeface="Inter" pitchFamily="34" charset="-120"/>
               </a:rPr>
-              <a:t>Qlik Sense  •  Predict  •  Answers  •  Discovery Agent  •  MCP</a:t>
+              <a:t>Qlik Analytics  •  Predict  •  Answers  •  Discovery Agent  •  MCP</a:t>
             </a:r>
             <a:endParaRPr lang="en-US" sz="1600" dirty="0"/>
           </a:p>
@@ -16894,7 +16894,7 @@
                 <a:ea typeface="Inter" pitchFamily="34" charset="-122"/>
                 <a:cs typeface="Inter" pitchFamily="34" charset="-120"/>
               </a:rPr>
-              <a:t>Qlik Sense — 2 Domain Apps</a:t>
+              <a:t>Qlik Analytics — 2 Domain Apps</a:t>
             </a:r>
             <a:endParaRPr lang="en-US" sz="1400" dirty="0"/>
           </a:p>

</xml_diff>

<commit_message>
Regenerate documents and decks, add Technology Architecture v2
- Update 9 generators (demo scripts, setup/creation guides, glossary
  Excel, architecture and demo overview decks, carriers, governance)
- Regenerate all 38 Word/Excel documents and both PPTX decks
- Add MCG_Technology_Architecture_v2.pptx

Co-Authored-By: Claude Fable 5 <noreply@anthropic.com>
</commit_message>
<xml_diff>
--- a/MCG_Technology_Architecture.pptx
+++ b/MCG_Technology_Architecture.pptx
@@ -1856,7 +1856,7 @@
       </p:grpSpPr>
       <p:pic>
         <p:nvPicPr>
-          <p:cNvPr id="2" name="Image 0" descr="C:\Claude\End-To-End Demo\generators\assets\qlik_cover_bg.png">    </p:cNvPr>
+          <p:cNvPr id="2" name="Image 0" descr="C:\Claude\MCG Full Stack\generators\assets\qlik_cover_bg.png">    </p:cNvPr>
           <p:cNvPicPr>
             <a:picLocks noChangeAspect="1"/>
           </p:cNvPicPr>
@@ -1880,7 +1880,7 @@
       </p:pic>
       <p:pic>
         <p:nvPicPr>
-          <p:cNvPr id="3" name="Image 1" descr="C:\Claude\End-To-End Demo\generators\assets\qlik_logo.png">    </p:cNvPr>
+          <p:cNvPr id="3" name="Image 1" descr="C:\Claude\MCG Full Stack\generators\assets\qlik_logo.png">    </p:cNvPr>
           <p:cNvPicPr>
             <a:picLocks noChangeAspect="1"/>
           </p:cNvPicPr>
@@ -2422,7 +2422,7 @@
       </p:sp>
       <p:pic>
         <p:nvPicPr>
-          <p:cNvPr id="4" name="Image 0" descr="C:\Claude\End-To-End Demo\generators\assets\qlik_logo.png">    </p:cNvPr>
+          <p:cNvPr id="4" name="Image 0" descr="C:\Claude\MCG Full Stack\generators\assets\qlik_logo.png">    </p:cNvPr>
           <p:cNvPicPr>
             <a:picLocks noChangeAspect="1"/>
           </p:cNvPicPr>
@@ -3987,7 +3987,7 @@
       </p:sp>
       <p:pic>
         <p:nvPicPr>
-          <p:cNvPr id="4" name="Image 0" descr="C:\Claude\End-To-End Demo\generators\assets\qlik_logo.png">    </p:cNvPr>
+          <p:cNvPr id="4" name="Image 0" descr="C:\Claude\MCG Full Stack\generators\assets\qlik_logo.png">    </p:cNvPr>
           <p:cNvPicPr>
             <a:picLocks noChangeAspect="1"/>
           </p:cNvPicPr>
@@ -5363,7 +5363,7 @@
       </p:sp>
       <p:pic>
         <p:nvPicPr>
-          <p:cNvPr id="4" name="Image 0" descr="C:\Claude\End-To-End Demo\generators\assets\qlik_logo.png">    </p:cNvPr>
+          <p:cNvPr id="4" name="Image 0" descr="C:\Claude\MCG Full Stack\generators\assets\qlik_logo.png">    </p:cNvPr>
           <p:cNvPicPr>
             <a:picLocks noChangeAspect="1"/>
           </p:cNvPicPr>
@@ -6337,7 +6337,7 @@
       </p:sp>
       <p:pic>
         <p:nvPicPr>
-          <p:cNvPr id="4" name="Image 0" descr="C:\Claude\End-To-End Demo\generators\assets\qlik_logo.png">    </p:cNvPr>
+          <p:cNvPr id="4" name="Image 0" descr="C:\Claude\MCG Full Stack\generators\assets\qlik_logo.png">    </p:cNvPr>
           <p:cNvPicPr>
             <a:picLocks noChangeAspect="1"/>
           </p:cNvPicPr>
@@ -8991,7 +8991,7 @@
       </p:sp>
       <p:pic>
         <p:nvPicPr>
-          <p:cNvPr id="4" name="Image 0" descr="C:\Claude\End-To-End Demo\generators\assets\qlik_logo.png">    </p:cNvPr>
+          <p:cNvPr id="4" name="Image 0" descr="C:\Claude\MCG Full Stack\generators\assets\qlik_logo.png">    </p:cNvPr>
           <p:cNvPicPr>
             <a:picLocks noChangeAspect="1"/>
           </p:cNvPicPr>
@@ -10802,7 +10802,7 @@
       </p:sp>
       <p:pic>
         <p:nvPicPr>
-          <p:cNvPr id="4" name="Image 0" descr="C:\Claude\End-To-End Demo\generators\assets\qlik_logo.png">    </p:cNvPr>
+          <p:cNvPr id="4" name="Image 0" descr="C:\Claude\MCG Full Stack\generators\assets\qlik_logo.png">    </p:cNvPr>
           <p:cNvPicPr>
             <a:picLocks noChangeAspect="1"/>
           </p:cNvPicPr>
@@ -12518,336 +12518,6 @@
         </p:nvSpPr>
         <p:spPr>
           <a:xfrm>
-            <a:off x="8183880" y="2898648"/>
-            <a:ext cx="3291840" cy="420624"/>
-          </a:xfrm>
-          <a:prstGeom prst="roundRect">
-            <a:avLst>
-              <a:gd name="adj" fmla="val 13043"/>
-            </a:avLst>
-          </a:prstGeom>
-          <a:solidFill>
-            <a:srgbClr val="FFFFFF"/>
-          </a:solidFill>
-          <a:ln w="9525">
-            <a:solidFill>
-              <a:srgbClr val="19416C"/>
-            </a:solidFill>
-            <a:prstDash val="solid"/>
-          </a:ln>
-        </p:spPr>
-      </p:sp>
-      <p:sp>
-        <p:nvSpPr>
-          <p:cNvPr id="57" name="Text 54"/>
-          <p:cNvSpPr/>
-          <p:nvPr/>
-        </p:nvSpPr>
-        <p:spPr>
-          <a:xfrm>
-            <a:off x="8302752" y="2898648"/>
-            <a:ext cx="3054096" cy="420624"/>
-          </a:xfrm>
-          <a:prstGeom prst="rect">
-            <a:avLst/>
-          </a:prstGeom>
-          <a:noFill/>
-          <a:ln/>
-        </p:spPr>
-        <p:txBody>
-          <a:bodyPr wrap="square" rtlCol="0" anchor="ctr"/>
-          <a:lstStyle/>
-          <a:p>
-            <a:pPr indent="0" marL="0">
-              <a:buNone/>
-            </a:pPr>
-            <a:r>
-              <a:rPr lang="en-US" sz="1000" dirty="0">
-                <a:solidFill>
-                  <a:srgbClr val="454659"/>
-                </a:solidFill>
-                <a:latin typeface="Inter" pitchFamily="34" charset="0"/>
-                <a:ea typeface="Inter" pitchFamily="34" charset="-122"/>
-                <a:cs typeface="Inter" pitchFamily="34" charset="-120"/>
-              </a:rPr>
-              <a:t>cold_chain_compliance</a:t>
-            </a:r>
-            <a:endParaRPr lang="en-US" sz="1000" dirty="0"/>
-          </a:p>
-        </p:txBody>
-      </p:sp>
-      <p:sp>
-        <p:nvSpPr>
-          <p:cNvPr id="58" name="Shape 55"/>
-          <p:cNvSpPr/>
-          <p:nvPr/>
-        </p:nvSpPr>
-        <p:spPr>
-          <a:xfrm>
-            <a:off x="8183880" y="3410712"/>
-            <a:ext cx="3291840" cy="420624"/>
-          </a:xfrm>
-          <a:prstGeom prst="roundRect">
-            <a:avLst>
-              <a:gd name="adj" fmla="val 13043"/>
-            </a:avLst>
-          </a:prstGeom>
-          <a:solidFill>
-            <a:srgbClr val="FFFFFF"/>
-          </a:solidFill>
-          <a:ln w="9525">
-            <a:solidFill>
-              <a:srgbClr val="19416C"/>
-            </a:solidFill>
-            <a:prstDash val="solid"/>
-          </a:ln>
-        </p:spPr>
-      </p:sp>
-      <p:sp>
-        <p:nvSpPr>
-          <p:cNvPr id="59" name="Text 56"/>
-          <p:cNvSpPr/>
-          <p:nvPr/>
-        </p:nvSpPr>
-        <p:spPr>
-          <a:xfrm>
-            <a:off x="8302752" y="3410712"/>
-            <a:ext cx="3054096" cy="420624"/>
-          </a:xfrm>
-          <a:prstGeom prst="rect">
-            <a:avLst/>
-          </a:prstGeom>
-          <a:noFill/>
-          <a:ln/>
-        </p:spPr>
-        <p:txBody>
-          <a:bodyPr wrap="square" rtlCol="0" anchor="ctr"/>
-          <a:lstStyle/>
-          <a:p>
-            <a:pPr indent="0" marL="0">
-              <a:buNone/>
-            </a:pPr>
-            <a:r>
-              <a:rPr lang="en-US" sz="1000" dirty="0">
-                <a:solidFill>
-                  <a:srgbClr val="454659"/>
-                </a:solidFill>
-                <a:latin typeface="Inter" pitchFamily="34" charset="0"/>
-                <a:ea typeface="Inter" pitchFamily="34" charset="-122"/>
-                <a:cs typeface="Inter" pitchFamily="34" charset="-120"/>
-              </a:rPr>
-              <a:t>product_master_360</a:t>
-            </a:r>
-            <a:endParaRPr lang="en-US" sz="1000" dirty="0"/>
-          </a:p>
-        </p:txBody>
-      </p:sp>
-      <p:sp>
-        <p:nvSpPr>
-          <p:cNvPr id="60" name="Shape 57"/>
-          <p:cNvSpPr/>
-          <p:nvPr/>
-        </p:nvSpPr>
-        <p:spPr>
-          <a:xfrm>
-            <a:off x="8183880" y="3922776"/>
-            <a:ext cx="3291840" cy="420624"/>
-          </a:xfrm>
-          <a:prstGeom prst="roundRect">
-            <a:avLst>
-              <a:gd name="adj" fmla="val 13043"/>
-            </a:avLst>
-          </a:prstGeom>
-          <a:solidFill>
-            <a:srgbClr val="FFFFFF"/>
-          </a:solidFill>
-          <a:ln w="9525">
-            <a:solidFill>
-              <a:srgbClr val="19416C"/>
-            </a:solidFill>
-            <a:prstDash val="solid"/>
-          </a:ln>
-        </p:spPr>
-      </p:sp>
-      <p:sp>
-        <p:nvSpPr>
-          <p:cNvPr id="61" name="Text 58"/>
-          <p:cNvSpPr/>
-          <p:nvPr/>
-        </p:nvSpPr>
-        <p:spPr>
-          <a:xfrm>
-            <a:off x="8302752" y="3922776"/>
-            <a:ext cx="3054096" cy="420624"/>
-          </a:xfrm>
-          <a:prstGeom prst="rect">
-            <a:avLst/>
-          </a:prstGeom>
-          <a:noFill/>
-          <a:ln/>
-        </p:spPr>
-        <p:txBody>
-          <a:bodyPr wrap="square" rtlCol="0" anchor="ctr"/>
-          <a:lstStyle/>
-          <a:p>
-            <a:pPr indent="0" marL="0">
-              <a:buNone/>
-            </a:pPr>
-            <a:r>
-              <a:rPr lang="en-US" sz="1000" dirty="0">
-                <a:solidFill>
-                  <a:srgbClr val="454659"/>
-                </a:solidFill>
-                <a:latin typeface="Inter" pitchFamily="34" charset="0"/>
-                <a:ea typeface="Inter" pitchFamily="34" charset="-122"/>
-                <a:cs typeface="Inter" pitchFamily="34" charset="-120"/>
-              </a:rPr>
-              <a:t>customer_delivery_experience</a:t>
-            </a:r>
-            <a:endParaRPr lang="en-US" sz="1000" dirty="0"/>
-          </a:p>
-        </p:txBody>
-      </p:sp>
-      <p:sp>
-        <p:nvSpPr>
-          <p:cNvPr id="62" name="Shape 59"/>
-          <p:cNvSpPr/>
-          <p:nvPr/>
-        </p:nvSpPr>
-        <p:spPr>
-          <a:xfrm>
-            <a:off x="8183880" y="4434840"/>
-            <a:ext cx="3291840" cy="420624"/>
-          </a:xfrm>
-          <a:prstGeom prst="roundRect">
-            <a:avLst>
-              <a:gd name="adj" fmla="val 13043"/>
-            </a:avLst>
-          </a:prstGeom>
-          <a:solidFill>
-            <a:srgbClr val="FFFFFF"/>
-          </a:solidFill>
-          <a:ln w="9525">
-            <a:solidFill>
-              <a:srgbClr val="19416C"/>
-            </a:solidFill>
-            <a:prstDash val="solid"/>
-          </a:ln>
-        </p:spPr>
-      </p:sp>
-      <p:sp>
-        <p:nvSpPr>
-          <p:cNvPr id="63" name="Text 60"/>
-          <p:cNvSpPr/>
-          <p:nvPr/>
-        </p:nvSpPr>
-        <p:spPr>
-          <a:xfrm>
-            <a:off x="8302752" y="4434840"/>
-            <a:ext cx="3054096" cy="420624"/>
-          </a:xfrm>
-          <a:prstGeom prst="rect">
-            <a:avLst/>
-          </a:prstGeom>
-          <a:noFill/>
-          <a:ln/>
-        </p:spPr>
-        <p:txBody>
-          <a:bodyPr wrap="square" rtlCol="0" anchor="ctr"/>
-          <a:lstStyle/>
-          <a:p>
-            <a:pPr indent="0" marL="0">
-              <a:buNone/>
-            </a:pPr>
-            <a:r>
-              <a:rPr lang="en-US" sz="1000" dirty="0">
-                <a:solidFill>
-                  <a:srgbClr val="454659"/>
-                </a:solidFill>
-                <a:latin typeface="Inter" pitchFamily="34" charset="0"/>
-                <a:ea typeface="Inter" pitchFamily="34" charset="-122"/>
-                <a:cs typeface="Inter" pitchFamily="34" charset="-120"/>
-              </a:rPr>
-              <a:t>compliance_readiness</a:t>
-            </a:r>
-            <a:endParaRPr lang="en-US" sz="1000" dirty="0"/>
-          </a:p>
-        </p:txBody>
-      </p:sp>
-      <p:sp>
-        <p:nvSpPr>
-          <p:cNvPr id="64" name="Shape 61"/>
-          <p:cNvSpPr/>
-          <p:nvPr/>
-        </p:nvSpPr>
-        <p:spPr>
-          <a:xfrm>
-            <a:off x="8183880" y="4946904"/>
-            <a:ext cx="3291840" cy="420624"/>
-          </a:xfrm>
-          <a:prstGeom prst="roundRect">
-            <a:avLst>
-              <a:gd name="adj" fmla="val 13043"/>
-            </a:avLst>
-          </a:prstGeom>
-          <a:solidFill>
-            <a:srgbClr val="FFFFFF"/>
-          </a:solidFill>
-          <a:ln w="9525">
-            <a:solidFill>
-              <a:srgbClr val="19416C"/>
-            </a:solidFill>
-            <a:prstDash val="solid"/>
-          </a:ln>
-        </p:spPr>
-      </p:sp>
-      <p:sp>
-        <p:nvSpPr>
-          <p:cNvPr id="65" name="Text 62"/>
-          <p:cNvSpPr/>
-          <p:nvPr/>
-        </p:nvSpPr>
-        <p:spPr>
-          <a:xfrm>
-            <a:off x="8302752" y="4946904"/>
-            <a:ext cx="3054096" cy="420624"/>
-          </a:xfrm>
-          <a:prstGeom prst="rect">
-            <a:avLst/>
-          </a:prstGeom>
-          <a:noFill/>
-          <a:ln/>
-        </p:spPr>
-        <p:txBody>
-          <a:bodyPr wrap="square" rtlCol="0" anchor="ctr"/>
-          <a:lstStyle/>
-          <a:p>
-            <a:pPr indent="0" marL="0">
-              <a:buNone/>
-            </a:pPr>
-            <a:r>
-              <a:rPr lang="en-US" sz="1000" dirty="0">
-                <a:solidFill>
-                  <a:srgbClr val="454659"/>
-                </a:solidFill>
-                <a:latin typeface="Inter" pitchFamily="34" charset="0"/>
-                <a:ea typeface="Inter" pitchFamily="34" charset="-122"/>
-                <a:cs typeface="Inter" pitchFamily="34" charset="-120"/>
-              </a:rPr>
-              <a:t>operational_cost_impact</a:t>
-            </a:r>
-            <a:endParaRPr lang="en-US" sz="1000" dirty="0"/>
-          </a:p>
-        </p:txBody>
-      </p:sp>
-      <p:sp>
-        <p:nvSpPr>
-          <p:cNvPr id="66" name="Shape 63"/>
-          <p:cNvSpPr/>
-          <p:nvPr/>
-        </p:nvSpPr>
-        <p:spPr>
-          <a:xfrm>
             <a:off x="3749040" y="3474720"/>
             <a:ext cx="457200" cy="0"/>
           </a:xfrm>
@@ -12866,7 +12536,7 @@
       </p:sp>
       <p:sp>
         <p:nvSpPr>
-          <p:cNvPr id="67" name="Shape 64"/>
+          <p:cNvPr id="57" name="Shape 54"/>
           <p:cNvSpPr/>
           <p:nvPr/>
         </p:nvSpPr>
@@ -12890,7 +12560,7 @@
       </p:sp>
       <p:sp>
         <p:nvSpPr>
-          <p:cNvPr id="68" name="Text 65"/>
+          <p:cNvPr id="58" name="Text 55"/>
           <p:cNvSpPr/>
           <p:nvPr/>
         </p:nvSpPr>
@@ -12946,7 +12616,7 @@
       </p:sp>
       <p:sp>
         <p:nvSpPr>
-          <p:cNvPr id="69" name="Text 66"/>
+          <p:cNvPr id="59" name="Text 56"/>
           <p:cNvSpPr/>
           <p:nvPr/>
         </p:nvSpPr>
@@ -13074,7 +12744,7 @@
       </p:sp>
       <p:pic>
         <p:nvPicPr>
-          <p:cNvPr id="4" name="Image 0" descr="C:\Claude\End-To-End Demo\generators\assets\qlik_logo.png">    </p:cNvPr>
+          <p:cNvPr id="4" name="Image 0" descr="C:\Claude\MCG Full Stack\generators\assets\qlik_logo.png">    </p:cNvPr>
           <p:cNvPicPr>
             <a:picLocks noChangeAspect="1"/>
           </p:cNvPicPr>
@@ -14588,7 +14258,7 @@
       </p:sp>
       <p:pic>
         <p:nvPicPr>
-          <p:cNvPr id="4" name="Image 0" descr="C:\Claude\End-To-End Demo\generators\assets\qlik_logo.png">    </p:cNvPr>
+          <p:cNvPr id="4" name="Image 0" descr="C:\Claude\MCG Full Stack\generators\assets\qlik_logo.png">    </p:cNvPr>
           <p:cNvPicPr>
             <a:picLocks noChangeAspect="1"/>
           </p:cNvPicPr>
@@ -14721,7 +14391,7 @@
                 <a:ea typeface="Inter" pitchFamily="34" charset="-122"/>
                 <a:cs typeface="Inter" pitchFamily="34" charset="-120"/>
               </a:rPr>
-              <a:t>7 Gold-Layer Data Products</a:t>
+              <a:t>2 Gold-Layer Data Products</a:t>
             </a:r>
             <a:endParaRPr lang="en-US" sz="2200" dirty="0"/>
           </a:p>
@@ -15195,1251 +14865,6 @@
         <p:spPr>
           <a:xfrm>
             <a:off x="3337560" y="2743200"/>
-            <a:ext cx="2697480" cy="274320"/>
-          </a:xfrm>
-          <a:prstGeom prst="rect">
-            <a:avLst/>
-          </a:prstGeom>
-          <a:noFill/>
-          <a:ln/>
-        </p:spPr>
-        <p:txBody>
-          <a:bodyPr wrap="square" rtlCol="0" anchor="ctr"/>
-          <a:lstStyle/>
-          <a:p>
-            <a:pPr algn="ctr" indent="0" marL="0">
-              <a:buNone/>
-            </a:pPr>
-            <a:r>
-              <a:rPr lang="en-US" sz="900" i="1" dirty="0">
-                <a:solidFill>
-                  <a:srgbClr val="A9B3B6"/>
-                </a:solidFill>
-                <a:latin typeface="Inter" pitchFamily="34" charset="0"/>
-                <a:ea typeface="Inter" pitchFamily="34" charset="-122"/>
-                <a:cs typeface="Inter" pitchFamily="34" charset="-120"/>
-              </a:rPr>
-              <a:t>Trust Score  •  API Sharing  •  Lineage</a:t>
-            </a:r>
-            <a:endParaRPr lang="en-US" sz="900" dirty="0"/>
-          </a:p>
-        </p:txBody>
-      </p:sp>
-      <p:sp>
-        <p:nvSpPr>
-          <p:cNvPr id="22" name="Shape 19"/>
-          <p:cNvSpPr/>
-          <p:nvPr/>
-        </p:nvSpPr>
-        <p:spPr>
-          <a:xfrm>
-            <a:off x="6217920" y="1005840"/>
-            <a:ext cx="2697480" cy="2331720"/>
-          </a:xfrm>
-          <a:prstGeom prst="roundRect">
-            <a:avLst>
-              <a:gd name="adj" fmla="val 4706"/>
-            </a:avLst>
-          </a:prstGeom>
-          <a:solidFill>
-            <a:srgbClr val="FFFFFF"/>
-          </a:solidFill>
-          <a:ln w="19050">
-            <a:solidFill>
-              <a:srgbClr val="006580"/>
-            </a:solidFill>
-            <a:prstDash val="solid"/>
-          </a:ln>
-          <a:effectLst>
-            <a:outerShdw sx="100000" sy="100000" kx="0" ky="0" algn="bl" rotWithShape="0" blurRad="50800" dist="19050" dir="16200000">
-              <a:srgbClr val="000000">
-                <a:alpha val="8000"/>
-              </a:srgbClr>
-            </a:outerShdw>
-          </a:effectLst>
-        </p:spPr>
-      </p:sp>
-      <p:sp>
-        <p:nvSpPr>
-          <p:cNvPr id="23" name="Shape 20"/>
-          <p:cNvSpPr/>
-          <p:nvPr/>
-        </p:nvSpPr>
-        <p:spPr>
-          <a:xfrm>
-            <a:off x="6291072" y="1060704"/>
-            <a:ext cx="2551176" cy="54864"/>
-          </a:xfrm>
-          <a:prstGeom prst="rect">
-            <a:avLst/>
-          </a:prstGeom>
-          <a:solidFill>
-            <a:srgbClr val="006580"/>
-          </a:solidFill>
-          <a:ln/>
-        </p:spPr>
-      </p:sp>
-      <p:sp>
-        <p:nvSpPr>
-          <p:cNvPr id="24" name="Text 21"/>
-          <p:cNvSpPr/>
-          <p:nvPr/>
-        </p:nvSpPr>
-        <p:spPr>
-          <a:xfrm>
-            <a:off x="6217920" y="1188720"/>
-            <a:ext cx="2697480" cy="411480"/>
-          </a:xfrm>
-          <a:prstGeom prst="rect">
-            <a:avLst/>
-          </a:prstGeom>
-          <a:noFill/>
-          <a:ln/>
-        </p:spPr>
-        <p:txBody>
-          <a:bodyPr wrap="square" rtlCol="0" anchor="ctr"/>
-          <a:lstStyle/>
-          <a:p>
-            <a:pPr algn="ctr" indent="0" marL="0">
-              <a:buNone/>
-            </a:pPr>
-            <a:r>
-              <a:rPr lang="en-US" sz="1300" b="1" dirty="0">
-                <a:solidFill>
-                  <a:srgbClr val="19416C"/>
-                </a:solidFill>
-                <a:latin typeface="Inter" pitchFamily="34" charset="0"/>
-                <a:ea typeface="Inter" pitchFamily="34" charset="-122"/>
-                <a:cs typeface="Inter" pitchFamily="34" charset="-120"/>
-              </a:rPr>
-              <a:t>Cold Chain Compliance</a:t>
-            </a:r>
-            <a:endParaRPr lang="en-US" sz="1300" dirty="0"/>
-          </a:p>
-        </p:txBody>
-      </p:sp>
-      <p:sp>
-        <p:nvSpPr>
-          <p:cNvPr id="25" name="Text 22"/>
-          <p:cNvSpPr/>
-          <p:nvPr/>
-        </p:nvSpPr>
-        <p:spPr>
-          <a:xfrm>
-            <a:off x="6400800" y="1691640"/>
-            <a:ext cx="2331720" cy="274320"/>
-          </a:xfrm>
-          <a:prstGeom prst="rect">
-            <a:avLst/>
-          </a:prstGeom>
-          <a:noFill/>
-          <a:ln/>
-        </p:spPr>
-        <p:txBody>
-          <a:bodyPr wrap="square" rtlCol="0" anchor="ctr"/>
-          <a:lstStyle/>
-          <a:p>
-            <a:pPr indent="0" marL="0">
-              <a:buNone/>
-            </a:pPr>
-            <a:r>
-              <a:rPr lang="en-US" sz="1000" dirty="0">
-                <a:solidFill>
-                  <a:srgbClr val="6B7280"/>
-                </a:solidFill>
-                <a:latin typeface="Inter" pitchFamily="34" charset="0"/>
-                <a:ea typeface="Inter" pitchFamily="34" charset="-122"/>
-                <a:cs typeface="Inter" pitchFamily="34" charset="-120"/>
-              </a:rPr>
-              <a:t>Owner: Thomas Brennan</a:t>
-            </a:r>
-            <a:endParaRPr lang="en-US" sz="1000" dirty="0"/>
-          </a:p>
-        </p:txBody>
-      </p:sp>
-      <p:sp>
-        <p:nvSpPr>
-          <p:cNvPr id="26" name="Text 23"/>
-          <p:cNvSpPr/>
-          <p:nvPr/>
-        </p:nvSpPr>
-        <p:spPr>
-          <a:xfrm>
-            <a:off x="6400800" y="1965960"/>
-            <a:ext cx="2331720" cy="274320"/>
-          </a:xfrm>
-          <a:prstGeom prst="rect">
-            <a:avLst/>
-          </a:prstGeom>
-          <a:noFill/>
-          <a:ln/>
-        </p:spPr>
-        <p:txBody>
-          <a:bodyPr wrap="square" rtlCol="0" anchor="ctr"/>
-          <a:lstStyle/>
-          <a:p>
-            <a:pPr indent="0" marL="0">
-              <a:buNone/>
-            </a:pPr>
-            <a:r>
-              <a:rPr lang="en-US" sz="1000" dirty="0">
-                <a:solidFill>
-                  <a:srgbClr val="6B7280"/>
-                </a:solidFill>
-                <a:latin typeface="Inter" pitchFamily="34" charset="0"/>
-                <a:ea typeface="Inter" pitchFamily="34" charset="-122"/>
-                <a:cs typeface="Inter" pitchFamily="34" charset="-120"/>
-              </a:rPr>
-              <a:t>Refresh: 5 min</a:t>
-            </a:r>
-            <a:endParaRPr lang="en-US" sz="1000" dirty="0"/>
-          </a:p>
-        </p:txBody>
-      </p:sp>
-      <p:sp>
-        <p:nvSpPr>
-          <p:cNvPr id="27" name="Text 24"/>
-          <p:cNvSpPr/>
-          <p:nvPr/>
-        </p:nvSpPr>
-        <p:spPr>
-          <a:xfrm>
-            <a:off x="6400800" y="2240280"/>
-            <a:ext cx="2331720" cy="274320"/>
-          </a:xfrm>
-          <a:prstGeom prst="rect">
-            <a:avLst/>
-          </a:prstGeom>
-          <a:noFill/>
-          <a:ln/>
-        </p:spPr>
-        <p:txBody>
-          <a:bodyPr wrap="square" rtlCol="0" anchor="ctr"/>
-          <a:lstStyle/>
-          <a:p>
-            <a:pPr indent="0" marL="0">
-              <a:buNone/>
-            </a:pPr>
-            <a:r>
-              <a:rPr lang="en-US" sz="1100" b="1" dirty="0">
-                <a:solidFill>
-                  <a:srgbClr val="006580"/>
-                </a:solidFill>
-                <a:latin typeface="Inter" pitchFamily="34" charset="0"/>
-                <a:ea typeface="Inter" pitchFamily="34" charset="-122"/>
-                <a:cs typeface="Inter" pitchFamily="34" charset="-120"/>
-              </a:rPr>
-              <a:t>KPI: Spoilage risk score</a:t>
-            </a:r>
-            <a:endParaRPr lang="en-US" sz="1100" dirty="0"/>
-          </a:p>
-        </p:txBody>
-      </p:sp>
-      <p:sp>
-        <p:nvSpPr>
-          <p:cNvPr id="28" name="Text 25"/>
-          <p:cNvSpPr/>
-          <p:nvPr/>
-        </p:nvSpPr>
-        <p:spPr>
-          <a:xfrm>
-            <a:off x="6217920" y="2743200"/>
-            <a:ext cx="2697480" cy="274320"/>
-          </a:xfrm>
-          <a:prstGeom prst="rect">
-            <a:avLst/>
-          </a:prstGeom>
-          <a:noFill/>
-          <a:ln/>
-        </p:spPr>
-        <p:txBody>
-          <a:bodyPr wrap="square" rtlCol="0" anchor="ctr"/>
-          <a:lstStyle/>
-          <a:p>
-            <a:pPr algn="ctr" indent="0" marL="0">
-              <a:buNone/>
-            </a:pPr>
-            <a:r>
-              <a:rPr lang="en-US" sz="900" i="1" dirty="0">
-                <a:solidFill>
-                  <a:srgbClr val="A9B3B6"/>
-                </a:solidFill>
-                <a:latin typeface="Inter" pitchFamily="34" charset="0"/>
-                <a:ea typeface="Inter" pitchFamily="34" charset="-122"/>
-                <a:cs typeface="Inter" pitchFamily="34" charset="-120"/>
-              </a:rPr>
-              <a:t>Trust Score  •  API Sharing  •  Lineage</a:t>
-            </a:r>
-            <a:endParaRPr lang="en-US" sz="900" dirty="0"/>
-          </a:p>
-        </p:txBody>
-      </p:sp>
-      <p:sp>
-        <p:nvSpPr>
-          <p:cNvPr id="29" name="Shape 26"/>
-          <p:cNvSpPr/>
-          <p:nvPr/>
-        </p:nvSpPr>
-        <p:spPr>
-          <a:xfrm>
-            <a:off x="9098280" y="1005840"/>
-            <a:ext cx="2697480" cy="2331720"/>
-          </a:xfrm>
-          <a:prstGeom prst="roundRect">
-            <a:avLst>
-              <a:gd name="adj" fmla="val 4706"/>
-            </a:avLst>
-          </a:prstGeom>
-          <a:solidFill>
-            <a:srgbClr val="FFFFFF"/>
-          </a:solidFill>
-          <a:ln w="19050">
-            <a:solidFill>
-              <a:srgbClr val="009845"/>
-            </a:solidFill>
-            <a:prstDash val="solid"/>
-          </a:ln>
-          <a:effectLst>
-            <a:outerShdw sx="100000" sy="100000" kx="0" ky="0" algn="bl" rotWithShape="0" blurRad="50800" dist="19050" dir="16200000">
-              <a:srgbClr val="000000">
-                <a:alpha val="8000"/>
-              </a:srgbClr>
-            </a:outerShdw>
-          </a:effectLst>
-        </p:spPr>
-      </p:sp>
-      <p:sp>
-        <p:nvSpPr>
-          <p:cNvPr id="30" name="Shape 27"/>
-          <p:cNvSpPr/>
-          <p:nvPr/>
-        </p:nvSpPr>
-        <p:spPr>
-          <a:xfrm>
-            <a:off x="9171432" y="1060704"/>
-            <a:ext cx="2551176" cy="54864"/>
-          </a:xfrm>
-          <a:prstGeom prst="rect">
-            <a:avLst/>
-          </a:prstGeom>
-          <a:solidFill>
-            <a:srgbClr val="009845"/>
-          </a:solidFill>
-          <a:ln/>
-        </p:spPr>
-      </p:sp>
-      <p:sp>
-        <p:nvSpPr>
-          <p:cNvPr id="31" name="Text 28"/>
-          <p:cNvSpPr/>
-          <p:nvPr/>
-        </p:nvSpPr>
-        <p:spPr>
-          <a:xfrm>
-            <a:off x="9098280" y="1188720"/>
-            <a:ext cx="2697480" cy="411480"/>
-          </a:xfrm>
-          <a:prstGeom prst="rect">
-            <a:avLst/>
-          </a:prstGeom>
-          <a:noFill/>
-          <a:ln/>
-        </p:spPr>
-        <p:txBody>
-          <a:bodyPr wrap="square" rtlCol="0" anchor="ctr"/>
-          <a:lstStyle/>
-          <a:p>
-            <a:pPr algn="ctr" indent="0" marL="0">
-              <a:buNone/>
-            </a:pPr>
-            <a:r>
-              <a:rPr lang="en-US" sz="1300" b="1" dirty="0">
-                <a:solidFill>
-                  <a:srgbClr val="19416C"/>
-                </a:solidFill>
-                <a:latin typeface="Inter" pitchFamily="34" charset="0"/>
-                <a:ea typeface="Inter" pitchFamily="34" charset="-122"/>
-                <a:cs typeface="Inter" pitchFamily="34" charset="-120"/>
-              </a:rPr>
-              <a:t>Product Master 360</a:t>
-            </a:r>
-            <a:endParaRPr lang="en-US" sz="1300" dirty="0"/>
-          </a:p>
-        </p:txBody>
-      </p:sp>
-      <p:sp>
-        <p:nvSpPr>
-          <p:cNvPr id="32" name="Text 29"/>
-          <p:cNvSpPr/>
-          <p:nvPr/>
-        </p:nvSpPr>
-        <p:spPr>
-          <a:xfrm>
-            <a:off x="9281160" y="1691640"/>
-            <a:ext cx="2331720" cy="274320"/>
-          </a:xfrm>
-          <a:prstGeom prst="rect">
-            <a:avLst/>
-          </a:prstGeom>
-          <a:noFill/>
-          <a:ln/>
-        </p:spPr>
-        <p:txBody>
-          <a:bodyPr wrap="square" rtlCol="0" anchor="ctr"/>
-          <a:lstStyle/>
-          <a:p>
-            <a:pPr indent="0" marL="0">
-              <a:buNone/>
-            </a:pPr>
-            <a:r>
-              <a:rPr lang="en-US" sz="1000" dirty="0">
-                <a:solidFill>
-                  <a:srgbClr val="6B7280"/>
-                </a:solidFill>
-                <a:latin typeface="Inter" pitchFamily="34" charset="0"/>
-                <a:ea typeface="Inter" pitchFamily="34" charset="-122"/>
-                <a:cs typeface="Inter" pitchFamily="34" charset="-120"/>
-              </a:rPr>
-              <a:t>Owner: Thomas Berger</a:t>
-            </a:r>
-            <a:endParaRPr lang="en-US" sz="1000" dirty="0"/>
-          </a:p>
-        </p:txBody>
-      </p:sp>
-      <p:sp>
-        <p:nvSpPr>
-          <p:cNvPr id="33" name="Text 30"/>
-          <p:cNvSpPr/>
-          <p:nvPr/>
-        </p:nvSpPr>
-        <p:spPr>
-          <a:xfrm>
-            <a:off x="9281160" y="1965960"/>
-            <a:ext cx="2331720" cy="274320"/>
-          </a:xfrm>
-          <a:prstGeom prst="rect">
-            <a:avLst/>
-          </a:prstGeom>
-          <a:noFill/>
-          <a:ln/>
-        </p:spPr>
-        <p:txBody>
-          <a:bodyPr wrap="square" rtlCol="0" anchor="ctr"/>
-          <a:lstStyle/>
-          <a:p>
-            <a:pPr indent="0" marL="0">
-              <a:buNone/>
-            </a:pPr>
-            <a:r>
-              <a:rPr lang="en-US" sz="1000" dirty="0">
-                <a:solidFill>
-                  <a:srgbClr val="6B7280"/>
-                </a:solidFill>
-                <a:latin typeface="Inter" pitchFamily="34" charset="0"/>
-                <a:ea typeface="Inter" pitchFamily="34" charset="-122"/>
-                <a:cs typeface="Inter" pitchFamily="34" charset="-120"/>
-              </a:rPr>
-              <a:t>Refresh: 1 hour</a:t>
-            </a:r>
-            <a:endParaRPr lang="en-US" sz="1000" dirty="0"/>
-          </a:p>
-        </p:txBody>
-      </p:sp>
-      <p:sp>
-        <p:nvSpPr>
-          <p:cNvPr id="34" name="Text 31"/>
-          <p:cNvSpPr/>
-          <p:nvPr/>
-        </p:nvSpPr>
-        <p:spPr>
-          <a:xfrm>
-            <a:off x="9281160" y="2240280"/>
-            <a:ext cx="2331720" cy="274320"/>
-          </a:xfrm>
-          <a:prstGeom prst="rect">
-            <a:avLst/>
-          </a:prstGeom>
-          <a:noFill/>
-          <a:ln/>
-        </p:spPr>
-        <p:txBody>
-          <a:bodyPr wrap="square" rtlCol="0" anchor="ctr"/>
-          <a:lstStyle/>
-          <a:p>
-            <a:pPr indent="0" marL="0">
-              <a:buNone/>
-            </a:pPr>
-            <a:r>
-              <a:rPr lang="en-US" sz="1100" b="1" dirty="0">
-                <a:solidFill>
-                  <a:srgbClr val="009845"/>
-                </a:solidFill>
-                <a:latin typeface="Inter" pitchFamily="34" charset="0"/>
-                <a:ea typeface="Inter" pitchFamily="34" charset="-122"/>
-                <a:cs typeface="Inter" pitchFamily="34" charset="-120"/>
-              </a:rPr>
-              <a:t>KPI: 8,200 missing weights</a:t>
-            </a:r>
-            <a:endParaRPr lang="en-US" sz="1100" dirty="0"/>
-          </a:p>
-        </p:txBody>
-      </p:sp>
-      <p:sp>
-        <p:nvSpPr>
-          <p:cNvPr id="35" name="Text 32"/>
-          <p:cNvSpPr/>
-          <p:nvPr/>
-        </p:nvSpPr>
-        <p:spPr>
-          <a:xfrm>
-            <a:off x="9098280" y="2743200"/>
-            <a:ext cx="2697480" cy="274320"/>
-          </a:xfrm>
-          <a:prstGeom prst="rect">
-            <a:avLst/>
-          </a:prstGeom>
-          <a:noFill/>
-          <a:ln/>
-        </p:spPr>
-        <p:txBody>
-          <a:bodyPr wrap="square" rtlCol="0" anchor="ctr"/>
-          <a:lstStyle/>
-          <a:p>
-            <a:pPr algn="ctr" indent="0" marL="0">
-              <a:buNone/>
-            </a:pPr>
-            <a:r>
-              <a:rPr lang="en-US" sz="900" i="1" dirty="0">
-                <a:solidFill>
-                  <a:srgbClr val="A9B3B6"/>
-                </a:solidFill>
-                <a:latin typeface="Inter" pitchFamily="34" charset="0"/>
-                <a:ea typeface="Inter" pitchFamily="34" charset="-122"/>
-                <a:cs typeface="Inter" pitchFamily="34" charset="-120"/>
-              </a:rPr>
-              <a:t>Trust Score  •  API Sharing  •  Lineage</a:t>
-            </a:r>
-            <a:endParaRPr lang="en-US" sz="900" dirty="0"/>
-          </a:p>
-        </p:txBody>
-      </p:sp>
-      <p:sp>
-        <p:nvSpPr>
-          <p:cNvPr id="36" name="Shape 33"/>
-          <p:cNvSpPr/>
-          <p:nvPr/>
-        </p:nvSpPr>
-        <p:spPr>
-          <a:xfrm>
-            <a:off x="457200" y="3566160"/>
-            <a:ext cx="2697480" cy="2331720"/>
-          </a:xfrm>
-          <a:prstGeom prst="roundRect">
-            <a:avLst>
-              <a:gd name="adj" fmla="val 4706"/>
-            </a:avLst>
-          </a:prstGeom>
-          <a:solidFill>
-            <a:srgbClr val="FFFFFF"/>
-          </a:solidFill>
-          <a:ln w="19050">
-            <a:solidFill>
-              <a:srgbClr val="19416C"/>
-            </a:solidFill>
-            <a:prstDash val="solid"/>
-          </a:ln>
-          <a:effectLst>
-            <a:outerShdw sx="100000" sy="100000" kx="0" ky="0" algn="bl" rotWithShape="0" blurRad="50800" dist="19050" dir="16200000">
-              <a:srgbClr val="000000">
-                <a:alpha val="8000"/>
-              </a:srgbClr>
-            </a:outerShdw>
-          </a:effectLst>
-        </p:spPr>
-      </p:sp>
-      <p:sp>
-        <p:nvSpPr>
-          <p:cNvPr id="37" name="Shape 34"/>
-          <p:cNvSpPr/>
-          <p:nvPr/>
-        </p:nvSpPr>
-        <p:spPr>
-          <a:xfrm>
-            <a:off x="530352" y="3621024"/>
-            <a:ext cx="2551176" cy="54864"/>
-          </a:xfrm>
-          <a:prstGeom prst="rect">
-            <a:avLst/>
-          </a:prstGeom>
-          <a:solidFill>
-            <a:srgbClr val="19416C"/>
-          </a:solidFill>
-          <a:ln/>
-        </p:spPr>
-      </p:sp>
-      <p:sp>
-        <p:nvSpPr>
-          <p:cNvPr id="38" name="Text 35"/>
-          <p:cNvSpPr/>
-          <p:nvPr/>
-        </p:nvSpPr>
-        <p:spPr>
-          <a:xfrm>
-            <a:off x="457200" y="3749040"/>
-            <a:ext cx="2697480" cy="411480"/>
-          </a:xfrm>
-          <a:prstGeom prst="rect">
-            <a:avLst/>
-          </a:prstGeom>
-          <a:noFill/>
-          <a:ln/>
-        </p:spPr>
-        <p:txBody>
-          <a:bodyPr wrap="square" rtlCol="0" anchor="ctr"/>
-          <a:lstStyle/>
-          <a:p>
-            <a:pPr algn="ctr" indent="0" marL="0">
-              <a:buNone/>
-            </a:pPr>
-            <a:r>
-              <a:rPr lang="en-US" sz="1300" b="1" dirty="0">
-                <a:solidFill>
-                  <a:srgbClr val="19416C"/>
-                </a:solidFill>
-                <a:latin typeface="Inter" pitchFamily="34" charset="0"/>
-                <a:ea typeface="Inter" pitchFamily="34" charset="-122"/>
-                <a:cs typeface="Inter" pitchFamily="34" charset="-120"/>
-              </a:rPr>
-              <a:t>Customer Delivery Exp.</a:t>
-            </a:r>
-            <a:endParaRPr lang="en-US" sz="1300" dirty="0"/>
-          </a:p>
-        </p:txBody>
-      </p:sp>
-      <p:sp>
-        <p:nvSpPr>
-          <p:cNvPr id="39" name="Text 36"/>
-          <p:cNvSpPr/>
-          <p:nvPr/>
-        </p:nvSpPr>
-        <p:spPr>
-          <a:xfrm>
-            <a:off x="640080" y="4251960"/>
-            <a:ext cx="2331720" cy="274320"/>
-          </a:xfrm>
-          <a:prstGeom prst="rect">
-            <a:avLst/>
-          </a:prstGeom>
-          <a:noFill/>
-          <a:ln/>
-        </p:spPr>
-        <p:txBody>
-          <a:bodyPr wrap="square" rtlCol="0" anchor="ctr"/>
-          <a:lstStyle/>
-          <a:p>
-            <a:pPr indent="0" marL="0">
-              <a:buNone/>
-            </a:pPr>
-            <a:r>
-              <a:rPr lang="en-US" sz="1000" dirty="0">
-                <a:solidFill>
-                  <a:srgbClr val="6B7280"/>
-                </a:solidFill>
-                <a:latin typeface="Inter" pitchFamily="34" charset="0"/>
-                <a:ea typeface="Inter" pitchFamily="34" charset="-122"/>
-                <a:cs typeface="Inter" pitchFamily="34" charset="-120"/>
-              </a:rPr>
-              <a:t>Owner: Lisa Park</a:t>
-            </a:r>
-            <a:endParaRPr lang="en-US" sz="1000" dirty="0"/>
-          </a:p>
-        </p:txBody>
-      </p:sp>
-      <p:sp>
-        <p:nvSpPr>
-          <p:cNvPr id="40" name="Text 37"/>
-          <p:cNvSpPr/>
-          <p:nvPr/>
-        </p:nvSpPr>
-        <p:spPr>
-          <a:xfrm>
-            <a:off x="640080" y="4526280"/>
-            <a:ext cx="2331720" cy="274320"/>
-          </a:xfrm>
-          <a:prstGeom prst="rect">
-            <a:avLst/>
-          </a:prstGeom>
-          <a:noFill/>
-          <a:ln/>
-        </p:spPr>
-        <p:txBody>
-          <a:bodyPr wrap="square" rtlCol="0" anchor="ctr"/>
-          <a:lstStyle/>
-          <a:p>
-            <a:pPr indent="0" marL="0">
-              <a:buNone/>
-            </a:pPr>
-            <a:r>
-              <a:rPr lang="en-US" sz="1000" dirty="0">
-                <a:solidFill>
-                  <a:srgbClr val="6B7280"/>
-                </a:solidFill>
-                <a:latin typeface="Inter" pitchFamily="34" charset="0"/>
-                <a:ea typeface="Inter" pitchFamily="34" charset="-122"/>
-                <a:cs typeface="Inter" pitchFamily="34" charset="-120"/>
-              </a:rPr>
-              <a:t>Refresh: 1 hour</a:t>
-            </a:r>
-            <a:endParaRPr lang="en-US" sz="1000" dirty="0"/>
-          </a:p>
-        </p:txBody>
-      </p:sp>
-      <p:sp>
-        <p:nvSpPr>
-          <p:cNvPr id="41" name="Text 38"/>
-          <p:cNvSpPr/>
-          <p:nvPr/>
-        </p:nvSpPr>
-        <p:spPr>
-          <a:xfrm>
-            <a:off x="640080" y="4800600"/>
-            <a:ext cx="2331720" cy="274320"/>
-          </a:xfrm>
-          <a:prstGeom prst="rect">
-            <a:avLst/>
-          </a:prstGeom>
-          <a:noFill/>
-          <a:ln/>
-        </p:spPr>
-        <p:txBody>
-          <a:bodyPr wrap="square" rtlCol="0" anchor="ctr"/>
-          <a:lstStyle/>
-          <a:p>
-            <a:pPr indent="0" marL="0">
-              <a:buNone/>
-            </a:pPr>
-            <a:r>
-              <a:rPr lang="en-US" sz="1100" b="1" dirty="0">
-                <a:solidFill>
-                  <a:srgbClr val="19416C"/>
-                </a:solidFill>
-                <a:latin typeface="Inter" pitchFamily="34" charset="0"/>
-                <a:ea typeface="Inter" pitchFamily="34" charset="-122"/>
-                <a:cs typeface="Inter" pitchFamily="34" charset="-120"/>
-              </a:rPr>
-              <a:t>KPI: WISMO: 41%</a:t>
-            </a:r>
-            <a:endParaRPr lang="en-US" sz="1100" dirty="0"/>
-          </a:p>
-        </p:txBody>
-      </p:sp>
-      <p:sp>
-        <p:nvSpPr>
-          <p:cNvPr id="42" name="Text 39"/>
-          <p:cNvSpPr/>
-          <p:nvPr/>
-        </p:nvSpPr>
-        <p:spPr>
-          <a:xfrm>
-            <a:off x="457200" y="5303520"/>
-            <a:ext cx="2697480" cy="274320"/>
-          </a:xfrm>
-          <a:prstGeom prst="rect">
-            <a:avLst/>
-          </a:prstGeom>
-          <a:noFill/>
-          <a:ln/>
-        </p:spPr>
-        <p:txBody>
-          <a:bodyPr wrap="square" rtlCol="0" anchor="ctr"/>
-          <a:lstStyle/>
-          <a:p>
-            <a:pPr algn="ctr" indent="0" marL="0">
-              <a:buNone/>
-            </a:pPr>
-            <a:r>
-              <a:rPr lang="en-US" sz="900" i="1" dirty="0">
-                <a:solidFill>
-                  <a:srgbClr val="A9B3B6"/>
-                </a:solidFill>
-                <a:latin typeface="Inter" pitchFamily="34" charset="0"/>
-                <a:ea typeface="Inter" pitchFamily="34" charset="-122"/>
-                <a:cs typeface="Inter" pitchFamily="34" charset="-120"/>
-              </a:rPr>
-              <a:t>Trust Score  •  API Sharing  •  Lineage</a:t>
-            </a:r>
-            <a:endParaRPr lang="en-US" sz="900" dirty="0"/>
-          </a:p>
-        </p:txBody>
-      </p:sp>
-      <p:sp>
-        <p:nvSpPr>
-          <p:cNvPr id="43" name="Shape 40"/>
-          <p:cNvSpPr/>
-          <p:nvPr/>
-        </p:nvSpPr>
-        <p:spPr>
-          <a:xfrm>
-            <a:off x="3337560" y="3566160"/>
-            <a:ext cx="2697480" cy="2331720"/>
-          </a:xfrm>
-          <a:prstGeom prst="roundRect">
-            <a:avLst>
-              <a:gd name="adj" fmla="val 4706"/>
-            </a:avLst>
-          </a:prstGeom>
-          <a:solidFill>
-            <a:srgbClr val="FFFFFF"/>
-          </a:solidFill>
-          <a:ln w="19050">
-            <a:solidFill>
-              <a:srgbClr val="19416C"/>
-            </a:solidFill>
-            <a:prstDash val="solid"/>
-          </a:ln>
-          <a:effectLst>
-            <a:outerShdw sx="100000" sy="100000" kx="0" ky="0" algn="bl" rotWithShape="0" blurRad="50800" dist="19050" dir="16200000">
-              <a:srgbClr val="000000">
-                <a:alpha val="8000"/>
-              </a:srgbClr>
-            </a:outerShdw>
-          </a:effectLst>
-        </p:spPr>
-      </p:sp>
-      <p:sp>
-        <p:nvSpPr>
-          <p:cNvPr id="44" name="Shape 41"/>
-          <p:cNvSpPr/>
-          <p:nvPr/>
-        </p:nvSpPr>
-        <p:spPr>
-          <a:xfrm>
-            <a:off x="3410712" y="3621024"/>
-            <a:ext cx="2551176" cy="54864"/>
-          </a:xfrm>
-          <a:prstGeom prst="rect">
-            <a:avLst/>
-          </a:prstGeom>
-          <a:solidFill>
-            <a:srgbClr val="19416C"/>
-          </a:solidFill>
-          <a:ln/>
-        </p:spPr>
-      </p:sp>
-      <p:sp>
-        <p:nvSpPr>
-          <p:cNvPr id="45" name="Text 42"/>
-          <p:cNvSpPr/>
-          <p:nvPr/>
-        </p:nvSpPr>
-        <p:spPr>
-          <a:xfrm>
-            <a:off x="3337560" y="3749040"/>
-            <a:ext cx="2697480" cy="411480"/>
-          </a:xfrm>
-          <a:prstGeom prst="rect">
-            <a:avLst/>
-          </a:prstGeom>
-          <a:noFill/>
-          <a:ln/>
-        </p:spPr>
-        <p:txBody>
-          <a:bodyPr wrap="square" rtlCol="0" anchor="ctr"/>
-          <a:lstStyle/>
-          <a:p>
-            <a:pPr algn="ctr" indent="0" marL="0">
-              <a:buNone/>
-            </a:pPr>
-            <a:r>
-              <a:rPr lang="en-US" sz="1300" b="1" dirty="0">
-                <a:solidFill>
-                  <a:srgbClr val="19416C"/>
-                </a:solidFill>
-                <a:latin typeface="Inter" pitchFamily="34" charset="0"/>
-                <a:ea typeface="Inter" pitchFamily="34" charset="-122"/>
-                <a:cs typeface="Inter" pitchFamily="34" charset="-120"/>
-              </a:rPr>
-              <a:t>Compliance Readiness</a:t>
-            </a:r>
-            <a:endParaRPr lang="en-US" sz="1300" dirty="0"/>
-          </a:p>
-        </p:txBody>
-      </p:sp>
-      <p:sp>
-        <p:nvSpPr>
-          <p:cNvPr id="46" name="Text 43"/>
-          <p:cNvSpPr/>
-          <p:nvPr/>
-        </p:nvSpPr>
-        <p:spPr>
-          <a:xfrm>
-            <a:off x="3520440" y="4251960"/>
-            <a:ext cx="2331720" cy="274320"/>
-          </a:xfrm>
-          <a:prstGeom prst="rect">
-            <a:avLst/>
-          </a:prstGeom>
-          <a:noFill/>
-          <a:ln/>
-        </p:spPr>
-        <p:txBody>
-          <a:bodyPr wrap="square" rtlCol="0" anchor="ctr"/>
-          <a:lstStyle/>
-          <a:p>
-            <a:pPr indent="0" marL="0">
-              <a:buNone/>
-            </a:pPr>
-            <a:r>
-              <a:rPr lang="en-US" sz="1000" dirty="0">
-                <a:solidFill>
-                  <a:srgbClr val="6B7280"/>
-                </a:solidFill>
-                <a:latin typeface="Inter" pitchFamily="34" charset="0"/>
-                <a:ea typeface="Inter" pitchFamily="34" charset="-122"/>
-                <a:cs typeface="Inter" pitchFamily="34" charset="-120"/>
-              </a:rPr>
-              <a:t>Owner: Dr. Elena Vasquez</a:t>
-            </a:r>
-            <a:endParaRPr lang="en-US" sz="1000" dirty="0"/>
-          </a:p>
-        </p:txBody>
-      </p:sp>
-      <p:sp>
-        <p:nvSpPr>
-          <p:cNvPr id="47" name="Text 44"/>
-          <p:cNvSpPr/>
-          <p:nvPr/>
-        </p:nvSpPr>
-        <p:spPr>
-          <a:xfrm>
-            <a:off x="3520440" y="4526280"/>
-            <a:ext cx="2331720" cy="274320"/>
-          </a:xfrm>
-          <a:prstGeom prst="rect">
-            <a:avLst/>
-          </a:prstGeom>
-          <a:noFill/>
-          <a:ln/>
-        </p:spPr>
-        <p:txBody>
-          <a:bodyPr wrap="square" rtlCol="0" anchor="ctr"/>
-          <a:lstStyle/>
-          <a:p>
-            <a:pPr indent="0" marL="0">
-              <a:buNone/>
-            </a:pPr>
-            <a:r>
-              <a:rPr lang="en-US" sz="1000" dirty="0">
-                <a:solidFill>
-                  <a:srgbClr val="6B7280"/>
-                </a:solidFill>
-                <a:latin typeface="Inter" pitchFamily="34" charset="0"/>
-                <a:ea typeface="Inter" pitchFamily="34" charset="-122"/>
-                <a:cs typeface="Inter" pitchFamily="34" charset="-120"/>
-              </a:rPr>
-              <a:t>Refresh: Daily</a:t>
-            </a:r>
-            <a:endParaRPr lang="en-US" sz="1000" dirty="0"/>
-          </a:p>
-        </p:txBody>
-      </p:sp>
-      <p:sp>
-        <p:nvSpPr>
-          <p:cNvPr id="48" name="Text 45"/>
-          <p:cNvSpPr/>
-          <p:nvPr/>
-        </p:nvSpPr>
-        <p:spPr>
-          <a:xfrm>
-            <a:off x="3520440" y="4800600"/>
-            <a:ext cx="2331720" cy="274320"/>
-          </a:xfrm>
-          <a:prstGeom prst="rect">
-            <a:avLst/>
-          </a:prstGeom>
-          <a:noFill/>
-          <a:ln/>
-        </p:spPr>
-        <p:txBody>
-          <a:bodyPr wrap="square" rtlCol="0" anchor="ctr"/>
-          <a:lstStyle/>
-          <a:p>
-            <a:pPr indent="0" marL="0">
-              <a:buNone/>
-            </a:pPr>
-            <a:r>
-              <a:rPr lang="en-US" sz="1100" b="1" dirty="0">
-                <a:solidFill>
-                  <a:srgbClr val="19416C"/>
-                </a:solidFill>
-                <a:latin typeface="Inter" pitchFamily="34" charset="0"/>
-                <a:ea typeface="Inter" pitchFamily="34" charset="-122"/>
-                <a:cs typeface="Inter" pitchFamily="34" charset="-120"/>
-              </a:rPr>
-              <a:t>KPI: Lot capture: 85%</a:t>
-            </a:r>
-            <a:endParaRPr lang="en-US" sz="1100" dirty="0"/>
-          </a:p>
-        </p:txBody>
-      </p:sp>
-      <p:sp>
-        <p:nvSpPr>
-          <p:cNvPr id="49" name="Text 46"/>
-          <p:cNvSpPr/>
-          <p:nvPr/>
-        </p:nvSpPr>
-        <p:spPr>
-          <a:xfrm>
-            <a:off x="3337560" y="5303520"/>
-            <a:ext cx="2697480" cy="274320"/>
-          </a:xfrm>
-          <a:prstGeom prst="rect">
-            <a:avLst/>
-          </a:prstGeom>
-          <a:noFill/>
-          <a:ln/>
-        </p:spPr>
-        <p:txBody>
-          <a:bodyPr wrap="square" rtlCol="0" anchor="ctr"/>
-          <a:lstStyle/>
-          <a:p>
-            <a:pPr algn="ctr" indent="0" marL="0">
-              <a:buNone/>
-            </a:pPr>
-            <a:r>
-              <a:rPr lang="en-US" sz="900" i="1" dirty="0">
-                <a:solidFill>
-                  <a:srgbClr val="A9B3B6"/>
-                </a:solidFill>
-                <a:latin typeface="Inter" pitchFamily="34" charset="0"/>
-                <a:ea typeface="Inter" pitchFamily="34" charset="-122"/>
-                <a:cs typeface="Inter" pitchFamily="34" charset="-120"/>
-              </a:rPr>
-              <a:t>Trust Score  •  API Sharing  •  Lineage</a:t>
-            </a:r>
-            <a:endParaRPr lang="en-US" sz="900" dirty="0"/>
-          </a:p>
-        </p:txBody>
-      </p:sp>
-      <p:sp>
-        <p:nvSpPr>
-          <p:cNvPr id="50" name="Shape 47"/>
-          <p:cNvSpPr/>
-          <p:nvPr/>
-        </p:nvSpPr>
-        <p:spPr>
-          <a:xfrm>
-            <a:off x="6217920" y="3566160"/>
-            <a:ext cx="2697480" cy="2331720"/>
-          </a:xfrm>
-          <a:prstGeom prst="roundRect">
-            <a:avLst>
-              <a:gd name="adj" fmla="val 4706"/>
-            </a:avLst>
-          </a:prstGeom>
-          <a:solidFill>
-            <a:srgbClr val="FFFFFF"/>
-          </a:solidFill>
-          <a:ln w="19050">
-            <a:solidFill>
-              <a:srgbClr val="006580"/>
-            </a:solidFill>
-            <a:prstDash val="solid"/>
-          </a:ln>
-          <a:effectLst>
-            <a:outerShdw sx="100000" sy="100000" kx="0" ky="0" algn="bl" rotWithShape="0" blurRad="50800" dist="19050" dir="16200000">
-              <a:srgbClr val="000000">
-                <a:alpha val="8000"/>
-              </a:srgbClr>
-            </a:outerShdw>
-          </a:effectLst>
-        </p:spPr>
-      </p:sp>
-      <p:sp>
-        <p:nvSpPr>
-          <p:cNvPr id="51" name="Shape 48"/>
-          <p:cNvSpPr/>
-          <p:nvPr/>
-        </p:nvSpPr>
-        <p:spPr>
-          <a:xfrm>
-            <a:off x="6291072" y="3621024"/>
-            <a:ext cx="2551176" cy="54864"/>
-          </a:xfrm>
-          <a:prstGeom prst="rect">
-            <a:avLst/>
-          </a:prstGeom>
-          <a:solidFill>
-            <a:srgbClr val="006580"/>
-          </a:solidFill>
-          <a:ln/>
-        </p:spPr>
-      </p:sp>
-      <p:sp>
-        <p:nvSpPr>
-          <p:cNvPr id="52" name="Text 49"/>
-          <p:cNvSpPr/>
-          <p:nvPr/>
-        </p:nvSpPr>
-        <p:spPr>
-          <a:xfrm>
-            <a:off x="6217920" y="3749040"/>
-            <a:ext cx="2697480" cy="411480"/>
-          </a:xfrm>
-          <a:prstGeom prst="rect">
-            <a:avLst/>
-          </a:prstGeom>
-          <a:noFill/>
-          <a:ln/>
-        </p:spPr>
-        <p:txBody>
-          <a:bodyPr wrap="square" rtlCol="0" anchor="ctr"/>
-          <a:lstStyle/>
-          <a:p>
-            <a:pPr algn="ctr" indent="0" marL="0">
-              <a:buNone/>
-            </a:pPr>
-            <a:r>
-              <a:rPr lang="en-US" sz="1300" b="1" dirty="0">
-                <a:solidFill>
-                  <a:srgbClr val="19416C"/>
-                </a:solidFill>
-                <a:latin typeface="Inter" pitchFamily="34" charset="0"/>
-                <a:ea typeface="Inter" pitchFamily="34" charset="-122"/>
-                <a:cs typeface="Inter" pitchFamily="34" charset="-120"/>
-              </a:rPr>
-              <a:t>Operational Cost Impact</a:t>
-            </a:r>
-            <a:endParaRPr lang="en-US" sz="1300" dirty="0"/>
-          </a:p>
-        </p:txBody>
-      </p:sp>
-      <p:sp>
-        <p:nvSpPr>
-          <p:cNvPr id="53" name="Text 50"/>
-          <p:cNvSpPr/>
-          <p:nvPr/>
-        </p:nvSpPr>
-        <p:spPr>
-          <a:xfrm>
-            <a:off x="6400800" y="4251960"/>
-            <a:ext cx="2331720" cy="274320"/>
-          </a:xfrm>
-          <a:prstGeom prst="rect">
-            <a:avLst/>
-          </a:prstGeom>
-          <a:noFill/>
-          <a:ln/>
-        </p:spPr>
-        <p:txBody>
-          <a:bodyPr wrap="square" rtlCol="0" anchor="ctr"/>
-          <a:lstStyle/>
-          <a:p>
-            <a:pPr indent="0" marL="0">
-              <a:buNone/>
-            </a:pPr>
-            <a:r>
-              <a:rPr lang="en-US" sz="1000" dirty="0">
-                <a:solidFill>
-                  <a:srgbClr val="6B7280"/>
-                </a:solidFill>
-                <a:latin typeface="Inter" pitchFamily="34" charset="0"/>
-                <a:ea typeface="Inter" pitchFamily="34" charset="-122"/>
-                <a:cs typeface="Inter" pitchFamily="34" charset="-120"/>
-              </a:rPr>
-              <a:t>Owner: CFO Office</a:t>
-            </a:r>
-            <a:endParaRPr lang="en-US" sz="1000" dirty="0"/>
-          </a:p>
-        </p:txBody>
-      </p:sp>
-      <p:sp>
-        <p:nvSpPr>
-          <p:cNvPr id="54" name="Text 51"/>
-          <p:cNvSpPr/>
-          <p:nvPr/>
-        </p:nvSpPr>
-        <p:spPr>
-          <a:xfrm>
-            <a:off x="6400800" y="4526280"/>
-            <a:ext cx="2331720" cy="274320"/>
-          </a:xfrm>
-          <a:prstGeom prst="rect">
-            <a:avLst/>
-          </a:prstGeom>
-          <a:noFill/>
-          <a:ln/>
-        </p:spPr>
-        <p:txBody>
-          <a:bodyPr wrap="square" rtlCol="0" anchor="ctr"/>
-          <a:lstStyle/>
-          <a:p>
-            <a:pPr indent="0" marL="0">
-              <a:buNone/>
-            </a:pPr>
-            <a:r>
-              <a:rPr lang="en-US" sz="1000" dirty="0">
-                <a:solidFill>
-                  <a:srgbClr val="6B7280"/>
-                </a:solidFill>
-                <a:latin typeface="Inter" pitchFamily="34" charset="0"/>
-                <a:ea typeface="Inter" pitchFamily="34" charset="-122"/>
-                <a:cs typeface="Inter" pitchFamily="34" charset="-120"/>
-              </a:rPr>
-              <a:t>Refresh: Daily</a:t>
-            </a:r>
-            <a:endParaRPr lang="en-US" sz="1000" dirty="0"/>
-          </a:p>
-        </p:txBody>
-      </p:sp>
-      <p:sp>
-        <p:nvSpPr>
-          <p:cNvPr id="55" name="Text 52"/>
-          <p:cNvSpPr/>
-          <p:nvPr/>
-        </p:nvSpPr>
-        <p:spPr>
-          <a:xfrm>
-            <a:off x="6400800" y="4800600"/>
-            <a:ext cx="2331720" cy="274320"/>
-          </a:xfrm>
-          <a:prstGeom prst="rect">
-            <a:avLst/>
-          </a:prstGeom>
-          <a:noFill/>
-          <a:ln/>
-        </p:spPr>
-        <p:txBody>
-          <a:bodyPr wrap="square" rtlCol="0" anchor="ctr"/>
-          <a:lstStyle/>
-          <a:p>
-            <a:pPr indent="0" marL="0">
-              <a:buNone/>
-            </a:pPr>
-            <a:r>
-              <a:rPr lang="en-US" sz="1100" b="1" dirty="0">
-                <a:solidFill>
-                  <a:srgbClr val="006580"/>
-                </a:solidFill>
-                <a:latin typeface="Inter" pitchFamily="34" charset="0"/>
-                <a:ea typeface="Inter" pitchFamily="34" charset="-122"/>
-                <a:cs typeface="Inter" pitchFamily="34" charset="-120"/>
-              </a:rPr>
-              <a:t>KPI: $127M annual</a:t>
-            </a:r>
-            <a:endParaRPr lang="en-US" sz="1100" dirty="0"/>
-          </a:p>
-        </p:txBody>
-      </p:sp>
-      <p:sp>
-        <p:nvSpPr>
-          <p:cNvPr id="56" name="Text 53"/>
-          <p:cNvSpPr/>
-          <p:nvPr/>
-        </p:nvSpPr>
-        <p:spPr>
-          <a:xfrm>
-            <a:off x="6217920" y="5303520"/>
             <a:ext cx="2697480" cy="274320"/>
           </a:xfrm>
           <a:prstGeom prst="rect">
@@ -16504,7 +14929,7 @@
       </p:grpSpPr>
       <p:pic>
         <p:nvPicPr>
-          <p:cNvPr id="2" name="Image 0" descr="C:\Claude\End-To-End Demo\generators\assets\qlik_divider_bg.png">    </p:cNvPr>
+          <p:cNvPr id="2" name="Image 0" descr="C:\Claude\MCG Full Stack\generators\assets\qlik_divider_bg.png">    </p:cNvPr>
           <p:cNvPicPr>
             <a:picLocks noChangeAspect="1"/>
           </p:cNvPicPr>
@@ -16695,7 +15120,7 @@
       </p:sp>
       <p:pic>
         <p:nvPicPr>
-          <p:cNvPr id="4" name="Image 0" descr="C:\Claude\End-To-End Demo\generators\assets\qlik_logo.png">    </p:cNvPr>
+          <p:cNvPr id="4" name="Image 0" descr="C:\Claude\MCG Full Stack\generators\assets\qlik_logo.png">    </p:cNvPr>
           <p:cNvPicPr>
             <a:picLocks noChangeAspect="1"/>
           </p:cNvPicPr>
@@ -18304,7 +16729,7 @@
       </p:grpSpPr>
       <p:pic>
         <p:nvPicPr>
-          <p:cNvPr id="2" name="Image 0" descr="C:\Claude\End-To-End Demo\generators\assets\qlik_divider_bg.png">    </p:cNvPr>
+          <p:cNvPr id="2" name="Image 0" descr="C:\Claude\MCG Full Stack\generators\assets\qlik_divider_bg.png">    </p:cNvPr>
           <p:cNvPicPr>
             <a:picLocks noChangeAspect="1"/>
           </p:cNvPicPr>

</xml_diff>

<commit_message>
Add Qlik line-art icons to architecture diagram slides
Bring the qlik-marketecture skill's visual language into the architecture
diagrams of both decks: charcoal + Qlik-green line-art clip-art icons on
white chips, with consistent icon-card styling.

- New icon system: 14 line-art SVGs (12 curated from the marketecture skill +
  custom lakehouse/automation) rasterized to square transparent PNGs by
  generators/lib/render-icons.js; wired in as Phase 0 of generate-all.js.
- Technology Architecture deck: icon cards on the End-to-End Overview, Gateway,
  and Analytics & AI slides (iconCard / iconCardTop / iconBadge helpers).
- Demo Overview deck: icon-left component cards on Technical Architecture and
  icon header badges on Functional Architecture.

Verified each changed slide via PowerPoint render; regenerated both decks.

Co-Authored-By: Claude Opus 4.8 <noreply@anthropic.com>
</commit_message>
<xml_diff>
--- a/MCG_Technology_Architecture.pptx
+++ b/MCG_Technology_Architecture.pptx
@@ -7031,14 +7031,70 @@
       </p:sp>
       <p:sp>
         <p:nvSpPr>
-          <p:cNvPr id="17" name="Text 14"/>
-          <p:cNvSpPr/>
-          <p:nvPr/>
-        </p:nvSpPr>
-        <p:spPr>
-          <a:xfrm>
-            <a:off x="2039112" y="1060704"/>
-            <a:ext cx="2688336" cy="457200"/>
+          <p:cNvPr id="17" name="Shape 14"/>
+          <p:cNvSpPr/>
+          <p:nvPr/>
+        </p:nvSpPr>
+        <p:spPr>
+          <a:xfrm>
+            <a:off x="2084832" y="1179576"/>
+            <a:ext cx="566928" cy="566928"/>
+          </a:xfrm>
+          <a:prstGeom prst="ellipse">
+            <a:avLst/>
+          </a:prstGeom>
+          <a:solidFill>
+            <a:srgbClr val="FFFFFF"/>
+          </a:solidFill>
+          <a:ln w="12700">
+            <a:solidFill>
+              <a:srgbClr val="FFFFFF"/>
+            </a:solidFill>
+            <a:prstDash val="solid"/>
+          </a:ln>
+          <a:effectLst>
+            <a:outerShdw sx="100000" sy="100000" kx="0" ky="0" algn="bl" rotWithShape="0" blurRad="38100" dist="12700" dir="16200000">
+              <a:srgbClr val="000000">
+                <a:alpha val="15000"/>
+              </a:srgbClr>
+            </a:outerShdw>
+          </a:effectLst>
+        </p:spPr>
+      </p:sp>
+      <p:pic>
+        <p:nvPicPr>
+          <p:cNvPr id="18" name="Image 1" descr="C:\Claude\MCG Full Stack\generators\assets\icons\database.png">    </p:cNvPr>
+          <p:cNvPicPr>
+            <a:picLocks noChangeAspect="1"/>
+          </p:cNvPicPr>
+          <p:nvPr/>
+        </p:nvPicPr>
+        <p:blipFill>
+          <a:blip r:embed="rId2"/>
+          <a:stretch>
+            <a:fillRect/>
+          </a:stretch>
+        </p:blipFill>
+        <p:spPr>
+          <a:xfrm>
+            <a:off x="2192548" y="1287292"/>
+            <a:ext cx="351495" cy="351495"/>
+          </a:xfrm>
+          <a:prstGeom prst="rect">
+            <a:avLst/>
+          </a:prstGeom>
+        </p:spPr>
+      </p:pic>
+      <p:sp>
+        <p:nvSpPr>
+          <p:cNvPr id="19" name="Text 15"/>
+          <p:cNvSpPr/>
+          <p:nvPr/>
+        </p:nvSpPr>
+        <p:spPr>
+          <a:xfrm>
+            <a:off x="2779776" y="1078992"/>
+            <a:ext cx="1929384" cy="438912"/>
           </a:xfrm>
           <a:prstGeom prst="rect">
             <a:avLst/>
@@ -7050,7 +7106,7 @@
           <a:bodyPr wrap="square" rtlCol="0" anchor="b"/>
           <a:lstStyle/>
           <a:p>
-            <a:pPr algn="ctr" indent="0" marL="0">
+            <a:pPr algn="l" indent="0" marL="0">
               <a:buNone/>
             </a:pPr>
             <a:r>
@@ -7070,14 +7126,14 @@
       </p:sp>
       <p:sp>
         <p:nvSpPr>
-          <p:cNvPr id="18" name="Text 15"/>
-          <p:cNvSpPr/>
-          <p:nvPr/>
-        </p:nvSpPr>
-        <p:spPr>
-          <a:xfrm>
-            <a:off x="2039112" y="1481328"/>
-            <a:ext cx="2688336" cy="384048"/>
+          <p:cNvPr id="20" name="Text 16"/>
+          <p:cNvSpPr/>
+          <p:nvPr/>
+        </p:nvSpPr>
+        <p:spPr>
+          <a:xfrm>
+            <a:off x="2779776" y="1463040"/>
+            <a:ext cx="1929384" cy="402336"/>
           </a:xfrm>
           <a:prstGeom prst="rect">
             <a:avLst/>
@@ -7089,16 +7145,16 @@
           <a:bodyPr wrap="square" rtlCol="0" anchor="t"/>
           <a:lstStyle/>
           <a:p>
-            <a:pPr algn="ctr" indent="0" marL="0">
+            <a:pPr algn="l" indent="0" marL="0">
               <a:lnSpc>
-                <a:spcPct val="105000"/>
+                <a:spcPct val="102000"/>
               </a:lnSpc>
               <a:buNone/>
             </a:pPr>
             <a:r>
-              <a:rPr lang="en-US" sz="1000" dirty="0">
-                <a:solidFill>
-                  <a:srgbClr val="D0D4D7"/>
+              <a:rPr lang="en-US" sz="950" dirty="0">
+                <a:solidFill>
+                  <a:srgbClr val="D8DCE0"/>
                 </a:solidFill>
                 <a:latin typeface="Inter" pitchFamily="34" charset="0"/>
                 <a:ea typeface="Inter" pitchFamily="34" charset="-122"/>
@@ -7106,13 +7162,13 @@
               </a:rPr>
               <a:t>CDC • 3 tables • Real-time</a:t>
             </a:r>
-            <a:endParaRPr lang="en-US" sz="1000" dirty="0"/>
-          </a:p>
-        </p:txBody>
-      </p:sp>
-      <p:sp>
-        <p:nvSpPr>
-          <p:cNvPr id="19" name="Shape 16"/>
+            <a:endParaRPr lang="en-US" sz="950" dirty="0"/>
+          </a:p>
+        </p:txBody>
+      </p:sp>
+      <p:sp>
+        <p:nvSpPr>
+          <p:cNvPr id="21" name="Shape 17"/>
           <p:cNvSpPr/>
           <p:nvPr/>
         </p:nvSpPr>
@@ -7146,14 +7202,70 @@
       </p:sp>
       <p:sp>
         <p:nvSpPr>
-          <p:cNvPr id="20" name="Text 17"/>
-          <p:cNvSpPr/>
-          <p:nvPr/>
-        </p:nvSpPr>
-        <p:spPr>
-          <a:xfrm>
-            <a:off x="5056632" y="1060704"/>
-            <a:ext cx="2688336" cy="457200"/>
+          <p:cNvPr id="22" name="Shape 18"/>
+          <p:cNvSpPr/>
+          <p:nvPr/>
+        </p:nvSpPr>
+        <p:spPr>
+          <a:xfrm>
+            <a:off x="5102352" y="1179576"/>
+            <a:ext cx="566928" cy="566928"/>
+          </a:xfrm>
+          <a:prstGeom prst="ellipse">
+            <a:avLst/>
+          </a:prstGeom>
+          <a:solidFill>
+            <a:srgbClr val="FFFFFF"/>
+          </a:solidFill>
+          <a:ln w="12700">
+            <a:solidFill>
+              <a:srgbClr val="FFFFFF"/>
+            </a:solidFill>
+            <a:prstDash val="solid"/>
+          </a:ln>
+          <a:effectLst>
+            <a:outerShdw sx="100000" sy="100000" kx="0" ky="0" algn="bl" rotWithShape="0" blurRad="38100" dist="12700" dir="16200000">
+              <a:srgbClr val="000000">
+                <a:alpha val="15000"/>
+              </a:srgbClr>
+            </a:outerShdw>
+          </a:effectLst>
+        </p:spPr>
+      </p:sp>
+      <p:pic>
+        <p:nvPicPr>
+          <p:cNvPr id="23" name="Image 2" descr="C:\Claude\MCG Full Stack\generators\assets\icons\stream.png">    </p:cNvPr>
+          <p:cNvPicPr>
+            <a:picLocks noChangeAspect="1"/>
+          </p:cNvPicPr>
+          <p:nvPr/>
+        </p:nvPicPr>
+        <p:blipFill>
+          <a:blip r:embed="rId3"/>
+          <a:stretch>
+            <a:fillRect/>
+          </a:stretch>
+        </p:blipFill>
+        <p:spPr>
+          <a:xfrm>
+            <a:off x="5210068" y="1287292"/>
+            <a:ext cx="351495" cy="351495"/>
+          </a:xfrm>
+          <a:prstGeom prst="rect">
+            <a:avLst/>
+          </a:prstGeom>
+        </p:spPr>
+      </p:pic>
+      <p:sp>
+        <p:nvSpPr>
+          <p:cNvPr id="24" name="Text 19"/>
+          <p:cNvSpPr/>
+          <p:nvPr/>
+        </p:nvSpPr>
+        <p:spPr>
+          <a:xfrm>
+            <a:off x="5797296" y="1078992"/>
+            <a:ext cx="1929384" cy="438912"/>
           </a:xfrm>
           <a:prstGeom prst="rect">
             <a:avLst/>
@@ -7165,7 +7277,7 @@
           <a:bodyPr wrap="square" rtlCol="0" anchor="b"/>
           <a:lstStyle/>
           <a:p>
-            <a:pPr algn="ctr" indent="0" marL="0">
+            <a:pPr algn="l" indent="0" marL="0">
               <a:buNone/>
             </a:pPr>
             <a:r>
@@ -7185,14 +7297,14 @@
       </p:sp>
       <p:sp>
         <p:nvSpPr>
-          <p:cNvPr id="21" name="Text 18"/>
-          <p:cNvSpPr/>
-          <p:nvPr/>
-        </p:nvSpPr>
-        <p:spPr>
-          <a:xfrm>
-            <a:off x="5056632" y="1481328"/>
-            <a:ext cx="2688336" cy="384048"/>
+          <p:cNvPr id="25" name="Text 20"/>
+          <p:cNvSpPr/>
+          <p:nvPr/>
+        </p:nvSpPr>
+        <p:spPr>
+          <a:xfrm>
+            <a:off x="5797296" y="1463040"/>
+            <a:ext cx="1929384" cy="402336"/>
           </a:xfrm>
           <a:prstGeom prst="rect">
             <a:avLst/>
@@ -7204,16 +7316,16 @@
           <a:bodyPr wrap="square" rtlCol="0" anchor="t"/>
           <a:lstStyle/>
           <a:p>
-            <a:pPr algn="ctr" indent="0" marL="0">
+            <a:pPr algn="l" indent="0" marL="0">
               <a:lnSpc>
-                <a:spcPct val="105000"/>
+                <a:spcPct val="102000"/>
               </a:lnSpc>
               <a:buNone/>
             </a:pPr>
             <a:r>
-              <a:rPr lang="en-US" sz="1000" dirty="0">
-                <a:solidFill>
-                  <a:srgbClr val="D0D4D7"/>
+              <a:rPr lang="en-US" sz="950" dirty="0">
+                <a:solidFill>
+                  <a:srgbClr val="D8DCE0"/>
                 </a:solidFill>
                 <a:latin typeface="Inter" pitchFamily="34" charset="0"/>
                 <a:ea typeface="Inter" pitchFamily="34" charset="-122"/>
@@ -7221,13 +7333,13 @@
               </a:rPr>
               <a:t>Streaming • 2 IoT topics</a:t>
             </a:r>
-            <a:endParaRPr lang="en-US" sz="1000" dirty="0"/>
-          </a:p>
-        </p:txBody>
-      </p:sp>
-      <p:sp>
-        <p:nvSpPr>
-          <p:cNvPr id="22" name="Shape 19"/>
+            <a:endParaRPr lang="en-US" sz="950" dirty="0"/>
+          </a:p>
+        </p:txBody>
+      </p:sp>
+      <p:sp>
+        <p:nvSpPr>
+          <p:cNvPr id="26" name="Shape 21"/>
           <p:cNvSpPr/>
           <p:nvPr/>
         </p:nvSpPr>
@@ -7261,14 +7373,70 @@
       </p:sp>
       <p:sp>
         <p:nvSpPr>
-          <p:cNvPr id="23" name="Text 20"/>
-          <p:cNvSpPr/>
-          <p:nvPr/>
-        </p:nvSpPr>
-        <p:spPr>
-          <a:xfrm>
-            <a:off x="8074152" y="1060704"/>
-            <a:ext cx="2688336" cy="457200"/>
+          <p:cNvPr id="27" name="Shape 22"/>
+          <p:cNvSpPr/>
+          <p:nvPr/>
+        </p:nvSpPr>
+        <p:spPr>
+          <a:xfrm>
+            <a:off x="8119872" y="1179576"/>
+            <a:ext cx="566928" cy="566928"/>
+          </a:xfrm>
+          <a:prstGeom prst="ellipse">
+            <a:avLst/>
+          </a:prstGeom>
+          <a:solidFill>
+            <a:srgbClr val="FFFFFF"/>
+          </a:solidFill>
+          <a:ln w="12700">
+            <a:solidFill>
+              <a:srgbClr val="FFFFFF"/>
+            </a:solidFill>
+            <a:prstDash val="solid"/>
+          </a:ln>
+          <a:effectLst>
+            <a:outerShdw sx="100000" sy="100000" kx="0" ky="0" algn="bl" rotWithShape="0" blurRad="38100" dist="12700" dir="16200000">
+              <a:srgbClr val="000000">
+                <a:alpha val="15000"/>
+              </a:srgbClr>
+            </a:outerShdw>
+          </a:effectLst>
+        </p:spPr>
+      </p:sp>
+      <p:pic>
+        <p:nvPicPr>
+          <p:cNvPr id="28" name="Image 3" descr="C:\Claude\MCG Full Stack\generators\assets\icons\cloud.png">    </p:cNvPr>
+          <p:cNvPicPr>
+            <a:picLocks noChangeAspect="1"/>
+          </p:cNvPicPr>
+          <p:nvPr/>
+        </p:nvPicPr>
+        <p:blipFill>
+          <a:blip r:embed="rId4"/>
+          <a:stretch>
+            <a:fillRect/>
+          </a:stretch>
+        </p:blipFill>
+        <p:spPr>
+          <a:xfrm>
+            <a:off x="8227588" y="1287292"/>
+            <a:ext cx="351495" cy="351495"/>
+          </a:xfrm>
+          <a:prstGeom prst="rect">
+            <a:avLst/>
+          </a:prstGeom>
+        </p:spPr>
+      </p:pic>
+      <p:sp>
+        <p:nvSpPr>
+          <p:cNvPr id="29" name="Text 23"/>
+          <p:cNvSpPr/>
+          <p:nvPr/>
+        </p:nvSpPr>
+        <p:spPr>
+          <a:xfrm>
+            <a:off x="8814816" y="1078992"/>
+            <a:ext cx="1929384" cy="438912"/>
           </a:xfrm>
           <a:prstGeom prst="rect">
             <a:avLst/>
@@ -7280,7 +7448,7 @@
           <a:bodyPr wrap="square" rtlCol="0" anchor="b"/>
           <a:lstStyle/>
           <a:p>
-            <a:pPr algn="ctr" indent="0" marL="0">
+            <a:pPr algn="l" indent="0" marL="0">
               <a:buNone/>
             </a:pPr>
             <a:r>
@@ -7300,14 +7468,14 @@
       </p:sp>
       <p:sp>
         <p:nvSpPr>
-          <p:cNvPr id="24" name="Text 21"/>
-          <p:cNvSpPr/>
-          <p:nvPr/>
-        </p:nvSpPr>
-        <p:spPr>
-          <a:xfrm>
-            <a:off x="8074152" y="1481328"/>
-            <a:ext cx="2688336" cy="384048"/>
+          <p:cNvPr id="30" name="Text 24"/>
+          <p:cNvSpPr/>
+          <p:nvPr/>
+        </p:nvSpPr>
+        <p:spPr>
+          <a:xfrm>
+            <a:off x="8814816" y="1463040"/>
+            <a:ext cx="1929384" cy="402336"/>
           </a:xfrm>
           <a:prstGeom prst="rect">
             <a:avLst/>
@@ -7319,16 +7487,16 @@
           <a:bodyPr wrap="square" rtlCol="0" anchor="t"/>
           <a:lstStyle/>
           <a:p>
-            <a:pPr algn="ctr" indent="0" marL="0">
+            <a:pPr algn="l" indent="0" marL="0">
               <a:lnSpc>
-                <a:spcPct val="105000"/>
+                <a:spcPct val="102000"/>
               </a:lnSpc>
               <a:buNone/>
             </a:pPr>
             <a:r>
-              <a:rPr lang="en-US" sz="1000" dirty="0">
-                <a:solidFill>
-                  <a:srgbClr val="D0D4D7"/>
+              <a:rPr lang="en-US" sz="950" dirty="0">
+                <a:solidFill>
+                  <a:srgbClr val="D8DCE0"/>
                 </a:solidFill>
                 <a:latin typeface="Inter" pitchFamily="34" charset="0"/>
                 <a:ea typeface="Inter" pitchFamily="34" charset="-122"/>
@@ -7336,13 +7504,13 @@
               </a:rPr>
               <a:t>Connector • 3 objects • 15 min</a:t>
             </a:r>
-            <a:endParaRPr lang="en-US" sz="1000" dirty="0"/>
-          </a:p>
-        </p:txBody>
-      </p:sp>
-      <p:sp>
-        <p:nvSpPr>
-          <p:cNvPr id="25" name="Shape 22"/>
+            <a:endParaRPr lang="en-US" sz="950" dirty="0"/>
+          </a:p>
+        </p:txBody>
+      </p:sp>
+      <p:sp>
+        <p:nvSpPr>
+          <p:cNvPr id="31" name="Shape 25"/>
           <p:cNvSpPr/>
           <p:nvPr/>
         </p:nvSpPr>
@@ -7366,7 +7534,7 @@
       </p:sp>
       <p:sp>
         <p:nvSpPr>
-          <p:cNvPr id="26" name="Shape 23"/>
+          <p:cNvPr id="32" name="Shape 26"/>
           <p:cNvSpPr/>
           <p:nvPr/>
         </p:nvSpPr>
@@ -7390,7 +7558,7 @@
       </p:sp>
       <p:sp>
         <p:nvSpPr>
-          <p:cNvPr id="27" name="Shape 24"/>
+          <p:cNvPr id="33" name="Shape 27"/>
           <p:cNvSpPr/>
           <p:nvPr/>
         </p:nvSpPr>
@@ -7414,7 +7582,7 @@
       </p:sp>
       <p:sp>
         <p:nvSpPr>
-          <p:cNvPr id="28" name="Shape 25"/>
+          <p:cNvPr id="34" name="Shape 28"/>
           <p:cNvSpPr/>
           <p:nvPr/>
         </p:nvSpPr>
@@ -7441,7 +7609,63 @@
       </p:sp>
       <p:sp>
         <p:nvSpPr>
-          <p:cNvPr id="29" name="Text 26"/>
+          <p:cNvPr id="35" name="Shape 29"/>
+          <p:cNvSpPr/>
+          <p:nvPr/>
+        </p:nvSpPr>
+        <p:spPr>
+          <a:xfrm>
+            <a:off x="2075688" y="2441448"/>
+            <a:ext cx="256032" cy="256032"/>
+          </a:xfrm>
+          <a:prstGeom prst="ellipse">
+            <a:avLst/>
+          </a:prstGeom>
+          <a:solidFill>
+            <a:srgbClr val="FFFFFF"/>
+          </a:solidFill>
+          <a:ln w="12700">
+            <a:solidFill>
+              <a:srgbClr val="009845"/>
+            </a:solidFill>
+            <a:prstDash val="solid"/>
+          </a:ln>
+          <a:effectLst>
+            <a:outerShdw sx="100000" sy="100000" kx="0" ky="0" algn="bl" rotWithShape="0" blurRad="38100" dist="12700" dir="16200000">
+              <a:srgbClr val="000000">
+                <a:alpha val="15000"/>
+              </a:srgbClr>
+            </a:outerShdw>
+          </a:effectLst>
+        </p:spPr>
+      </p:sp>
+      <p:pic>
+        <p:nvPicPr>
+          <p:cNvPr id="36" name="Image 4" descr="C:\Claude\MCG Full Stack\generators\assets\icons\lakehouse.png">    </p:cNvPr>
+          <p:cNvPicPr>
+            <a:picLocks noChangeAspect="1"/>
+          </p:cNvPicPr>
+          <p:nvPr/>
+        </p:nvPicPr>
+        <p:blipFill>
+          <a:blip r:embed="rId5"/>
+          <a:stretch>
+            <a:fillRect/>
+          </a:stretch>
+        </p:blipFill>
+        <p:spPr>
+          <a:xfrm>
+            <a:off x="2124334" y="2490094"/>
+            <a:ext cx="158740" cy="158740"/>
+          </a:xfrm>
+          <a:prstGeom prst="rect">
+            <a:avLst/>
+          </a:prstGeom>
+        </p:spPr>
+      </p:pic>
+      <p:sp>
+        <p:nvSpPr>
+          <p:cNvPr id="37" name="Text 30"/>
           <p:cNvSpPr/>
           <p:nvPr/>
         </p:nvSpPr>
@@ -7480,7 +7704,7 @@
       </p:sp>
       <p:sp>
         <p:nvSpPr>
-          <p:cNvPr id="30" name="Shape 27"/>
+          <p:cNvPr id="38" name="Shape 31"/>
           <p:cNvSpPr/>
           <p:nvPr/>
         </p:nvSpPr>
@@ -7514,7 +7738,7 @@
       </p:sp>
       <p:sp>
         <p:nvSpPr>
-          <p:cNvPr id="31" name="Text 28"/>
+          <p:cNvPr id="39" name="Text 32"/>
           <p:cNvSpPr/>
           <p:nvPr/>
         </p:nvSpPr>
@@ -7553,7 +7777,7 @@
       </p:sp>
       <p:sp>
         <p:nvSpPr>
-          <p:cNvPr id="32" name="Text 29"/>
+          <p:cNvPr id="40" name="Text 33"/>
           <p:cNvSpPr/>
           <p:nvPr/>
         </p:nvSpPr>
@@ -7595,7 +7819,7 @@
       </p:sp>
       <p:sp>
         <p:nvSpPr>
-          <p:cNvPr id="33" name="Shape 30"/>
+          <p:cNvPr id="41" name="Shape 34"/>
           <p:cNvSpPr/>
           <p:nvPr/>
         </p:nvSpPr>
@@ -7629,7 +7853,7 @@
       </p:sp>
       <p:sp>
         <p:nvSpPr>
-          <p:cNvPr id="34" name="Text 31"/>
+          <p:cNvPr id="42" name="Text 35"/>
           <p:cNvSpPr/>
           <p:nvPr/>
         </p:nvSpPr>
@@ -7668,7 +7892,7 @@
       </p:sp>
       <p:sp>
         <p:nvSpPr>
-          <p:cNvPr id="35" name="Text 32"/>
+          <p:cNvPr id="43" name="Text 36"/>
           <p:cNvSpPr/>
           <p:nvPr/>
         </p:nvSpPr>
@@ -7710,7 +7934,7 @@
       </p:sp>
       <p:sp>
         <p:nvSpPr>
-          <p:cNvPr id="36" name="Shape 33"/>
+          <p:cNvPr id="44" name="Shape 37"/>
           <p:cNvSpPr/>
           <p:nvPr/>
         </p:nvSpPr>
@@ -7744,7 +7968,7 @@
       </p:sp>
       <p:sp>
         <p:nvSpPr>
-          <p:cNvPr id="37" name="Text 34"/>
+          <p:cNvPr id="45" name="Text 38"/>
           <p:cNvSpPr/>
           <p:nvPr/>
         </p:nvSpPr>
@@ -7783,7 +8007,7 @@
       </p:sp>
       <p:sp>
         <p:nvSpPr>
-          <p:cNvPr id="38" name="Text 35"/>
+          <p:cNvPr id="46" name="Text 39"/>
           <p:cNvSpPr/>
           <p:nvPr/>
         </p:nvSpPr>
@@ -7825,7 +8049,7 @@
       </p:sp>
       <p:sp>
         <p:nvSpPr>
-          <p:cNvPr id="39" name="Shape 36"/>
+          <p:cNvPr id="47" name="Shape 40"/>
           <p:cNvSpPr/>
           <p:nvPr/>
         </p:nvSpPr>
@@ -7849,7 +8073,7 @@
       </p:sp>
       <p:sp>
         <p:nvSpPr>
-          <p:cNvPr id="40" name="Shape 37"/>
+          <p:cNvPr id="48" name="Shape 41"/>
           <p:cNvSpPr/>
           <p:nvPr/>
         </p:nvSpPr>
@@ -7873,14 +8097,14 @@
       </p:sp>
       <p:sp>
         <p:nvSpPr>
-          <p:cNvPr id="41" name="Shape 38"/>
-          <p:cNvSpPr/>
-          <p:nvPr/>
-        </p:nvSpPr>
-        <p:spPr>
-          <a:xfrm>
-            <a:off x="9189720" y="2423160"/>
-            <a:ext cx="1691640" cy="914400"/>
+          <p:cNvPr id="49" name="Shape 42"/>
+          <p:cNvSpPr/>
+          <p:nvPr/>
+        </p:nvSpPr>
+        <p:spPr>
+          <a:xfrm>
+            <a:off x="9144000" y="2423160"/>
+            <a:ext cx="1874520" cy="914400"/>
           </a:xfrm>
           <a:prstGeom prst="roundRect">
             <a:avLst>
@@ -7907,14 +8131,70 @@
       </p:sp>
       <p:sp>
         <p:nvSpPr>
-          <p:cNvPr id="42" name="Text 39"/>
-          <p:cNvSpPr/>
-          <p:nvPr/>
-        </p:nvSpPr>
-        <p:spPr>
-          <a:xfrm>
-            <a:off x="9262872" y="2478024"/>
-            <a:ext cx="1545336" cy="457200"/>
+          <p:cNvPr id="50" name="Shape 43"/>
+          <p:cNvSpPr/>
+          <p:nvPr/>
+        </p:nvSpPr>
+        <p:spPr>
+          <a:xfrm>
+            <a:off x="9262872" y="2596896"/>
+            <a:ext cx="566928" cy="566928"/>
+          </a:xfrm>
+          <a:prstGeom prst="ellipse">
+            <a:avLst/>
+          </a:prstGeom>
+          <a:solidFill>
+            <a:srgbClr val="FFFFFF"/>
+          </a:solidFill>
+          <a:ln w="12700">
+            <a:solidFill>
+              <a:srgbClr val="FFFFFF"/>
+            </a:solidFill>
+            <a:prstDash val="solid"/>
+          </a:ln>
+          <a:effectLst>
+            <a:outerShdw sx="100000" sy="100000" kx="0" ky="0" algn="bl" rotWithShape="0" blurRad="38100" dist="12700" dir="16200000">
+              <a:srgbClr val="000000">
+                <a:alpha val="15000"/>
+              </a:srgbClr>
+            </a:outerShdw>
+          </a:effectLst>
+        </p:spPr>
+      </p:sp>
+      <p:pic>
+        <p:nvPicPr>
+          <p:cNvPr id="51" name="Image 5" descr="C:\Claude\MCG Full Stack\generators\assets\icons\transform.png">    </p:cNvPr>
+          <p:cNvPicPr>
+            <a:picLocks noChangeAspect="1"/>
+          </p:cNvPicPr>
+          <p:nvPr/>
+        </p:nvPicPr>
+        <p:blipFill>
+          <a:blip r:embed="rId6"/>
+          <a:stretch>
+            <a:fillRect/>
+          </a:stretch>
+        </p:blipFill>
+        <p:spPr>
+          <a:xfrm>
+            <a:off x="9370588" y="2704612"/>
+            <a:ext cx="351495" cy="351495"/>
+          </a:xfrm>
+          <a:prstGeom prst="rect">
+            <a:avLst/>
+          </a:prstGeom>
+        </p:spPr>
+      </p:pic>
+      <p:sp>
+        <p:nvSpPr>
+          <p:cNvPr id="52" name="Text 44"/>
+          <p:cNvSpPr/>
+          <p:nvPr/>
+        </p:nvSpPr>
+        <p:spPr>
+          <a:xfrm>
+            <a:off x="9957816" y="2496312"/>
+            <a:ext cx="969264" cy="438912"/>
           </a:xfrm>
           <a:prstGeom prst="rect">
             <a:avLst/>
@@ -7926,7 +8206,7 @@
           <a:bodyPr wrap="square" rtlCol="0" anchor="b"/>
           <a:lstStyle/>
           <a:p>
-            <a:pPr algn="ctr" indent="0" marL="0">
+            <a:pPr algn="l" indent="0" marL="0">
               <a:buNone/>
             </a:pPr>
             <a:r>
@@ -7946,14 +8226,14 @@
       </p:sp>
       <p:sp>
         <p:nvSpPr>
-          <p:cNvPr id="43" name="Text 40"/>
-          <p:cNvSpPr/>
-          <p:nvPr/>
-        </p:nvSpPr>
-        <p:spPr>
-          <a:xfrm>
-            <a:off x="9262872" y="2898648"/>
-            <a:ext cx="1545336" cy="384048"/>
+          <p:cNvPr id="53" name="Text 45"/>
+          <p:cNvSpPr/>
+          <p:nvPr/>
+        </p:nvSpPr>
+        <p:spPr>
+          <a:xfrm>
+            <a:off x="9957816" y="2880360"/>
+            <a:ext cx="969264" cy="402336"/>
           </a:xfrm>
           <a:prstGeom prst="rect">
             <a:avLst/>
@@ -7965,16 +8245,16 @@
           <a:bodyPr wrap="square" rtlCol="0" anchor="t"/>
           <a:lstStyle/>
           <a:p>
-            <a:pPr algn="ctr" indent="0" marL="0">
+            <a:pPr algn="l" indent="0" marL="0">
               <a:lnSpc>
-                <a:spcPct val="105000"/>
+                <a:spcPct val="102000"/>
               </a:lnSpc>
               <a:buNone/>
             </a:pPr>
             <a:r>
-              <a:rPr lang="en-US" sz="1000" dirty="0">
-                <a:solidFill>
-                  <a:srgbClr val="D0D4D7"/>
+              <a:rPr lang="en-US" sz="950" dirty="0">
+                <a:solidFill>
+                  <a:srgbClr val="D8DCE0"/>
                 </a:solidFill>
                 <a:latin typeface="Inter" pitchFamily="34" charset="0"/>
                 <a:ea typeface="Inter" pitchFamily="34" charset="-122"/>
@@ -7982,33 +8262,13 @@
               </a:rPr>
               <a:t>Address Validation</a:t>
             </a:r>
-            <a:endParaRPr lang="en-US" sz="1000" dirty="0"/>
-          </a:p>
-          <a:p>
-            <a:pPr algn="ctr" indent="0" marL="0">
-              <a:lnSpc>
-                <a:spcPct val="105000"/>
-              </a:lnSpc>
-              <a:buNone/>
-            </a:pPr>
-            <a:r>
-              <a:rPr lang="en-US" sz="1000" dirty="0">
-                <a:solidFill>
-                  <a:srgbClr val="D0D4D7"/>
-                </a:solidFill>
-                <a:latin typeface="Inter" pitchFamily="34" charset="0"/>
-                <a:ea typeface="Inter" pitchFamily="34" charset="-122"/>
-                <a:cs typeface="Inter" pitchFamily="34" charset="-120"/>
-              </a:rPr>
-              <a:t>+ Stewardship</a:t>
-            </a:r>
-            <a:endParaRPr lang="en-US" sz="1000" dirty="0"/>
-          </a:p>
-        </p:txBody>
-      </p:sp>
-      <p:sp>
-        <p:nvSpPr>
-          <p:cNvPr id="44" name="Shape 41"/>
+            <a:endParaRPr lang="en-US" sz="950" dirty="0"/>
+          </a:p>
+        </p:txBody>
+      </p:sp>
+      <p:sp>
+        <p:nvSpPr>
+          <p:cNvPr id="54" name="Shape 46"/>
           <p:cNvSpPr/>
           <p:nvPr/>
         </p:nvSpPr>
@@ -8037,7 +8297,7 @@
       </p:sp>
       <p:sp>
         <p:nvSpPr>
-          <p:cNvPr id="45" name="Text 42"/>
+          <p:cNvPr id="55" name="Text 47"/>
           <p:cNvSpPr/>
           <p:nvPr/>
         </p:nvSpPr>
@@ -8076,7 +8336,63 @@
       </p:sp>
       <p:sp>
         <p:nvSpPr>
-          <p:cNvPr id="46" name="Shape 43"/>
+          <p:cNvPr id="56" name="Shape 48"/>
+          <p:cNvSpPr/>
+          <p:nvPr/>
+        </p:nvSpPr>
+        <p:spPr>
+          <a:xfrm>
+            <a:off x="2029968" y="2057400"/>
+            <a:ext cx="256032" cy="256032"/>
+          </a:xfrm>
+          <a:prstGeom prst="ellipse">
+            <a:avLst/>
+          </a:prstGeom>
+          <a:solidFill>
+            <a:srgbClr val="FFFFFF"/>
+          </a:solidFill>
+          <a:ln w="12700">
+            <a:solidFill>
+              <a:srgbClr val="FFFFFF"/>
+            </a:solidFill>
+            <a:prstDash val="solid"/>
+          </a:ln>
+          <a:effectLst>
+            <a:outerShdw sx="100000" sy="100000" kx="0" ky="0" algn="bl" rotWithShape="0" blurRad="38100" dist="12700" dir="16200000">
+              <a:srgbClr val="000000">
+                <a:alpha val="15000"/>
+              </a:srgbClr>
+            </a:outerShdw>
+          </a:effectLst>
+        </p:spPr>
+      </p:sp>
+      <p:pic>
+        <p:nvPicPr>
+          <p:cNvPr id="57" name="Image 6" descr="C:\Claude\MCG Full Stack\generators\assets\icons\pipeline.png">    </p:cNvPr>
+          <p:cNvPicPr>
+            <a:picLocks noChangeAspect="1"/>
+          </p:cNvPicPr>
+          <p:nvPr/>
+        </p:nvPicPr>
+        <p:blipFill>
+          <a:blip r:embed="rId7"/>
+          <a:stretch>
+            <a:fillRect/>
+          </a:stretch>
+        </p:blipFill>
+        <p:spPr>
+          <a:xfrm>
+            <a:off x="2078614" y="2106046"/>
+            <a:ext cx="158740" cy="158740"/>
+          </a:xfrm>
+          <a:prstGeom prst="rect">
+            <a:avLst/>
+          </a:prstGeom>
+        </p:spPr>
+      </p:pic>
+      <p:sp>
+        <p:nvSpPr>
+          <p:cNvPr id="58" name="Shape 49"/>
           <p:cNvSpPr/>
           <p:nvPr/>
         </p:nvSpPr>
@@ -8100,7 +8416,7 @@
       </p:sp>
       <p:sp>
         <p:nvSpPr>
-          <p:cNvPr id="47" name="Shape 44"/>
+          <p:cNvPr id="59" name="Shape 50"/>
           <p:cNvSpPr/>
           <p:nvPr/>
         </p:nvSpPr>
@@ -8124,7 +8440,7 @@
       </p:sp>
       <p:sp>
         <p:nvSpPr>
-          <p:cNvPr id="48" name="Shape 45"/>
+          <p:cNvPr id="60" name="Shape 51"/>
           <p:cNvSpPr/>
           <p:nvPr/>
         </p:nvSpPr>
@@ -8158,14 +8474,70 @@
       </p:sp>
       <p:sp>
         <p:nvSpPr>
-          <p:cNvPr id="49" name="Text 46"/>
-          <p:cNvSpPr/>
-          <p:nvPr/>
-        </p:nvSpPr>
-        <p:spPr>
-          <a:xfrm>
-            <a:off x="2039112" y="3849624"/>
-            <a:ext cx="2596896" cy="457200"/>
+          <p:cNvPr id="61" name="Shape 52"/>
+          <p:cNvSpPr/>
+          <p:nvPr/>
+        </p:nvSpPr>
+        <p:spPr>
+          <a:xfrm>
+            <a:off x="2084832" y="3968496"/>
+            <a:ext cx="566928" cy="566928"/>
+          </a:xfrm>
+          <a:prstGeom prst="ellipse">
+            <a:avLst/>
+          </a:prstGeom>
+          <a:solidFill>
+            <a:srgbClr val="FFFFFF"/>
+          </a:solidFill>
+          <a:ln w="12700">
+            <a:solidFill>
+              <a:srgbClr val="FFFFFF"/>
+            </a:solidFill>
+            <a:prstDash val="solid"/>
+          </a:ln>
+          <a:effectLst>
+            <a:outerShdw sx="100000" sy="100000" kx="0" ky="0" algn="bl" rotWithShape="0" blurRad="38100" dist="12700" dir="16200000">
+              <a:srgbClr val="000000">
+                <a:alpha val="15000"/>
+              </a:srgbClr>
+            </a:outerShdw>
+          </a:effectLst>
+        </p:spPr>
+      </p:sp>
+      <p:pic>
+        <p:nvPicPr>
+          <p:cNvPr id="62" name="Image 7" descr="C:\Claude\MCG Full Stack\generators\assets\icons\analytics.png">    </p:cNvPr>
+          <p:cNvPicPr>
+            <a:picLocks noChangeAspect="1"/>
+          </p:cNvPicPr>
+          <p:nvPr/>
+        </p:nvPicPr>
+        <p:blipFill>
+          <a:blip r:embed="rId8"/>
+          <a:stretch>
+            <a:fillRect/>
+          </a:stretch>
+        </p:blipFill>
+        <p:spPr>
+          <a:xfrm>
+            <a:off x="2192548" y="4076212"/>
+            <a:ext cx="351495" cy="351495"/>
+          </a:xfrm>
+          <a:prstGeom prst="rect">
+            <a:avLst/>
+          </a:prstGeom>
+        </p:spPr>
+      </p:pic>
+      <p:sp>
+        <p:nvSpPr>
+          <p:cNvPr id="63" name="Text 53"/>
+          <p:cNvSpPr/>
+          <p:nvPr/>
+        </p:nvSpPr>
+        <p:spPr>
+          <a:xfrm>
+            <a:off x="2779776" y="3867912"/>
+            <a:ext cx="1837944" cy="438912"/>
           </a:xfrm>
           <a:prstGeom prst="rect">
             <a:avLst/>
@@ -8177,7 +8549,7 @@
           <a:bodyPr wrap="square" rtlCol="0" anchor="b"/>
           <a:lstStyle/>
           <a:p>
-            <a:pPr algn="ctr" indent="0" marL="0">
+            <a:pPr algn="l" indent="0" marL="0">
               <a:buNone/>
             </a:pPr>
             <a:r>
@@ -8197,14 +8569,14 @@
       </p:sp>
       <p:sp>
         <p:nvSpPr>
-          <p:cNvPr id="50" name="Text 47"/>
-          <p:cNvSpPr/>
-          <p:nvPr/>
-        </p:nvSpPr>
-        <p:spPr>
-          <a:xfrm>
-            <a:off x="2039112" y="4270248"/>
-            <a:ext cx="2596896" cy="384048"/>
+          <p:cNvPr id="64" name="Text 54"/>
+          <p:cNvSpPr/>
+          <p:nvPr/>
+        </p:nvSpPr>
+        <p:spPr>
+          <a:xfrm>
+            <a:off x="2779776" y="4251960"/>
+            <a:ext cx="1837944" cy="402336"/>
           </a:xfrm>
           <a:prstGeom prst="rect">
             <a:avLst/>
@@ -8216,16 +8588,16 @@
           <a:bodyPr wrap="square" rtlCol="0" anchor="t"/>
           <a:lstStyle/>
           <a:p>
-            <a:pPr algn="ctr" indent="0" marL="0">
+            <a:pPr algn="l" indent="0" marL="0">
               <a:lnSpc>
-                <a:spcPct val="105000"/>
+                <a:spcPct val="102000"/>
               </a:lnSpc>
               <a:buNone/>
             </a:pPr>
             <a:r>
-              <a:rPr lang="en-US" sz="1000" dirty="0">
-                <a:solidFill>
-                  <a:srgbClr val="D0D4D7"/>
+              <a:rPr lang="en-US" sz="950" dirty="0">
+                <a:solidFill>
+                  <a:srgbClr val="D8DCE0"/>
                 </a:solidFill>
                 <a:latin typeface="Inter" pitchFamily="34" charset="0"/>
                 <a:ea typeface="Inter" pitchFamily="34" charset="-122"/>
@@ -8233,13 +8605,13 @@
               </a:rPr>
               <a:t>2 apps • 10 sheets</a:t>
             </a:r>
-            <a:endParaRPr lang="en-US" sz="1000" dirty="0"/>
-          </a:p>
-        </p:txBody>
-      </p:sp>
-      <p:sp>
-        <p:nvSpPr>
-          <p:cNvPr id="51" name="Shape 48"/>
+            <a:endParaRPr lang="en-US" sz="950" dirty="0"/>
+          </a:p>
+        </p:txBody>
+      </p:sp>
+      <p:sp>
+        <p:nvSpPr>
+          <p:cNvPr id="65" name="Shape 55"/>
           <p:cNvSpPr/>
           <p:nvPr/>
         </p:nvSpPr>
@@ -8273,14 +8645,70 @@
       </p:sp>
       <p:sp>
         <p:nvSpPr>
-          <p:cNvPr id="52" name="Text 49"/>
-          <p:cNvSpPr/>
-          <p:nvPr/>
-        </p:nvSpPr>
-        <p:spPr>
-          <a:xfrm>
-            <a:off x="4965192" y="3849624"/>
-            <a:ext cx="2596896" cy="457200"/>
+          <p:cNvPr id="66" name="Shape 56"/>
+          <p:cNvSpPr/>
+          <p:nvPr/>
+        </p:nvSpPr>
+        <p:spPr>
+          <a:xfrm>
+            <a:off x="5010912" y="3968496"/>
+            <a:ext cx="566928" cy="566928"/>
+          </a:xfrm>
+          <a:prstGeom prst="ellipse">
+            <a:avLst/>
+          </a:prstGeom>
+          <a:solidFill>
+            <a:srgbClr val="FFFFFF"/>
+          </a:solidFill>
+          <a:ln w="12700">
+            <a:solidFill>
+              <a:srgbClr val="FFFFFF"/>
+            </a:solidFill>
+            <a:prstDash val="solid"/>
+          </a:ln>
+          <a:effectLst>
+            <a:outerShdw sx="100000" sy="100000" kx="0" ky="0" algn="bl" rotWithShape="0" blurRad="38100" dist="12700" dir="16200000">
+              <a:srgbClr val="000000">
+                <a:alpha val="15000"/>
+              </a:srgbClr>
+            </a:outerShdw>
+          </a:effectLst>
+        </p:spPr>
+      </p:sp>
+      <p:pic>
+        <p:nvPicPr>
+          <p:cNvPr id="67" name="Image 8" descr="C:\Claude\MCG Full Stack\generators\assets\icons\predict.png">    </p:cNvPr>
+          <p:cNvPicPr>
+            <a:picLocks noChangeAspect="1"/>
+          </p:cNvPicPr>
+          <p:nvPr/>
+        </p:nvPicPr>
+        <p:blipFill>
+          <a:blip r:embed="rId9"/>
+          <a:stretch>
+            <a:fillRect/>
+          </a:stretch>
+        </p:blipFill>
+        <p:spPr>
+          <a:xfrm>
+            <a:off x="5118628" y="4076212"/>
+            <a:ext cx="351495" cy="351495"/>
+          </a:xfrm>
+          <a:prstGeom prst="rect">
+            <a:avLst/>
+          </a:prstGeom>
+        </p:spPr>
+      </p:pic>
+      <p:sp>
+        <p:nvSpPr>
+          <p:cNvPr id="68" name="Text 57"/>
+          <p:cNvSpPr/>
+          <p:nvPr/>
+        </p:nvSpPr>
+        <p:spPr>
+          <a:xfrm>
+            <a:off x="5705856" y="3867912"/>
+            <a:ext cx="1837944" cy="438912"/>
           </a:xfrm>
           <a:prstGeom prst="rect">
             <a:avLst/>
@@ -8292,7 +8720,7 @@
           <a:bodyPr wrap="square" rtlCol="0" anchor="b"/>
           <a:lstStyle/>
           <a:p>
-            <a:pPr algn="ctr" indent="0" marL="0">
+            <a:pPr algn="l" indent="0" marL="0">
               <a:buNone/>
             </a:pPr>
             <a:r>
@@ -8312,14 +8740,14 @@
       </p:sp>
       <p:sp>
         <p:nvSpPr>
-          <p:cNvPr id="53" name="Text 50"/>
-          <p:cNvSpPr/>
-          <p:nvPr/>
-        </p:nvSpPr>
-        <p:spPr>
-          <a:xfrm>
-            <a:off x="4965192" y="4270248"/>
-            <a:ext cx="2596896" cy="384048"/>
+          <p:cNvPr id="69" name="Text 58"/>
+          <p:cNvSpPr/>
+          <p:nvPr/>
+        </p:nvSpPr>
+        <p:spPr>
+          <a:xfrm>
+            <a:off x="5705856" y="4251960"/>
+            <a:ext cx="1837944" cy="402336"/>
           </a:xfrm>
           <a:prstGeom prst="rect">
             <a:avLst/>
@@ -8331,16 +8759,16 @@
           <a:bodyPr wrap="square" rtlCol="0" anchor="t"/>
           <a:lstStyle/>
           <a:p>
-            <a:pPr algn="ctr" indent="0" marL="0">
+            <a:pPr algn="l" indent="0" marL="0">
               <a:lnSpc>
-                <a:spcPct val="105000"/>
+                <a:spcPct val="102000"/>
               </a:lnSpc>
               <a:buNone/>
             </a:pPr>
             <a:r>
-              <a:rPr lang="en-US" sz="1000" dirty="0">
-                <a:solidFill>
-                  <a:srgbClr val="D0D4D7"/>
+              <a:rPr lang="en-US" sz="950" dirty="0">
+                <a:solidFill>
+                  <a:srgbClr val="D8DCE0"/>
                 </a:solidFill>
                 <a:latin typeface="Inter" pitchFamily="34" charset="0"/>
                 <a:ea typeface="Inter" pitchFamily="34" charset="-122"/>
@@ -8348,13 +8776,13 @@
               </a:rPr>
               <a:t>Exceedance • Late Delivery</a:t>
             </a:r>
-            <a:endParaRPr lang="en-US" sz="1000" dirty="0"/>
-          </a:p>
-        </p:txBody>
-      </p:sp>
-      <p:sp>
-        <p:nvSpPr>
-          <p:cNvPr id="54" name="Shape 51"/>
+            <a:endParaRPr lang="en-US" sz="950" dirty="0"/>
+          </a:p>
+        </p:txBody>
+      </p:sp>
+      <p:sp>
+        <p:nvSpPr>
+          <p:cNvPr id="70" name="Shape 59"/>
           <p:cNvSpPr/>
           <p:nvPr/>
         </p:nvSpPr>
@@ -8388,14 +8816,70 @@
       </p:sp>
       <p:sp>
         <p:nvSpPr>
-          <p:cNvPr id="55" name="Text 52"/>
-          <p:cNvSpPr/>
-          <p:nvPr/>
-        </p:nvSpPr>
-        <p:spPr>
-          <a:xfrm>
-            <a:off x="7891272" y="3849624"/>
-            <a:ext cx="2916936" cy="457200"/>
+          <p:cNvPr id="71" name="Shape 60"/>
+          <p:cNvSpPr/>
+          <p:nvPr/>
+        </p:nvSpPr>
+        <p:spPr>
+          <a:xfrm>
+            <a:off x="7936992" y="3968496"/>
+            <a:ext cx="566928" cy="566928"/>
+          </a:xfrm>
+          <a:prstGeom prst="ellipse">
+            <a:avLst/>
+          </a:prstGeom>
+          <a:solidFill>
+            <a:srgbClr val="FFFFFF"/>
+          </a:solidFill>
+          <a:ln w="12700">
+            <a:solidFill>
+              <a:srgbClr val="FFFFFF"/>
+            </a:solidFill>
+            <a:prstDash val="solid"/>
+          </a:ln>
+          <a:effectLst>
+            <a:outerShdw sx="100000" sy="100000" kx="0" ky="0" algn="bl" rotWithShape="0" blurRad="38100" dist="12700" dir="16200000">
+              <a:srgbClr val="000000">
+                <a:alpha val="15000"/>
+              </a:srgbClr>
+            </a:outerShdw>
+          </a:effectLst>
+        </p:spPr>
+      </p:sp>
+      <p:pic>
+        <p:nvPicPr>
+          <p:cNvPr id="72" name="Image 9" descr="C:\Claude\MCG Full Stack\generators\assets\icons\governance.png">    </p:cNvPr>
+          <p:cNvPicPr>
+            <a:picLocks noChangeAspect="1"/>
+          </p:cNvPicPr>
+          <p:nvPr/>
+        </p:nvPicPr>
+        <p:blipFill>
+          <a:blip r:embed="rId10"/>
+          <a:stretch>
+            <a:fillRect/>
+          </a:stretch>
+        </p:blipFill>
+        <p:spPr>
+          <a:xfrm>
+            <a:off x="8044708" y="4076212"/>
+            <a:ext cx="351495" cy="351495"/>
+          </a:xfrm>
+          <a:prstGeom prst="rect">
+            <a:avLst/>
+          </a:prstGeom>
+        </p:spPr>
+      </p:pic>
+      <p:sp>
+        <p:nvSpPr>
+          <p:cNvPr id="73" name="Text 61"/>
+          <p:cNvSpPr/>
+          <p:nvPr/>
+        </p:nvSpPr>
+        <p:spPr>
+          <a:xfrm>
+            <a:off x="8631936" y="3867912"/>
+            <a:ext cx="2157984" cy="438912"/>
           </a:xfrm>
           <a:prstGeom prst="rect">
             <a:avLst/>
@@ -8407,7 +8891,7 @@
           <a:bodyPr wrap="square" rtlCol="0" anchor="b"/>
           <a:lstStyle/>
           <a:p>
-            <a:pPr algn="ctr" indent="0" marL="0">
+            <a:pPr algn="l" indent="0" marL="0">
               <a:buNone/>
             </a:pPr>
             <a:r>
@@ -8427,14 +8911,14 @@
       </p:sp>
       <p:sp>
         <p:nvSpPr>
-          <p:cNvPr id="56" name="Text 53"/>
-          <p:cNvSpPr/>
-          <p:nvPr/>
-        </p:nvSpPr>
-        <p:spPr>
-          <a:xfrm>
-            <a:off x="7891272" y="4270248"/>
-            <a:ext cx="2916936" cy="384048"/>
+          <p:cNvPr id="74" name="Text 62"/>
+          <p:cNvSpPr/>
+          <p:nvPr/>
+        </p:nvSpPr>
+        <p:spPr>
+          <a:xfrm>
+            <a:off x="8631936" y="4251960"/>
+            <a:ext cx="2157984" cy="402336"/>
           </a:xfrm>
           <a:prstGeom prst="rect">
             <a:avLst/>
@@ -8446,16 +8930,16 @@
           <a:bodyPr wrap="square" rtlCol="0" anchor="t"/>
           <a:lstStyle/>
           <a:p>
-            <a:pPr algn="ctr" indent="0" marL="0">
+            <a:pPr algn="l" indent="0" marL="0">
               <a:lnSpc>
-                <a:spcPct val="105000"/>
+                <a:spcPct val="102000"/>
               </a:lnSpc>
               <a:buNone/>
             </a:pPr>
             <a:r>
-              <a:rPr lang="en-US" sz="1000" dirty="0">
-                <a:solidFill>
-                  <a:srgbClr val="D0D4D7"/>
+              <a:rPr lang="en-US" sz="950" dirty="0">
+                <a:solidFill>
+                  <a:srgbClr val="D8DCE0"/>
                 </a:solidFill>
                 <a:latin typeface="Inter" pitchFamily="34" charset="0"/>
                 <a:ea typeface="Inter" pitchFamily="34" charset="-122"/>
@@ -8463,19 +8947,19 @@
               </a:rPr>
               <a:t>Trust Score • Stewardship</a:t>
             </a:r>
-            <a:endParaRPr lang="en-US" sz="1000" dirty="0"/>
-          </a:p>
-          <a:p>
-            <a:pPr algn="ctr" indent="0" marL="0">
+            <a:endParaRPr lang="en-US" sz="950" dirty="0"/>
+          </a:p>
+          <a:p>
+            <a:pPr algn="l" indent="0" marL="0">
               <a:lnSpc>
-                <a:spcPct val="105000"/>
+                <a:spcPct val="102000"/>
               </a:lnSpc>
               <a:buNone/>
             </a:pPr>
             <a:r>
-              <a:rPr lang="en-US" sz="1000" dirty="0">
-                <a:solidFill>
-                  <a:srgbClr val="D0D4D7"/>
+              <a:rPr lang="en-US" sz="950" dirty="0">
+                <a:solidFill>
+                  <a:srgbClr val="D8DCE0"/>
                 </a:solidFill>
                 <a:latin typeface="Inter" pitchFamily="34" charset="0"/>
                 <a:ea typeface="Inter" pitchFamily="34" charset="-122"/>
@@ -8483,13 +8967,13 @@
               </a:rPr>
               <a:t>Glossary • Lineage</a:t>
             </a:r>
-            <a:endParaRPr lang="en-US" sz="1000" dirty="0"/>
-          </a:p>
-        </p:txBody>
-      </p:sp>
-      <p:sp>
-        <p:nvSpPr>
-          <p:cNvPr id="57" name="Shape 54"/>
+            <a:endParaRPr lang="en-US" sz="950" dirty="0"/>
+          </a:p>
+        </p:txBody>
+      </p:sp>
+      <p:sp>
+        <p:nvSpPr>
+          <p:cNvPr id="75" name="Shape 63"/>
           <p:cNvSpPr/>
           <p:nvPr/>
         </p:nvSpPr>
@@ -8513,7 +8997,7 @@
       </p:sp>
       <p:sp>
         <p:nvSpPr>
-          <p:cNvPr id="58" name="Shape 55"/>
+          <p:cNvPr id="76" name="Shape 64"/>
           <p:cNvSpPr/>
           <p:nvPr/>
         </p:nvSpPr>
@@ -8537,7 +9021,7 @@
       </p:sp>
       <p:sp>
         <p:nvSpPr>
-          <p:cNvPr id="59" name="Shape 56"/>
+          <p:cNvPr id="77" name="Shape 65"/>
           <p:cNvSpPr/>
           <p:nvPr/>
         </p:nvSpPr>
@@ -8561,7 +9045,7 @@
       </p:sp>
       <p:sp>
         <p:nvSpPr>
-          <p:cNvPr id="60" name="Shape 57"/>
+          <p:cNvPr id="78" name="Shape 66"/>
           <p:cNvSpPr/>
           <p:nvPr/>
         </p:nvSpPr>
@@ -8595,14 +9079,70 @@
       </p:sp>
       <p:sp>
         <p:nvSpPr>
-          <p:cNvPr id="61" name="Text 58"/>
-          <p:cNvSpPr/>
-          <p:nvPr/>
-        </p:nvSpPr>
-        <p:spPr>
-          <a:xfrm>
-            <a:off x="2039112" y="5129784"/>
-            <a:ext cx="1956816" cy="457200"/>
+          <p:cNvPr id="79" name="Shape 67"/>
+          <p:cNvSpPr/>
+          <p:nvPr/>
+        </p:nvSpPr>
+        <p:spPr>
+          <a:xfrm>
+            <a:off x="2084832" y="5248656"/>
+            <a:ext cx="566928" cy="566928"/>
+          </a:xfrm>
+          <a:prstGeom prst="ellipse">
+            <a:avLst/>
+          </a:prstGeom>
+          <a:solidFill>
+            <a:srgbClr val="FFFFFF"/>
+          </a:solidFill>
+          <a:ln w="12700">
+            <a:solidFill>
+              <a:srgbClr val="FFFFFF"/>
+            </a:solidFill>
+            <a:prstDash val="solid"/>
+          </a:ln>
+          <a:effectLst>
+            <a:outerShdw sx="100000" sy="100000" kx="0" ky="0" algn="bl" rotWithShape="0" blurRad="38100" dist="12700" dir="16200000">
+              <a:srgbClr val="000000">
+                <a:alpha val="15000"/>
+              </a:srgbClr>
+            </a:outerShdw>
+          </a:effectLst>
+        </p:spPr>
+      </p:sp>
+      <p:pic>
+        <p:nvPicPr>
+          <p:cNvPr id="80" name="Image 10" descr="C:\Claude\MCG Full Stack\generators\assets\icons\answers.png">    </p:cNvPr>
+          <p:cNvPicPr>
+            <a:picLocks noChangeAspect="1"/>
+          </p:cNvPicPr>
+          <p:nvPr/>
+        </p:nvPicPr>
+        <p:blipFill>
+          <a:blip r:embed="rId11"/>
+          <a:stretch>
+            <a:fillRect/>
+          </a:stretch>
+        </p:blipFill>
+        <p:spPr>
+          <a:xfrm>
+            <a:off x="2192548" y="5356372"/>
+            <a:ext cx="351495" cy="351495"/>
+          </a:xfrm>
+          <a:prstGeom prst="rect">
+            <a:avLst/>
+          </a:prstGeom>
+        </p:spPr>
+      </p:pic>
+      <p:sp>
+        <p:nvSpPr>
+          <p:cNvPr id="81" name="Text 68"/>
+          <p:cNvSpPr/>
+          <p:nvPr/>
+        </p:nvSpPr>
+        <p:spPr>
+          <a:xfrm>
+            <a:off x="2779776" y="5148072"/>
+            <a:ext cx="1197864" cy="438912"/>
           </a:xfrm>
           <a:prstGeom prst="rect">
             <a:avLst/>
@@ -8614,7 +9154,7 @@
           <a:bodyPr wrap="square" rtlCol="0" anchor="b"/>
           <a:lstStyle/>
           <a:p>
-            <a:pPr algn="ctr" indent="0" marL="0">
+            <a:pPr algn="l" indent="0" marL="0">
               <a:buNone/>
             </a:pPr>
             <a:r>
@@ -8634,14 +9174,14 @@
       </p:sp>
       <p:sp>
         <p:nvSpPr>
-          <p:cNvPr id="62" name="Text 59"/>
-          <p:cNvSpPr/>
-          <p:nvPr/>
-        </p:nvSpPr>
-        <p:spPr>
-          <a:xfrm>
-            <a:off x="2039112" y="5550408"/>
-            <a:ext cx="1956816" cy="384048"/>
+          <p:cNvPr id="82" name="Text 69"/>
+          <p:cNvSpPr/>
+          <p:nvPr/>
+        </p:nvSpPr>
+        <p:spPr>
+          <a:xfrm>
+            <a:off x="2779776" y="5532120"/>
+            <a:ext cx="1197864" cy="402336"/>
           </a:xfrm>
           <a:prstGeom prst="rect">
             <a:avLst/>
@@ -8653,16 +9193,16 @@
           <a:bodyPr wrap="square" rtlCol="0" anchor="t"/>
           <a:lstStyle/>
           <a:p>
-            <a:pPr algn="ctr" indent="0" marL="0">
+            <a:pPr algn="l" indent="0" marL="0">
               <a:lnSpc>
-                <a:spcPct val="105000"/>
+                <a:spcPct val="102000"/>
               </a:lnSpc>
               <a:buNone/>
             </a:pPr>
             <a:r>
-              <a:rPr lang="en-US" sz="1000" dirty="0">
-                <a:solidFill>
-                  <a:srgbClr val="D0D4D7"/>
+              <a:rPr lang="en-US" sz="950" dirty="0">
+                <a:solidFill>
+                  <a:srgbClr val="D8DCE0"/>
                 </a:solidFill>
                 <a:latin typeface="Inter" pitchFamily="34" charset="0"/>
                 <a:ea typeface="Inter" pitchFamily="34" charset="-122"/>
@@ -8670,19 +9210,19 @@
               </a:rPr>
               <a:t>25 DOCX docs</a:t>
             </a:r>
-            <a:endParaRPr lang="en-US" sz="1000" dirty="0"/>
-          </a:p>
-          <a:p>
-            <a:pPr algn="ctr" indent="0" marL="0">
+            <a:endParaRPr lang="en-US" sz="950" dirty="0"/>
+          </a:p>
+          <a:p>
+            <a:pPr algn="l" indent="0" marL="0">
               <a:lnSpc>
-                <a:spcPct val="105000"/>
+                <a:spcPct val="102000"/>
               </a:lnSpc>
               <a:buNone/>
             </a:pPr>
             <a:r>
-              <a:rPr lang="en-US" sz="1000" dirty="0">
-                <a:solidFill>
-                  <a:srgbClr val="D0D4D7"/>
+              <a:rPr lang="en-US" sz="950" dirty="0">
+                <a:solidFill>
+                  <a:srgbClr val="D8DCE0"/>
                 </a:solidFill>
                 <a:latin typeface="Inter" pitchFamily="34" charset="0"/>
                 <a:ea typeface="Inter" pitchFamily="34" charset="-122"/>
@@ -8690,13 +9230,13 @@
               </a:rPr>
               <a:t>Knowledge base</a:t>
             </a:r>
-            <a:endParaRPr lang="en-US" sz="1000" dirty="0"/>
-          </a:p>
-        </p:txBody>
-      </p:sp>
-      <p:sp>
-        <p:nvSpPr>
-          <p:cNvPr id="63" name="Shape 60"/>
+            <a:endParaRPr lang="en-US" sz="950" dirty="0"/>
+          </a:p>
+        </p:txBody>
+      </p:sp>
+      <p:sp>
+        <p:nvSpPr>
+          <p:cNvPr id="83" name="Shape 70"/>
           <p:cNvSpPr/>
           <p:nvPr/>
         </p:nvSpPr>
@@ -8730,14 +9270,70 @@
       </p:sp>
       <p:sp>
         <p:nvSpPr>
-          <p:cNvPr id="64" name="Text 61"/>
-          <p:cNvSpPr/>
-          <p:nvPr/>
-        </p:nvSpPr>
-        <p:spPr>
-          <a:xfrm>
-            <a:off x="4325112" y="5129784"/>
-            <a:ext cx="1956816" cy="457200"/>
+          <p:cNvPr id="84" name="Shape 71"/>
+          <p:cNvSpPr/>
+          <p:nvPr/>
+        </p:nvSpPr>
+        <p:spPr>
+          <a:xfrm>
+            <a:off x="4370832" y="5248656"/>
+            <a:ext cx="566928" cy="566928"/>
+          </a:xfrm>
+          <a:prstGeom prst="ellipse">
+            <a:avLst/>
+          </a:prstGeom>
+          <a:solidFill>
+            <a:srgbClr val="FFFFFF"/>
+          </a:solidFill>
+          <a:ln w="12700">
+            <a:solidFill>
+              <a:srgbClr val="FFFFFF"/>
+            </a:solidFill>
+            <a:prstDash val="solid"/>
+          </a:ln>
+          <a:effectLst>
+            <a:outerShdw sx="100000" sy="100000" kx="0" ky="0" algn="bl" rotWithShape="0" blurRad="38100" dist="12700" dir="16200000">
+              <a:srgbClr val="000000">
+                <a:alpha val="15000"/>
+              </a:srgbClr>
+            </a:outerShdw>
+          </a:effectLst>
+        </p:spPr>
+      </p:sp>
+      <p:pic>
+        <p:nvPicPr>
+          <p:cNvPr id="85" name="Image 11" descr="C:\Claude\MCG Full Stack\generators\assets\icons\agent.png">    </p:cNvPr>
+          <p:cNvPicPr>
+            <a:picLocks noChangeAspect="1"/>
+          </p:cNvPicPr>
+          <p:nvPr/>
+        </p:nvPicPr>
+        <p:blipFill>
+          <a:blip r:embed="rId12"/>
+          <a:stretch>
+            <a:fillRect/>
+          </a:stretch>
+        </p:blipFill>
+        <p:spPr>
+          <a:xfrm>
+            <a:off x="4478548" y="5356372"/>
+            <a:ext cx="351495" cy="351495"/>
+          </a:xfrm>
+          <a:prstGeom prst="rect">
+            <a:avLst/>
+          </a:prstGeom>
+        </p:spPr>
+      </p:pic>
+      <p:sp>
+        <p:nvSpPr>
+          <p:cNvPr id="86" name="Text 72"/>
+          <p:cNvSpPr/>
+          <p:nvPr/>
+        </p:nvSpPr>
+        <p:spPr>
+          <a:xfrm>
+            <a:off x="5065776" y="5148072"/>
+            <a:ext cx="1197864" cy="438912"/>
           </a:xfrm>
           <a:prstGeom prst="rect">
             <a:avLst/>
@@ -8749,7 +9345,7 @@
           <a:bodyPr wrap="square" rtlCol="0" anchor="b"/>
           <a:lstStyle/>
           <a:p>
-            <a:pPr algn="ctr" indent="0" marL="0">
+            <a:pPr algn="l" indent="0" marL="0">
               <a:buNone/>
             </a:pPr>
             <a:r>
@@ -8769,14 +9365,14 @@
       </p:sp>
       <p:sp>
         <p:nvSpPr>
-          <p:cNvPr id="65" name="Text 62"/>
-          <p:cNvSpPr/>
-          <p:nvPr/>
-        </p:nvSpPr>
-        <p:spPr>
-          <a:xfrm>
-            <a:off x="4325112" y="5550408"/>
-            <a:ext cx="1956816" cy="384048"/>
+          <p:cNvPr id="87" name="Text 73"/>
+          <p:cNvSpPr/>
+          <p:nvPr/>
+        </p:nvSpPr>
+        <p:spPr>
+          <a:xfrm>
+            <a:off x="5065776" y="5532120"/>
+            <a:ext cx="1197864" cy="402336"/>
           </a:xfrm>
           <a:prstGeom prst="rect">
             <a:avLst/>
@@ -8788,16 +9384,16 @@
           <a:bodyPr wrap="square" rtlCol="0" anchor="t"/>
           <a:lstStyle/>
           <a:p>
-            <a:pPr algn="ctr" indent="0" marL="0">
+            <a:pPr algn="l" indent="0" marL="0">
               <a:lnSpc>
-                <a:spcPct val="105000"/>
+                <a:spcPct val="102000"/>
               </a:lnSpc>
               <a:buNone/>
             </a:pPr>
             <a:r>
-              <a:rPr lang="en-US" sz="1000" dirty="0">
-                <a:solidFill>
-                  <a:srgbClr val="D0D4D7"/>
+              <a:rPr lang="en-US" sz="950" dirty="0">
+                <a:solidFill>
+                  <a:srgbClr val="D8DCE0"/>
                 </a:solidFill>
                 <a:latin typeface="Inter" pitchFamily="34" charset="0"/>
                 <a:ea typeface="Inter" pitchFamily="34" charset="-122"/>
@@ -8805,19 +9401,19 @@
               </a:rPr>
               <a:t>Anomaly detection</a:t>
             </a:r>
-            <a:endParaRPr lang="en-US" sz="1000" dirty="0"/>
-          </a:p>
-          <a:p>
-            <a:pPr algn="ctr" indent="0" marL="0">
+            <a:endParaRPr lang="en-US" sz="950" dirty="0"/>
+          </a:p>
+          <a:p>
+            <a:pPr algn="l" indent="0" marL="0">
               <a:lnSpc>
-                <a:spcPct val="105000"/>
+                <a:spcPct val="102000"/>
               </a:lnSpc>
               <a:buNone/>
             </a:pPr>
             <a:r>
-              <a:rPr lang="en-US" sz="1000" dirty="0">
-                <a:solidFill>
-                  <a:srgbClr val="D0D4D7"/>
+              <a:rPr lang="en-US" sz="950" dirty="0">
+                <a:solidFill>
+                  <a:srgbClr val="D8DCE0"/>
                 </a:solidFill>
                 <a:latin typeface="Inter" pitchFamily="34" charset="0"/>
                 <a:ea typeface="Inter" pitchFamily="34" charset="-122"/>
@@ -8825,13 +9421,13 @@
               </a:rPr>
               <a:t>Proactive alerts</a:t>
             </a:r>
-            <a:endParaRPr lang="en-US" sz="1000" dirty="0"/>
-          </a:p>
-        </p:txBody>
-      </p:sp>
-      <p:sp>
-        <p:nvSpPr>
-          <p:cNvPr id="66" name="Shape 63"/>
+            <a:endParaRPr lang="en-US" sz="950" dirty="0"/>
+          </a:p>
+        </p:txBody>
+      </p:sp>
+      <p:sp>
+        <p:nvSpPr>
+          <p:cNvPr id="88" name="Shape 74"/>
           <p:cNvSpPr/>
           <p:nvPr/>
         </p:nvSpPr>
@@ -8865,14 +9461,70 @@
       </p:sp>
       <p:sp>
         <p:nvSpPr>
-          <p:cNvPr id="67" name="Text 64"/>
-          <p:cNvSpPr/>
-          <p:nvPr/>
-        </p:nvSpPr>
-        <p:spPr>
-          <a:xfrm>
-            <a:off x="6611112" y="5129784"/>
-            <a:ext cx="1956816" cy="457200"/>
+          <p:cNvPr id="89" name="Shape 75"/>
+          <p:cNvSpPr/>
+          <p:nvPr/>
+        </p:nvSpPr>
+        <p:spPr>
+          <a:xfrm>
+            <a:off x="6656832" y="5248656"/>
+            <a:ext cx="566928" cy="566928"/>
+          </a:xfrm>
+          <a:prstGeom prst="ellipse">
+            <a:avLst/>
+          </a:prstGeom>
+          <a:solidFill>
+            <a:srgbClr val="FFFFFF"/>
+          </a:solidFill>
+          <a:ln w="12700">
+            <a:solidFill>
+              <a:srgbClr val="FFFFFF"/>
+            </a:solidFill>
+            <a:prstDash val="solid"/>
+          </a:ln>
+          <a:effectLst>
+            <a:outerShdw sx="100000" sy="100000" kx="0" ky="0" algn="bl" rotWithShape="0" blurRad="38100" dist="12700" dir="16200000">
+              <a:srgbClr val="000000">
+                <a:alpha val="15000"/>
+              </a:srgbClr>
+            </a:outerShdw>
+          </a:effectLst>
+        </p:spPr>
+      </p:sp>
+      <p:pic>
+        <p:nvPicPr>
+          <p:cNvPr id="90" name="Image 12" descr="C:\Claude\MCG Full Stack\generators\assets\icons\mcp.png">    </p:cNvPr>
+          <p:cNvPicPr>
+            <a:picLocks noChangeAspect="1"/>
+          </p:cNvPicPr>
+          <p:nvPr/>
+        </p:nvPicPr>
+        <p:blipFill>
+          <a:blip r:embed="rId13"/>
+          <a:stretch>
+            <a:fillRect/>
+          </a:stretch>
+        </p:blipFill>
+        <p:spPr>
+          <a:xfrm>
+            <a:off x="6764548" y="5356372"/>
+            <a:ext cx="351495" cy="351495"/>
+          </a:xfrm>
+          <a:prstGeom prst="rect">
+            <a:avLst/>
+          </a:prstGeom>
+        </p:spPr>
+      </p:pic>
+      <p:sp>
+        <p:nvSpPr>
+          <p:cNvPr id="91" name="Text 76"/>
+          <p:cNvSpPr/>
+          <p:nvPr/>
+        </p:nvSpPr>
+        <p:spPr>
+          <a:xfrm>
+            <a:off x="7351776" y="5148072"/>
+            <a:ext cx="1197864" cy="438912"/>
           </a:xfrm>
           <a:prstGeom prst="rect">
             <a:avLst/>
@@ -8884,7 +9536,7 @@
           <a:bodyPr wrap="square" rtlCol="0" anchor="b"/>
           <a:lstStyle/>
           <a:p>
-            <a:pPr algn="ctr" indent="0" marL="0">
+            <a:pPr algn="l" indent="0" marL="0">
               <a:buNone/>
             </a:pPr>
             <a:r>
@@ -8904,14 +9556,14 @@
       </p:sp>
       <p:sp>
         <p:nvSpPr>
-          <p:cNvPr id="68" name="Text 65"/>
-          <p:cNvSpPr/>
-          <p:nvPr/>
-        </p:nvSpPr>
-        <p:spPr>
-          <a:xfrm>
-            <a:off x="6611112" y="5550408"/>
-            <a:ext cx="1956816" cy="384048"/>
+          <p:cNvPr id="92" name="Text 77"/>
+          <p:cNvSpPr/>
+          <p:nvPr/>
+        </p:nvSpPr>
+        <p:spPr>
+          <a:xfrm>
+            <a:off x="7351776" y="5532120"/>
+            <a:ext cx="1197864" cy="402336"/>
           </a:xfrm>
           <a:prstGeom prst="rect">
             <a:avLst/>
@@ -8923,16 +9575,16 @@
           <a:bodyPr wrap="square" rtlCol="0" anchor="t"/>
           <a:lstStyle/>
           <a:p>
-            <a:pPr algn="ctr" indent="0" marL="0">
+            <a:pPr algn="l" indent="0" marL="0">
               <a:lnSpc>
-                <a:spcPct val="105000"/>
+                <a:spcPct val="102000"/>
               </a:lnSpc>
               <a:buNone/>
             </a:pPr>
             <a:r>
-              <a:rPr lang="en-US" sz="1000" dirty="0">
-                <a:solidFill>
-                  <a:srgbClr val="D0D4D7"/>
+              <a:rPr lang="en-US" sz="950" dirty="0">
+                <a:solidFill>
+                  <a:srgbClr val="D8DCE0"/>
                 </a:solidFill>
                 <a:latin typeface="Inter" pitchFamily="34" charset="0"/>
                 <a:ea typeface="Inter" pitchFamily="34" charset="-122"/>
@@ -8940,19 +9592,19 @@
               </a:rPr>
               <a:t>Claude integration</a:t>
             </a:r>
-            <a:endParaRPr lang="en-US" sz="1000" dirty="0"/>
-          </a:p>
-          <a:p>
-            <a:pPr algn="ctr" indent="0" marL="0">
+            <a:endParaRPr lang="en-US" sz="950" dirty="0"/>
+          </a:p>
+          <a:p>
+            <a:pPr algn="l" indent="0" marL="0">
               <a:lnSpc>
-                <a:spcPct val="105000"/>
+                <a:spcPct val="102000"/>
               </a:lnSpc>
               <a:buNone/>
             </a:pPr>
             <a:r>
-              <a:rPr lang="en-US" sz="1000" dirty="0">
-                <a:solidFill>
-                  <a:srgbClr val="D0D4D7"/>
+              <a:rPr lang="en-US" sz="950" dirty="0">
+                <a:solidFill>
+                  <a:srgbClr val="D8DCE0"/>
                 </a:solidFill>
                 <a:latin typeface="Inter" pitchFamily="34" charset="0"/>
                 <a:ea typeface="Inter" pitchFamily="34" charset="-122"/>
@@ -8960,13 +9612,13 @@
               </a:rPr>
               <a:t>Agentic queries</a:t>
             </a:r>
-            <a:endParaRPr lang="en-US" sz="1000" dirty="0"/>
-          </a:p>
-        </p:txBody>
-      </p:sp>
-      <p:sp>
-        <p:nvSpPr>
-          <p:cNvPr id="69" name="Shape 66"/>
+            <a:endParaRPr lang="en-US" sz="950" dirty="0"/>
+          </a:p>
+        </p:txBody>
+      </p:sp>
+      <p:sp>
+        <p:nvSpPr>
+          <p:cNvPr id="93" name="Shape 78"/>
           <p:cNvSpPr/>
           <p:nvPr/>
         </p:nvSpPr>
@@ -9000,14 +9652,70 @@
       </p:sp>
       <p:sp>
         <p:nvSpPr>
-          <p:cNvPr id="70" name="Text 67"/>
-          <p:cNvSpPr/>
-          <p:nvPr/>
-        </p:nvSpPr>
-        <p:spPr>
-          <a:xfrm>
-            <a:off x="8897112" y="5129784"/>
-            <a:ext cx="1911096" cy="457200"/>
+          <p:cNvPr id="94" name="Shape 79"/>
+          <p:cNvSpPr/>
+          <p:nvPr/>
+        </p:nvSpPr>
+        <p:spPr>
+          <a:xfrm>
+            <a:off x="8942832" y="5248656"/>
+            <a:ext cx="566928" cy="566928"/>
+          </a:xfrm>
+          <a:prstGeom prst="ellipse">
+            <a:avLst/>
+          </a:prstGeom>
+          <a:solidFill>
+            <a:srgbClr val="FFFFFF"/>
+          </a:solidFill>
+          <a:ln w="12700">
+            <a:solidFill>
+              <a:srgbClr val="FFFFFF"/>
+            </a:solidFill>
+            <a:prstDash val="solid"/>
+          </a:ln>
+          <a:effectLst>
+            <a:outerShdw sx="100000" sy="100000" kx="0" ky="0" algn="bl" rotWithShape="0" blurRad="38100" dist="12700" dir="16200000">
+              <a:srgbClr val="000000">
+                <a:alpha val="15000"/>
+              </a:srgbClr>
+            </a:outerShdw>
+          </a:effectLst>
+        </p:spPr>
+      </p:sp>
+      <p:pic>
+        <p:nvPicPr>
+          <p:cNvPr id="95" name="Image 13" descr="C:\Claude\MCG Full Stack\generators\assets\icons\automation.png">    </p:cNvPr>
+          <p:cNvPicPr>
+            <a:picLocks noChangeAspect="1"/>
+          </p:cNvPicPr>
+          <p:nvPr/>
+        </p:nvPicPr>
+        <p:blipFill>
+          <a:blip r:embed="rId14"/>
+          <a:stretch>
+            <a:fillRect/>
+          </a:stretch>
+        </p:blipFill>
+        <p:spPr>
+          <a:xfrm>
+            <a:off x="9050548" y="5356372"/>
+            <a:ext cx="351495" cy="351495"/>
+          </a:xfrm>
+          <a:prstGeom prst="rect">
+            <a:avLst/>
+          </a:prstGeom>
+        </p:spPr>
+      </p:pic>
+      <p:sp>
+        <p:nvSpPr>
+          <p:cNvPr id="96" name="Text 80"/>
+          <p:cNvSpPr/>
+          <p:nvPr/>
+        </p:nvSpPr>
+        <p:spPr>
+          <a:xfrm>
+            <a:off x="9637776" y="5148072"/>
+            <a:ext cx="1152144" cy="438912"/>
           </a:xfrm>
           <a:prstGeom prst="rect">
             <a:avLst/>
@@ -9019,7 +9727,7 @@
           <a:bodyPr wrap="square" rtlCol="0" anchor="b"/>
           <a:lstStyle/>
           <a:p>
-            <a:pPr algn="ctr" indent="0" marL="0">
+            <a:pPr algn="l" indent="0" marL="0">
               <a:buNone/>
             </a:pPr>
             <a:r>
@@ -9039,14 +9747,14 @@
       </p:sp>
       <p:sp>
         <p:nvSpPr>
-          <p:cNvPr id="71" name="Text 68"/>
-          <p:cNvSpPr/>
-          <p:nvPr/>
-        </p:nvSpPr>
-        <p:spPr>
-          <a:xfrm>
-            <a:off x="8897112" y="5550408"/>
-            <a:ext cx="1911096" cy="384048"/>
+          <p:cNvPr id="97" name="Text 81"/>
+          <p:cNvSpPr/>
+          <p:nvPr/>
+        </p:nvSpPr>
+        <p:spPr>
+          <a:xfrm>
+            <a:off x="9637776" y="5532120"/>
+            <a:ext cx="1152144" cy="402336"/>
           </a:xfrm>
           <a:prstGeom prst="rect">
             <a:avLst/>
@@ -9058,16 +9766,16 @@
           <a:bodyPr wrap="square" rtlCol="0" anchor="t"/>
           <a:lstStyle/>
           <a:p>
-            <a:pPr algn="ctr" indent="0" marL="0">
+            <a:pPr algn="l" indent="0" marL="0">
               <a:lnSpc>
-                <a:spcPct val="105000"/>
+                <a:spcPct val="102000"/>
               </a:lnSpc>
               <a:buNone/>
             </a:pPr>
             <a:r>
-              <a:rPr lang="en-US" sz="1000" dirty="0">
-                <a:solidFill>
-                  <a:srgbClr val="D0D4D7"/>
+              <a:rPr lang="en-US" sz="950" dirty="0">
+                <a:solidFill>
+                  <a:srgbClr val="D8DCE0"/>
                 </a:solidFill>
                 <a:latin typeface="Inter" pitchFamily="34" charset="0"/>
                 <a:ea typeface="Inter" pitchFamily="34" charset="-122"/>
@@ -9075,19 +9783,19 @@
               </a:rPr>
               <a:t>Teams alerts</a:t>
             </a:r>
-            <a:endParaRPr lang="en-US" sz="1000" dirty="0"/>
-          </a:p>
-          <a:p>
-            <a:pPr algn="ctr" indent="0" marL="0">
+            <a:endParaRPr lang="en-US" sz="950" dirty="0"/>
+          </a:p>
+          <a:p>
+            <a:pPr algn="l" indent="0" marL="0">
               <a:lnSpc>
-                <a:spcPct val="105000"/>
+                <a:spcPct val="102000"/>
               </a:lnSpc>
               <a:buNone/>
             </a:pPr>
             <a:r>
-              <a:rPr lang="en-US" sz="1000" dirty="0">
-                <a:solidFill>
-                  <a:srgbClr val="D0D4D7"/>
+              <a:rPr lang="en-US" sz="950" dirty="0">
+                <a:solidFill>
+                  <a:srgbClr val="D8DCE0"/>
                 </a:solidFill>
                 <a:latin typeface="Inter" pitchFamily="34" charset="0"/>
                 <a:ea typeface="Inter" pitchFamily="34" charset="-122"/>
@@ -9095,13 +9803,13 @@
               </a:rPr>
               <a:t>Talend jobs</a:t>
             </a:r>
-            <a:endParaRPr lang="en-US" sz="1000" dirty="0"/>
-          </a:p>
-        </p:txBody>
-      </p:sp>
-      <p:sp>
-        <p:nvSpPr>
-          <p:cNvPr id="72" name="Shape 69"/>
+            <a:endParaRPr lang="en-US" sz="950" dirty="0"/>
+          </a:p>
+        </p:txBody>
+      </p:sp>
+      <p:sp>
+        <p:nvSpPr>
+          <p:cNvPr id="98" name="Shape 82"/>
           <p:cNvSpPr/>
           <p:nvPr/>
         </p:nvSpPr>
@@ -9128,7 +9836,7 @@
       </p:sp>
       <p:sp>
         <p:nvSpPr>
-          <p:cNvPr id="73" name="Text 70"/>
+          <p:cNvPr id="99" name="Text 83"/>
           <p:cNvSpPr/>
           <p:nvPr/>
         </p:nvSpPr>
@@ -11307,14 +12015,70 @@
       </p:sp>
       <p:sp>
         <p:nvSpPr>
-          <p:cNvPr id="10" name="Text 7"/>
-          <p:cNvSpPr/>
-          <p:nvPr/>
-        </p:nvSpPr>
-        <p:spPr>
-          <a:xfrm>
-            <a:off x="621792" y="1837944"/>
-            <a:ext cx="2962656" cy="502920"/>
+          <p:cNvPr id="10" name="Shape 7"/>
+          <p:cNvSpPr/>
+          <p:nvPr/>
+        </p:nvSpPr>
+        <p:spPr>
+          <a:xfrm>
+            <a:off x="667512" y="2002536"/>
+            <a:ext cx="566928" cy="566928"/>
+          </a:xfrm>
+          <a:prstGeom prst="ellipse">
+            <a:avLst/>
+          </a:prstGeom>
+          <a:solidFill>
+            <a:srgbClr val="FFFFFF"/>
+          </a:solidFill>
+          <a:ln w="12700">
+            <a:solidFill>
+              <a:srgbClr val="FFFFFF"/>
+            </a:solidFill>
+            <a:prstDash val="solid"/>
+          </a:ln>
+          <a:effectLst>
+            <a:outerShdw sx="100000" sy="100000" kx="0" ky="0" algn="bl" rotWithShape="0" blurRad="38100" dist="12700" dir="16200000">
+              <a:srgbClr val="000000">
+                <a:alpha val="15000"/>
+              </a:srgbClr>
+            </a:outerShdw>
+          </a:effectLst>
+        </p:spPr>
+      </p:sp>
+      <p:pic>
+        <p:nvPicPr>
+          <p:cNvPr id="11" name="Image 1" descr="C:\Claude\MCG Full Stack\generators\assets\icons\database.png">    </p:cNvPr>
+          <p:cNvPicPr>
+            <a:picLocks noChangeAspect="1"/>
+          </p:cNvPicPr>
+          <p:nvPr/>
+        </p:nvPicPr>
+        <p:blipFill>
+          <a:blip r:embed="rId2"/>
+          <a:stretch>
+            <a:fillRect/>
+          </a:stretch>
+        </p:blipFill>
+        <p:spPr>
+          <a:xfrm>
+            <a:off x="775228" y="2110252"/>
+            <a:ext cx="351495" cy="351495"/>
+          </a:xfrm>
+          <a:prstGeom prst="rect">
+            <a:avLst/>
+          </a:prstGeom>
+        </p:spPr>
+      </p:pic>
+      <p:sp>
+        <p:nvSpPr>
+          <p:cNvPr id="12" name="Text 8"/>
+          <p:cNvSpPr/>
+          <p:nvPr/>
+        </p:nvSpPr>
+        <p:spPr>
+          <a:xfrm>
+            <a:off x="1362456" y="1856232"/>
+            <a:ext cx="2203704" cy="484632"/>
           </a:xfrm>
           <a:prstGeom prst="rect">
             <a:avLst/>
@@ -11326,7 +12090,7 @@
           <a:bodyPr wrap="square" rtlCol="0" anchor="b"/>
           <a:lstStyle/>
           <a:p>
-            <a:pPr algn="ctr" indent="0" marL="0">
+            <a:pPr algn="l" indent="0" marL="0">
               <a:buNone/>
             </a:pPr>
             <a:r>
@@ -11346,14 +12110,14 @@
       </p:sp>
       <p:sp>
         <p:nvSpPr>
-          <p:cNvPr id="11" name="Text 8"/>
-          <p:cNvSpPr/>
-          <p:nvPr/>
-        </p:nvSpPr>
-        <p:spPr>
-          <a:xfrm>
-            <a:off x="621792" y="2304288"/>
-            <a:ext cx="2962656" cy="422453"/>
+          <p:cNvPr id="13" name="Text 9"/>
+          <p:cNvSpPr/>
+          <p:nvPr/>
+        </p:nvSpPr>
+        <p:spPr>
+          <a:xfrm>
+            <a:off x="1362456" y="2286000"/>
+            <a:ext cx="2203704" cy="448056"/>
           </a:xfrm>
           <a:prstGeom prst="rect">
             <a:avLst/>
@@ -11365,16 +12129,16 @@
           <a:bodyPr wrap="square" rtlCol="0" anchor="t"/>
           <a:lstStyle/>
           <a:p>
-            <a:pPr algn="ctr" indent="0" marL="0">
+            <a:pPr algn="l" indent="0" marL="0">
               <a:lnSpc>
-                <a:spcPct val="105000"/>
+                <a:spcPct val="102000"/>
               </a:lnSpc>
               <a:buNone/>
             </a:pPr>
             <a:r>
-              <a:rPr lang="en-US" sz="1000" dirty="0">
-                <a:solidFill>
-                  <a:srgbClr val="D0D4D7"/>
+              <a:rPr lang="en-US" sz="950" dirty="0">
+                <a:solidFill>
+                  <a:srgbClr val="D8DCE0"/>
                 </a:solidFill>
                 <a:latin typeface="Inter" pitchFamily="34" charset="0"/>
                 <a:ea typeface="Inter" pitchFamily="34" charset="-122"/>
@@ -11382,19 +12146,19 @@
               </a:rPr>
               <a:t>PostgreSQL • MySQL • SQL Server</a:t>
             </a:r>
-            <a:endParaRPr lang="en-US" sz="1000" dirty="0"/>
-          </a:p>
-          <a:p>
-            <a:pPr algn="ctr" indent="0" marL="0">
+            <a:endParaRPr lang="en-US" sz="950" dirty="0"/>
+          </a:p>
+          <a:p>
+            <a:pPr algn="l" indent="0" marL="0">
               <a:lnSpc>
-                <a:spcPct val="105000"/>
+                <a:spcPct val="102000"/>
               </a:lnSpc>
               <a:buNone/>
             </a:pPr>
             <a:r>
-              <a:rPr lang="en-US" sz="1000" dirty="0">
-                <a:solidFill>
-                  <a:srgbClr val="D0D4D7"/>
+              <a:rPr lang="en-US" sz="950" dirty="0">
+                <a:solidFill>
+                  <a:srgbClr val="D8DCE0"/>
                 </a:solidFill>
                 <a:latin typeface="Inter" pitchFamily="34" charset="0"/>
                 <a:ea typeface="Inter" pitchFamily="34" charset="-122"/>
@@ -11402,13 +12166,13 @@
               </a:rPr>
               <a:t>(mcg-qlik-dmg container)</a:t>
             </a:r>
-            <a:endParaRPr lang="en-US" sz="1000" dirty="0"/>
-          </a:p>
-        </p:txBody>
-      </p:sp>
-      <p:sp>
-        <p:nvSpPr>
-          <p:cNvPr id="12" name="Shape 9"/>
+            <a:endParaRPr lang="en-US" sz="950" dirty="0"/>
+          </a:p>
+        </p:txBody>
+      </p:sp>
+      <p:sp>
+        <p:nvSpPr>
+          <p:cNvPr id="14" name="Shape 10"/>
           <p:cNvSpPr/>
           <p:nvPr/>
         </p:nvSpPr>
@@ -11442,14 +12206,70 @@
       </p:sp>
       <p:sp>
         <p:nvSpPr>
-          <p:cNvPr id="13" name="Text 10"/>
-          <p:cNvSpPr/>
-          <p:nvPr/>
-        </p:nvSpPr>
-        <p:spPr>
-          <a:xfrm>
-            <a:off x="4645152" y="1837944"/>
-            <a:ext cx="2962656" cy="502920"/>
+          <p:cNvPr id="15" name="Shape 11"/>
+          <p:cNvSpPr/>
+          <p:nvPr/>
+        </p:nvSpPr>
+        <p:spPr>
+          <a:xfrm>
+            <a:off x="4690872" y="2002536"/>
+            <a:ext cx="566928" cy="566928"/>
+          </a:xfrm>
+          <a:prstGeom prst="ellipse">
+            <a:avLst/>
+          </a:prstGeom>
+          <a:solidFill>
+            <a:srgbClr val="FFFFFF"/>
+          </a:solidFill>
+          <a:ln w="12700">
+            <a:solidFill>
+              <a:srgbClr val="FFFFFF"/>
+            </a:solidFill>
+            <a:prstDash val="solid"/>
+          </a:ln>
+          <a:effectLst>
+            <a:outerShdw sx="100000" sy="100000" kx="0" ky="0" algn="bl" rotWithShape="0" blurRad="38100" dist="12700" dir="16200000">
+              <a:srgbClr val="000000">
+                <a:alpha val="15000"/>
+              </a:srgbClr>
+            </a:outerShdw>
+          </a:effectLst>
+        </p:spPr>
+      </p:sp>
+      <p:pic>
+        <p:nvPicPr>
+          <p:cNvPr id="16" name="Image 2" descr="C:\Claude\MCG Full Stack\generators\assets\icons\gateway.png">    </p:cNvPr>
+          <p:cNvPicPr>
+            <a:picLocks noChangeAspect="1"/>
+          </p:cNvPicPr>
+          <p:nvPr/>
+        </p:nvPicPr>
+        <p:blipFill>
+          <a:blip r:embed="rId3"/>
+          <a:stretch>
+            <a:fillRect/>
+          </a:stretch>
+        </p:blipFill>
+        <p:spPr>
+          <a:xfrm>
+            <a:off x="4798588" y="2110252"/>
+            <a:ext cx="351495" cy="351495"/>
+          </a:xfrm>
+          <a:prstGeom prst="rect">
+            <a:avLst/>
+          </a:prstGeom>
+        </p:spPr>
+      </p:pic>
+      <p:sp>
+        <p:nvSpPr>
+          <p:cNvPr id="17" name="Text 12"/>
+          <p:cNvSpPr/>
+          <p:nvPr/>
+        </p:nvSpPr>
+        <p:spPr>
+          <a:xfrm>
+            <a:off x="5385816" y="1856232"/>
+            <a:ext cx="2203704" cy="484632"/>
           </a:xfrm>
           <a:prstGeom prst="rect">
             <a:avLst/>
@@ -11461,7 +12281,7 @@
           <a:bodyPr wrap="square" rtlCol="0" anchor="b"/>
           <a:lstStyle/>
           <a:p>
-            <a:pPr algn="ctr" indent="0" marL="0">
+            <a:pPr algn="l" indent="0" marL="0">
               <a:buNone/>
             </a:pPr>
             <a:r>
@@ -11481,14 +12301,14 @@
       </p:sp>
       <p:sp>
         <p:nvSpPr>
-          <p:cNvPr id="14" name="Text 11"/>
-          <p:cNvSpPr/>
-          <p:nvPr/>
-        </p:nvSpPr>
-        <p:spPr>
-          <a:xfrm>
-            <a:off x="4645152" y="2304288"/>
-            <a:ext cx="2962656" cy="422453"/>
+          <p:cNvPr id="18" name="Text 13"/>
+          <p:cNvSpPr/>
+          <p:nvPr/>
+        </p:nvSpPr>
+        <p:spPr>
+          <a:xfrm>
+            <a:off x="5385816" y="2286000"/>
+            <a:ext cx="2203704" cy="448056"/>
           </a:xfrm>
           <a:prstGeom prst="rect">
             <a:avLst/>
@@ -11500,16 +12320,16 @@
           <a:bodyPr wrap="square" rtlCol="0" anchor="t"/>
           <a:lstStyle/>
           <a:p>
-            <a:pPr algn="ctr" indent="0" marL="0">
+            <a:pPr algn="l" indent="0" marL="0">
               <a:lnSpc>
-                <a:spcPct val="105000"/>
+                <a:spcPct val="102000"/>
               </a:lnSpc>
               <a:buNone/>
             </a:pPr>
             <a:r>
-              <a:rPr lang="en-US" sz="1000" dirty="0">
-                <a:solidFill>
-                  <a:srgbClr val="D0D4D7"/>
+              <a:rPr lang="en-US" sz="950" dirty="0">
+                <a:solidFill>
+                  <a:srgbClr val="D8DCE0"/>
                 </a:solidFill>
                 <a:latin typeface="Inter" pitchFamily="34" charset="0"/>
                 <a:ea typeface="Inter" pitchFamily="34" charset="-122"/>
@@ -11517,19 +12337,19 @@
               </a:rPr>
               <a:t>Registered to tenant</a:t>
             </a:r>
-            <a:endParaRPr lang="en-US" sz="1000" dirty="0"/>
-          </a:p>
-          <a:p>
-            <a:pPr algn="ctr" indent="0" marL="0">
+            <a:endParaRPr lang="en-US" sz="950" dirty="0"/>
+          </a:p>
+          <a:p>
+            <a:pPr algn="l" indent="0" marL="0">
               <a:lnSpc>
-                <a:spcPct val="105000"/>
+                <a:spcPct val="102000"/>
               </a:lnSpc>
               <a:buNone/>
             </a:pPr>
             <a:r>
-              <a:rPr lang="en-US" sz="1000" dirty="0">
-                <a:solidFill>
-                  <a:srgbClr val="D0D4D7"/>
+              <a:rPr lang="en-US" sz="950" dirty="0">
+                <a:solidFill>
+                  <a:srgbClr val="D8DCE0"/>
                 </a:solidFill>
                 <a:latin typeface="Inter" pitchFamily="34" charset="0"/>
                 <a:ea typeface="Inter" pitchFamily="34" charset="-122"/>
@@ -11537,13 +12357,13 @@
               </a:rPr>
               <a:t>Outbound HTTPS 443</a:t>
             </a:r>
-            <a:endParaRPr lang="en-US" sz="1000" dirty="0"/>
-          </a:p>
-        </p:txBody>
-      </p:sp>
-      <p:sp>
-        <p:nvSpPr>
-          <p:cNvPr id="15" name="Shape 12"/>
+            <a:endParaRPr lang="en-US" sz="950" dirty="0"/>
+          </a:p>
+        </p:txBody>
+      </p:sp>
+      <p:sp>
+        <p:nvSpPr>
+          <p:cNvPr id="19" name="Shape 14"/>
           <p:cNvSpPr/>
           <p:nvPr/>
         </p:nvSpPr>
@@ -11577,14 +12397,70 @@
       </p:sp>
       <p:sp>
         <p:nvSpPr>
-          <p:cNvPr id="16" name="Text 13"/>
-          <p:cNvSpPr/>
-          <p:nvPr/>
-        </p:nvSpPr>
-        <p:spPr>
-          <a:xfrm>
-            <a:off x="8668512" y="1837944"/>
-            <a:ext cx="2871216" cy="502920"/>
+          <p:cNvPr id="20" name="Shape 15"/>
+          <p:cNvSpPr/>
+          <p:nvPr/>
+        </p:nvSpPr>
+        <p:spPr>
+          <a:xfrm>
+            <a:off x="8714232" y="2002536"/>
+            <a:ext cx="566928" cy="566928"/>
+          </a:xfrm>
+          <a:prstGeom prst="ellipse">
+            <a:avLst/>
+          </a:prstGeom>
+          <a:solidFill>
+            <a:srgbClr val="FFFFFF"/>
+          </a:solidFill>
+          <a:ln w="12700">
+            <a:solidFill>
+              <a:srgbClr val="FFFFFF"/>
+            </a:solidFill>
+            <a:prstDash val="solid"/>
+          </a:ln>
+          <a:effectLst>
+            <a:outerShdw sx="100000" sy="100000" kx="0" ky="0" algn="bl" rotWithShape="0" blurRad="38100" dist="12700" dir="16200000">
+              <a:srgbClr val="000000">
+                <a:alpha val="15000"/>
+              </a:srgbClr>
+            </a:outerShdw>
+          </a:effectLst>
+        </p:spPr>
+      </p:sp>
+      <p:pic>
+        <p:nvPicPr>
+          <p:cNvPr id="21" name="Image 3" descr="C:\Claude\MCG Full Stack\generators\assets\icons\cloud.png">    </p:cNvPr>
+          <p:cNvPicPr>
+            <a:picLocks noChangeAspect="1"/>
+          </p:cNvPicPr>
+          <p:nvPr/>
+        </p:nvPicPr>
+        <p:blipFill>
+          <a:blip r:embed="rId4"/>
+          <a:stretch>
+            <a:fillRect/>
+          </a:stretch>
+        </p:blipFill>
+        <p:spPr>
+          <a:xfrm>
+            <a:off x="8821948" y="2110252"/>
+            <a:ext cx="351495" cy="351495"/>
+          </a:xfrm>
+          <a:prstGeom prst="rect">
+            <a:avLst/>
+          </a:prstGeom>
+        </p:spPr>
+      </p:pic>
+      <p:sp>
+        <p:nvSpPr>
+          <p:cNvPr id="22" name="Text 16"/>
+          <p:cNvSpPr/>
+          <p:nvPr/>
+        </p:nvSpPr>
+        <p:spPr>
+          <a:xfrm>
+            <a:off x="9409176" y="1856232"/>
+            <a:ext cx="2112264" cy="484632"/>
           </a:xfrm>
           <a:prstGeom prst="rect">
             <a:avLst/>
@@ -11596,7 +12472,7 @@
           <a:bodyPr wrap="square" rtlCol="0" anchor="b"/>
           <a:lstStyle/>
           <a:p>
-            <a:pPr algn="ctr" indent="0" marL="0">
+            <a:pPr algn="l" indent="0" marL="0">
               <a:buNone/>
             </a:pPr>
             <a:r>
@@ -11616,14 +12492,14 @@
       </p:sp>
       <p:sp>
         <p:nvSpPr>
-          <p:cNvPr id="17" name="Text 14"/>
-          <p:cNvSpPr/>
-          <p:nvPr/>
-        </p:nvSpPr>
-        <p:spPr>
-          <a:xfrm>
-            <a:off x="8668512" y="2304288"/>
-            <a:ext cx="2871216" cy="422453"/>
+          <p:cNvPr id="23" name="Text 17"/>
+          <p:cNvSpPr/>
+          <p:nvPr/>
+        </p:nvSpPr>
+        <p:spPr>
+          <a:xfrm>
+            <a:off x="9409176" y="2286000"/>
+            <a:ext cx="2112264" cy="448056"/>
           </a:xfrm>
           <a:prstGeom prst="rect">
             <a:avLst/>
@@ -11635,16 +12511,16 @@
           <a:bodyPr wrap="square" rtlCol="0" anchor="t"/>
           <a:lstStyle/>
           <a:p>
-            <a:pPr algn="ctr" indent="0" marL="0">
+            <a:pPr algn="l" indent="0" marL="0">
               <a:lnSpc>
-                <a:spcPct val="105000"/>
+                <a:spcPct val="102000"/>
               </a:lnSpc>
               <a:buNone/>
             </a:pPr>
             <a:r>
-              <a:rPr lang="en-US" sz="1000" dirty="0">
-                <a:solidFill>
-                  <a:srgbClr val="D0D4D7"/>
+              <a:rPr lang="en-US" sz="950" dirty="0">
+                <a:solidFill>
+                  <a:srgbClr val="D8DCE0"/>
                 </a:solidFill>
                 <a:latin typeface="Inter" pitchFamily="34" charset="0"/>
                 <a:ea typeface="Inter" pitchFamily="34" charset="-122"/>
@@ -11652,19 +12528,19 @@
               </a:rPr>
               <a:t>Data Integration project</a:t>
             </a:r>
-            <a:endParaRPr lang="en-US" sz="1000" dirty="0"/>
-          </a:p>
-          <a:p>
-            <a:pPr algn="ctr" indent="0" marL="0">
+            <a:endParaRPr lang="en-US" sz="950" dirty="0"/>
+          </a:p>
+          <a:p>
+            <a:pPr algn="l" indent="0" marL="0">
               <a:lnSpc>
-                <a:spcPct val="105000"/>
+                <a:spcPct val="102000"/>
               </a:lnSpc>
               <a:buNone/>
             </a:pPr>
             <a:r>
-              <a:rPr lang="en-US" sz="1000" dirty="0">
-                <a:solidFill>
-                  <a:srgbClr val="D0D4D7"/>
+              <a:rPr lang="en-US" sz="950" dirty="0">
+                <a:solidFill>
+                  <a:srgbClr val="D8DCE0"/>
                 </a:solidFill>
                 <a:latin typeface="Inter" pitchFamily="34" charset="0"/>
                 <a:ea typeface="Inter" pitchFamily="34" charset="-122"/>
@@ -11672,13 +12548,13 @@
               </a:rPr>
               <a:t>CDC → Open Lakehouse</a:t>
             </a:r>
-            <a:endParaRPr lang="en-US" sz="1000" dirty="0"/>
-          </a:p>
-        </p:txBody>
-      </p:sp>
-      <p:sp>
-        <p:nvSpPr>
-          <p:cNvPr id="18" name="Shape 15"/>
+            <a:endParaRPr lang="en-US" sz="950" dirty="0"/>
+          </a:p>
+        </p:txBody>
+      </p:sp>
+      <p:sp>
+        <p:nvSpPr>
+          <p:cNvPr id="24" name="Shape 18"/>
           <p:cNvSpPr/>
           <p:nvPr/>
         </p:nvSpPr>
@@ -11702,7 +12578,7 @@
       </p:sp>
       <p:sp>
         <p:nvSpPr>
-          <p:cNvPr id="19" name="Shape 16"/>
+          <p:cNvPr id="25" name="Shape 19"/>
           <p:cNvSpPr/>
           <p:nvPr/>
         </p:nvSpPr>
@@ -11726,7 +12602,7 @@
       </p:sp>
       <p:sp>
         <p:nvSpPr>
-          <p:cNvPr id="20" name="Text 17"/>
+          <p:cNvPr id="26" name="Text 20"/>
           <p:cNvSpPr/>
           <p:nvPr/>
         </p:nvSpPr>
@@ -11765,7 +12641,7 @@
       </p:sp>
       <p:sp>
         <p:nvSpPr>
-          <p:cNvPr id="21" name="Text 18"/>
+          <p:cNvPr id="27" name="Text 21"/>
           <p:cNvSpPr/>
           <p:nvPr/>
         </p:nvSpPr>
@@ -11804,7 +12680,7 @@
       </p:sp>
       <p:sp>
         <p:nvSpPr>
-          <p:cNvPr id="22" name="Text 19"/>
+          <p:cNvPr id="28" name="Text 22"/>
           <p:cNvSpPr/>
           <p:nvPr/>
         </p:nvSpPr>
@@ -11843,7 +12719,7 @@
       </p:sp>
       <p:sp>
         <p:nvSpPr>
-          <p:cNvPr id="23" name="Text 20"/>
+          <p:cNvPr id="29" name="Text 23"/>
           <p:cNvSpPr/>
           <p:nvPr/>
         </p:nvSpPr>
@@ -11882,7 +12758,7 @@
       </p:sp>
       <p:sp>
         <p:nvSpPr>
-          <p:cNvPr id="24" name="Text 21"/>
+          <p:cNvPr id="30" name="Text 24"/>
           <p:cNvSpPr/>
           <p:nvPr/>
         </p:nvSpPr>
@@ -11921,7 +12797,7 @@
       </p:sp>
       <p:sp>
         <p:nvSpPr>
-          <p:cNvPr id="25" name="Text 22"/>
+          <p:cNvPr id="31" name="Text 25"/>
           <p:cNvSpPr/>
           <p:nvPr/>
         </p:nvSpPr>
@@ -11960,7 +12836,7 @@
       </p:sp>
       <p:sp>
         <p:nvSpPr>
-          <p:cNvPr id="26" name="Text 23"/>
+          <p:cNvPr id="32" name="Text 26"/>
           <p:cNvSpPr/>
           <p:nvPr/>
         </p:nvSpPr>
@@ -11999,7 +12875,7 @@
       </p:sp>
       <p:sp>
         <p:nvSpPr>
-          <p:cNvPr id="27" name="Text 24"/>
+          <p:cNvPr id="33" name="Text 27"/>
           <p:cNvSpPr/>
           <p:nvPr/>
         </p:nvSpPr>
@@ -12038,7 +12914,7 @@
       </p:sp>
       <p:sp>
         <p:nvSpPr>
-          <p:cNvPr id="28" name="Shape 25"/>
+          <p:cNvPr id="34" name="Shape 28"/>
           <p:cNvSpPr/>
           <p:nvPr/>
         </p:nvSpPr>
@@ -12065,7 +12941,7 @@
       </p:sp>
       <p:sp>
         <p:nvSpPr>
-          <p:cNvPr id="29" name="Text 26"/>
+          <p:cNvPr id="35" name="Text 29"/>
           <p:cNvSpPr/>
           <p:nvPr/>
         </p:nvSpPr>
@@ -16704,7 +17580,63 @@
       </p:sp>
       <p:sp>
         <p:nvSpPr>
-          <p:cNvPr id="9" name="Text 6"/>
+          <p:cNvPr id="9" name="Shape 6"/>
+          <p:cNvSpPr/>
+          <p:nvPr/>
+        </p:nvSpPr>
+        <p:spPr>
+          <a:xfrm>
+            <a:off x="621792" y="1033272"/>
+            <a:ext cx="329184" cy="329184"/>
+          </a:xfrm>
+          <a:prstGeom prst="ellipse">
+            <a:avLst/>
+          </a:prstGeom>
+          <a:solidFill>
+            <a:srgbClr val="FFFFFF"/>
+          </a:solidFill>
+          <a:ln w="12700">
+            <a:solidFill>
+              <a:srgbClr val="19416C"/>
+            </a:solidFill>
+            <a:prstDash val="solid"/>
+          </a:ln>
+          <a:effectLst>
+            <a:outerShdw sx="100000" sy="100000" kx="0" ky="0" algn="bl" rotWithShape="0" blurRad="38100" dist="12700" dir="16200000">
+              <a:srgbClr val="000000">
+                <a:alpha val="15000"/>
+              </a:srgbClr>
+            </a:outerShdw>
+          </a:effectLst>
+        </p:spPr>
+      </p:sp>
+      <p:pic>
+        <p:nvPicPr>
+          <p:cNvPr id="10" name="Image 1" descr="C:\Claude\MCG Full Stack\generators\assets\icons\analytics.png">    </p:cNvPr>
+          <p:cNvPicPr>
+            <a:picLocks noChangeAspect="1"/>
+          </p:cNvPicPr>
+          <p:nvPr/>
+        </p:nvPicPr>
+        <p:blipFill>
+          <a:blip r:embed="rId2"/>
+          <a:stretch>
+            <a:fillRect/>
+          </a:stretch>
+        </p:blipFill>
+        <p:spPr>
+          <a:xfrm>
+            <a:off x="684337" y="1095817"/>
+            <a:ext cx="204094" cy="204094"/>
+          </a:xfrm>
+          <a:prstGeom prst="rect">
+            <a:avLst/>
+          </a:prstGeom>
+        </p:spPr>
+      </p:pic>
+      <p:sp>
+        <p:nvSpPr>
+          <p:cNvPr id="11" name="Text 7"/>
           <p:cNvSpPr/>
           <p:nvPr/>
         </p:nvSpPr>
@@ -16743,7 +17675,7 @@
       </p:sp>
       <p:sp>
         <p:nvSpPr>
-          <p:cNvPr id="10" name="Shape 7"/>
+          <p:cNvPr id="12" name="Shape 8"/>
           <p:cNvSpPr/>
           <p:nvPr/>
         </p:nvSpPr>
@@ -16777,7 +17709,7 @@
       </p:sp>
       <p:sp>
         <p:nvSpPr>
-          <p:cNvPr id="11" name="Text 8"/>
+          <p:cNvPr id="13" name="Text 9"/>
           <p:cNvSpPr/>
           <p:nvPr/>
         </p:nvSpPr>
@@ -16816,7 +17748,7 @@
       </p:sp>
       <p:sp>
         <p:nvSpPr>
-          <p:cNvPr id="12" name="Text 9"/>
+          <p:cNvPr id="14" name="Text 10"/>
           <p:cNvSpPr/>
           <p:nvPr/>
         </p:nvSpPr>
@@ -16878,7 +17810,7 @@
       </p:sp>
       <p:sp>
         <p:nvSpPr>
-          <p:cNvPr id="13" name="Shape 10"/>
+          <p:cNvPr id="15" name="Shape 11"/>
           <p:cNvSpPr/>
           <p:nvPr/>
         </p:nvSpPr>
@@ -16912,7 +17844,7 @@
       </p:sp>
       <p:sp>
         <p:nvSpPr>
-          <p:cNvPr id="14" name="Text 11"/>
+          <p:cNvPr id="16" name="Text 12"/>
           <p:cNvSpPr/>
           <p:nvPr/>
         </p:nvSpPr>
@@ -16951,7 +17883,7 @@
       </p:sp>
       <p:sp>
         <p:nvSpPr>
-          <p:cNvPr id="15" name="Text 12"/>
+          <p:cNvPr id="17" name="Text 13"/>
           <p:cNvSpPr/>
           <p:nvPr/>
         </p:nvSpPr>
@@ -17013,7 +17945,7 @@
       </p:sp>
       <p:sp>
         <p:nvSpPr>
-          <p:cNvPr id="16" name="Text 13"/>
+          <p:cNvPr id="18" name="Text 14"/>
           <p:cNvSpPr/>
           <p:nvPr/>
         </p:nvSpPr>
@@ -17052,7 +17984,7 @@
       </p:sp>
       <p:sp>
         <p:nvSpPr>
-          <p:cNvPr id="17" name="Shape 14"/>
+          <p:cNvPr id="19" name="Shape 15"/>
           <p:cNvSpPr/>
           <p:nvPr/>
         </p:nvSpPr>
@@ -17079,7 +18011,63 @@
       </p:sp>
       <p:sp>
         <p:nvSpPr>
-          <p:cNvPr id="18" name="Text 15"/>
+          <p:cNvPr id="20" name="Shape 16"/>
+          <p:cNvSpPr/>
+          <p:nvPr/>
+        </p:nvSpPr>
+        <p:spPr>
+          <a:xfrm>
+            <a:off x="6428232" y="1033272"/>
+            <a:ext cx="329184" cy="329184"/>
+          </a:xfrm>
+          <a:prstGeom prst="ellipse">
+            <a:avLst/>
+          </a:prstGeom>
+          <a:solidFill>
+            <a:srgbClr val="FFFFFF"/>
+          </a:solidFill>
+          <a:ln w="12700">
+            <a:solidFill>
+              <a:srgbClr val="006580"/>
+            </a:solidFill>
+            <a:prstDash val="solid"/>
+          </a:ln>
+          <a:effectLst>
+            <a:outerShdw sx="100000" sy="100000" kx="0" ky="0" algn="bl" rotWithShape="0" blurRad="38100" dist="12700" dir="16200000">
+              <a:srgbClr val="000000">
+                <a:alpha val="15000"/>
+              </a:srgbClr>
+            </a:outerShdw>
+          </a:effectLst>
+        </p:spPr>
+      </p:sp>
+      <p:pic>
+        <p:nvPicPr>
+          <p:cNvPr id="21" name="Image 2" descr="C:\Claude\MCG Full Stack\generators\assets\icons\predict.png">    </p:cNvPr>
+          <p:cNvPicPr>
+            <a:picLocks noChangeAspect="1"/>
+          </p:cNvPicPr>
+          <p:nvPr/>
+        </p:nvPicPr>
+        <p:blipFill>
+          <a:blip r:embed="rId3"/>
+          <a:stretch>
+            <a:fillRect/>
+          </a:stretch>
+        </p:blipFill>
+        <p:spPr>
+          <a:xfrm>
+            <a:off x="6490777" y="1095817"/>
+            <a:ext cx="204094" cy="204094"/>
+          </a:xfrm>
+          <a:prstGeom prst="rect">
+            <a:avLst/>
+          </a:prstGeom>
+        </p:spPr>
+      </p:pic>
+      <p:sp>
+        <p:nvSpPr>
+          <p:cNvPr id="22" name="Text 17"/>
           <p:cNvSpPr/>
           <p:nvPr/>
         </p:nvSpPr>
@@ -17118,7 +18106,7 @@
       </p:sp>
       <p:sp>
         <p:nvSpPr>
-          <p:cNvPr id="19" name="Shape 16"/>
+          <p:cNvPr id="23" name="Shape 18"/>
           <p:cNvSpPr/>
           <p:nvPr/>
         </p:nvSpPr>
@@ -17152,7 +18140,7 @@
       </p:sp>
       <p:sp>
         <p:nvSpPr>
-          <p:cNvPr id="20" name="Text 17"/>
+          <p:cNvPr id="24" name="Text 19"/>
           <p:cNvSpPr/>
           <p:nvPr/>
         </p:nvSpPr>
@@ -17191,7 +18179,7 @@
       </p:sp>
       <p:sp>
         <p:nvSpPr>
-          <p:cNvPr id="21" name="Text 18"/>
+          <p:cNvPr id="25" name="Text 20"/>
           <p:cNvSpPr/>
           <p:nvPr/>
         </p:nvSpPr>
@@ -17253,7 +18241,7 @@
       </p:sp>
       <p:sp>
         <p:nvSpPr>
-          <p:cNvPr id="22" name="Shape 19"/>
+          <p:cNvPr id="26" name="Shape 21"/>
           <p:cNvSpPr/>
           <p:nvPr/>
         </p:nvSpPr>
@@ -17287,7 +18275,7 @@
       </p:sp>
       <p:sp>
         <p:nvSpPr>
-          <p:cNvPr id="23" name="Text 20"/>
+          <p:cNvPr id="27" name="Text 22"/>
           <p:cNvSpPr/>
           <p:nvPr/>
         </p:nvSpPr>
@@ -17326,7 +18314,7 @@
       </p:sp>
       <p:sp>
         <p:nvSpPr>
-          <p:cNvPr id="24" name="Text 21"/>
+          <p:cNvPr id="28" name="Text 23"/>
           <p:cNvSpPr/>
           <p:nvPr/>
         </p:nvSpPr>
@@ -17388,7 +18376,7 @@
       </p:sp>
       <p:sp>
         <p:nvSpPr>
-          <p:cNvPr id="25" name="Text 22"/>
+          <p:cNvPr id="29" name="Text 24"/>
           <p:cNvSpPr/>
           <p:nvPr/>
         </p:nvSpPr>
@@ -17427,7 +18415,7 @@
       </p:sp>
       <p:sp>
         <p:nvSpPr>
-          <p:cNvPr id="26" name="Shape 23"/>
+          <p:cNvPr id="30" name="Shape 25"/>
           <p:cNvSpPr/>
           <p:nvPr/>
         </p:nvSpPr>
@@ -17454,7 +18442,63 @@
       </p:sp>
       <p:sp>
         <p:nvSpPr>
-          <p:cNvPr id="27" name="Text 24"/>
+          <p:cNvPr id="31" name="Shape 26"/>
+          <p:cNvSpPr/>
+          <p:nvPr/>
+        </p:nvSpPr>
+        <p:spPr>
+          <a:xfrm>
+            <a:off x="621792" y="3712464"/>
+            <a:ext cx="329184" cy="329184"/>
+          </a:xfrm>
+          <a:prstGeom prst="ellipse">
+            <a:avLst/>
+          </a:prstGeom>
+          <a:solidFill>
+            <a:srgbClr val="FFFFFF"/>
+          </a:solidFill>
+          <a:ln w="12700">
+            <a:solidFill>
+              <a:srgbClr val="4CB393"/>
+            </a:solidFill>
+            <a:prstDash val="solid"/>
+          </a:ln>
+          <a:effectLst>
+            <a:outerShdw sx="100000" sy="100000" kx="0" ky="0" algn="bl" rotWithShape="0" blurRad="38100" dist="12700" dir="16200000">
+              <a:srgbClr val="000000">
+                <a:alpha val="15000"/>
+              </a:srgbClr>
+            </a:outerShdw>
+          </a:effectLst>
+        </p:spPr>
+      </p:sp>
+      <p:pic>
+        <p:nvPicPr>
+          <p:cNvPr id="32" name="Image 3" descr="C:\Claude\MCG Full Stack\generators\assets\icons\agent.png">    </p:cNvPr>
+          <p:cNvPicPr>
+            <a:picLocks noChangeAspect="1"/>
+          </p:cNvPicPr>
+          <p:nvPr/>
+        </p:nvPicPr>
+        <p:blipFill>
+          <a:blip r:embed="rId4"/>
+          <a:stretch>
+            <a:fillRect/>
+          </a:stretch>
+        </p:blipFill>
+        <p:spPr>
+          <a:xfrm>
+            <a:off x="684337" y="3775009"/>
+            <a:ext cx="204094" cy="204094"/>
+          </a:xfrm>
+          <a:prstGeom prst="rect">
+            <a:avLst/>
+          </a:prstGeom>
+        </p:spPr>
+      </p:pic>
+      <p:sp>
+        <p:nvSpPr>
+          <p:cNvPr id="33" name="Text 27"/>
           <p:cNvSpPr/>
           <p:nvPr/>
         </p:nvSpPr>
@@ -17493,7 +18537,7 @@
       </p:sp>
       <p:sp>
         <p:nvSpPr>
-          <p:cNvPr id="28" name="Shape 25"/>
+          <p:cNvPr id="34" name="Shape 28"/>
           <p:cNvSpPr/>
           <p:nvPr/>
         </p:nvSpPr>
@@ -17527,30 +18571,86 @@
       </p:sp>
       <p:sp>
         <p:nvSpPr>
-          <p:cNvPr id="29" name="Text 26"/>
-          <p:cNvSpPr/>
-          <p:nvPr/>
-        </p:nvSpPr>
-        <p:spPr>
-          <a:xfrm>
-            <a:off x="758952" y="4261104"/>
-            <a:ext cx="2231136" cy="868680"/>
-          </a:xfrm>
-          <a:prstGeom prst="rect">
-            <a:avLst/>
-          </a:prstGeom>
-          <a:noFill/>
-          <a:ln/>
-        </p:spPr>
-        <p:txBody>
-          <a:bodyPr wrap="square" rtlCol="0" anchor="b"/>
+          <p:cNvPr id="35" name="Shape 29"/>
+          <p:cNvSpPr/>
+          <p:nvPr/>
+        </p:nvSpPr>
+        <p:spPr>
+          <a:xfrm>
+            <a:off x="1600200" y="4352544"/>
+            <a:ext cx="548640" cy="548640"/>
+          </a:xfrm>
+          <a:prstGeom prst="ellipse">
+            <a:avLst/>
+          </a:prstGeom>
+          <a:solidFill>
+            <a:srgbClr val="FFFFFF"/>
+          </a:solidFill>
+          <a:ln w="12700">
+            <a:solidFill>
+              <a:srgbClr val="FFFFFF"/>
+            </a:solidFill>
+            <a:prstDash val="solid"/>
+          </a:ln>
+          <a:effectLst>
+            <a:outerShdw sx="100000" sy="100000" kx="0" ky="0" algn="bl" rotWithShape="0" blurRad="38100" dist="12700" dir="16200000">
+              <a:srgbClr val="000000">
+                <a:alpha val="15000"/>
+              </a:srgbClr>
+            </a:outerShdw>
+          </a:effectLst>
+        </p:spPr>
+      </p:sp>
+      <p:pic>
+        <p:nvPicPr>
+          <p:cNvPr id="36" name="Image 4" descr="C:\Claude\MCG Full Stack\generators\assets\icons\answers.png">    </p:cNvPr>
+          <p:cNvPicPr>
+            <a:picLocks noChangeAspect="1"/>
+          </p:cNvPicPr>
+          <p:nvPr/>
+        </p:nvPicPr>
+        <p:blipFill>
+          <a:blip r:embed="rId5"/>
+          <a:stretch>
+            <a:fillRect/>
+          </a:stretch>
+        </p:blipFill>
+        <p:spPr>
+          <a:xfrm>
+            <a:off x="1704442" y="4456786"/>
+            <a:ext cx="340157" cy="340157"/>
+          </a:xfrm>
+          <a:prstGeom prst="rect">
+            <a:avLst/>
+          </a:prstGeom>
+        </p:spPr>
+      </p:pic>
+      <p:sp>
+        <p:nvSpPr>
+          <p:cNvPr id="37" name="Text 30"/>
+          <p:cNvSpPr/>
+          <p:nvPr/>
+        </p:nvSpPr>
+        <p:spPr>
+          <a:xfrm>
+            <a:off x="777240" y="4937760"/>
+            <a:ext cx="2194560" cy="310896"/>
+          </a:xfrm>
+          <a:prstGeom prst="rect">
+            <a:avLst/>
+          </a:prstGeom>
+          <a:noFill/>
+          <a:ln/>
+        </p:spPr>
+        <p:txBody>
+          <a:bodyPr wrap="square" rtlCol="0" anchor="t"/>
           <a:lstStyle/>
           <a:p>
             <a:pPr algn="ctr" indent="0" marL="0">
               <a:buNone/>
             </a:pPr>
             <a:r>
-              <a:rPr lang="en-US" sz="1200" b="1" dirty="0">
+              <a:rPr lang="en-US" sz="1300" b="1" dirty="0">
                 <a:solidFill>
                   <a:srgbClr val="FFFFFF"/>
                 </a:solidFill>
@@ -17560,20 +18660,20 @@
               </a:rPr>
               <a:t>Qlik Answers</a:t>
             </a:r>
-            <a:endParaRPr lang="en-US" sz="1200" dirty="0"/>
-          </a:p>
-        </p:txBody>
-      </p:sp>
-      <p:sp>
-        <p:nvSpPr>
-          <p:cNvPr id="30" name="Text 27"/>
-          <p:cNvSpPr/>
-          <p:nvPr/>
-        </p:nvSpPr>
-        <p:spPr>
-          <a:xfrm>
-            <a:off x="758952" y="5093208"/>
-            <a:ext cx="2231136" cy="729691"/>
+            <a:endParaRPr lang="en-US" sz="1300" dirty="0"/>
+          </a:p>
+        </p:txBody>
+      </p:sp>
+      <p:sp>
+        <p:nvSpPr>
+          <p:cNvPr id="38" name="Text 31"/>
+          <p:cNvSpPr/>
+          <p:nvPr/>
+        </p:nvSpPr>
+        <p:spPr>
+          <a:xfrm>
+            <a:off x="795528" y="5266944"/>
+            <a:ext cx="2157984" cy="621792"/>
           </a:xfrm>
           <a:prstGeom prst="rect">
             <a:avLst/>
@@ -17587,14 +18687,14 @@
           <a:p>
             <a:pPr algn="ctr" indent="0" marL="0">
               <a:lnSpc>
-                <a:spcPct val="105000"/>
+                <a:spcPct val="100000"/>
               </a:lnSpc>
               <a:buNone/>
             </a:pPr>
             <a:r>
-              <a:rPr lang="en-US" sz="1000" dirty="0">
-                <a:solidFill>
-                  <a:srgbClr val="D0D4D7"/>
+              <a:rPr lang="en-US" sz="950" dirty="0">
+                <a:solidFill>
+                  <a:srgbClr val="D8DCE0"/>
                 </a:solidFill>
                 <a:latin typeface="Inter" pitchFamily="34" charset="0"/>
                 <a:ea typeface="Inter" pitchFamily="34" charset="-122"/>
@@ -17602,19 +18702,19 @@
               </a:rPr>
               <a:t>25 DOCX docs</a:t>
             </a:r>
-            <a:endParaRPr lang="en-US" sz="1000" dirty="0"/>
+            <a:endParaRPr lang="en-US" sz="950" dirty="0"/>
           </a:p>
           <a:p>
             <a:pPr algn="ctr" indent="0" marL="0">
               <a:lnSpc>
-                <a:spcPct val="105000"/>
+                <a:spcPct val="100000"/>
               </a:lnSpc>
               <a:buNone/>
             </a:pPr>
             <a:r>
-              <a:rPr lang="en-US" sz="1000" dirty="0">
-                <a:solidFill>
-                  <a:srgbClr val="D0D4D7"/>
+              <a:rPr lang="en-US" sz="950" dirty="0">
+                <a:solidFill>
+                  <a:srgbClr val="D8DCE0"/>
                 </a:solidFill>
                 <a:latin typeface="Inter" pitchFamily="34" charset="0"/>
                 <a:ea typeface="Inter" pitchFamily="34" charset="-122"/>
@@ -17622,19 +18722,19 @@
               </a:rPr>
               <a:t>6 demo scenarios</a:t>
             </a:r>
-            <a:endParaRPr lang="en-US" sz="1000" dirty="0"/>
+            <a:endParaRPr lang="en-US" sz="950" dirty="0"/>
           </a:p>
           <a:p>
             <a:pPr algn="ctr" indent="0" marL="0">
               <a:lnSpc>
-                <a:spcPct val="105000"/>
+                <a:spcPct val="100000"/>
               </a:lnSpc>
               <a:buNone/>
             </a:pPr>
             <a:r>
-              <a:rPr lang="en-US" sz="1000" dirty="0">
-                <a:solidFill>
-                  <a:srgbClr val="D0D4D7"/>
+              <a:rPr lang="en-US" sz="950" dirty="0">
+                <a:solidFill>
+                  <a:srgbClr val="D8DCE0"/>
                 </a:solidFill>
                 <a:latin typeface="Inter" pitchFamily="34" charset="0"/>
                 <a:ea typeface="Inter" pitchFamily="34" charset="-122"/>
@@ -17642,13 +18742,13 @@
               </a:rPr>
               <a:t>Knowledge Mart</a:t>
             </a:r>
-            <a:endParaRPr lang="en-US" sz="1000" dirty="0"/>
-          </a:p>
-        </p:txBody>
-      </p:sp>
-      <p:sp>
-        <p:nvSpPr>
-          <p:cNvPr id="31" name="Shape 28"/>
+            <a:endParaRPr lang="en-US" sz="950" dirty="0"/>
+          </a:p>
+        </p:txBody>
+      </p:sp>
+      <p:sp>
+        <p:nvSpPr>
+          <p:cNvPr id="39" name="Shape 32"/>
           <p:cNvSpPr/>
           <p:nvPr/>
         </p:nvSpPr>
@@ -17682,30 +18782,86 @@
       </p:sp>
       <p:sp>
         <p:nvSpPr>
-          <p:cNvPr id="32" name="Text 29"/>
-          <p:cNvSpPr/>
-          <p:nvPr/>
-        </p:nvSpPr>
-        <p:spPr>
-          <a:xfrm>
-            <a:off x="3364992" y="4261104"/>
-            <a:ext cx="2231136" cy="868680"/>
-          </a:xfrm>
-          <a:prstGeom prst="rect">
-            <a:avLst/>
-          </a:prstGeom>
-          <a:noFill/>
-          <a:ln/>
-        </p:spPr>
-        <p:txBody>
-          <a:bodyPr wrap="square" rtlCol="0" anchor="b"/>
+          <p:cNvPr id="40" name="Shape 33"/>
+          <p:cNvSpPr/>
+          <p:nvPr/>
+        </p:nvSpPr>
+        <p:spPr>
+          <a:xfrm>
+            <a:off x="4206240" y="4352544"/>
+            <a:ext cx="548640" cy="548640"/>
+          </a:xfrm>
+          <a:prstGeom prst="ellipse">
+            <a:avLst/>
+          </a:prstGeom>
+          <a:solidFill>
+            <a:srgbClr val="FFFFFF"/>
+          </a:solidFill>
+          <a:ln w="12700">
+            <a:solidFill>
+              <a:srgbClr val="FFFFFF"/>
+            </a:solidFill>
+            <a:prstDash val="solid"/>
+          </a:ln>
+          <a:effectLst>
+            <a:outerShdw sx="100000" sy="100000" kx="0" ky="0" algn="bl" rotWithShape="0" blurRad="38100" dist="12700" dir="16200000">
+              <a:srgbClr val="000000">
+                <a:alpha val="15000"/>
+              </a:srgbClr>
+            </a:outerShdw>
+          </a:effectLst>
+        </p:spPr>
+      </p:sp>
+      <p:pic>
+        <p:nvPicPr>
+          <p:cNvPr id="41" name="Image 5" descr="C:\Claude\MCG Full Stack\generators\assets\icons\agent.png">    </p:cNvPr>
+          <p:cNvPicPr>
+            <a:picLocks noChangeAspect="1"/>
+          </p:cNvPicPr>
+          <p:nvPr/>
+        </p:nvPicPr>
+        <p:blipFill>
+          <a:blip r:embed="rId6"/>
+          <a:stretch>
+            <a:fillRect/>
+          </a:stretch>
+        </p:blipFill>
+        <p:spPr>
+          <a:xfrm>
+            <a:off x="4310482" y="4456786"/>
+            <a:ext cx="340157" cy="340157"/>
+          </a:xfrm>
+          <a:prstGeom prst="rect">
+            <a:avLst/>
+          </a:prstGeom>
+        </p:spPr>
+      </p:pic>
+      <p:sp>
+        <p:nvSpPr>
+          <p:cNvPr id="42" name="Text 34"/>
+          <p:cNvSpPr/>
+          <p:nvPr/>
+        </p:nvSpPr>
+        <p:spPr>
+          <a:xfrm>
+            <a:off x="3383280" y="4937760"/>
+            <a:ext cx="2194560" cy="310896"/>
+          </a:xfrm>
+          <a:prstGeom prst="rect">
+            <a:avLst/>
+          </a:prstGeom>
+          <a:noFill/>
+          <a:ln/>
+        </p:spPr>
+        <p:txBody>
+          <a:bodyPr wrap="square" rtlCol="0" anchor="t"/>
           <a:lstStyle/>
           <a:p>
             <a:pPr algn="ctr" indent="0" marL="0">
               <a:buNone/>
             </a:pPr>
             <a:r>
-              <a:rPr lang="en-US" sz="1200" b="1" dirty="0">
+              <a:rPr lang="en-US" sz="1300" b="1" dirty="0">
                 <a:solidFill>
                   <a:srgbClr val="FFFFFF"/>
                 </a:solidFill>
@@ -17715,20 +18871,20 @@
               </a:rPr>
               <a:t>Discovery Agent</a:t>
             </a:r>
-            <a:endParaRPr lang="en-US" sz="1200" dirty="0"/>
-          </a:p>
-        </p:txBody>
-      </p:sp>
-      <p:sp>
-        <p:nvSpPr>
-          <p:cNvPr id="33" name="Text 30"/>
-          <p:cNvSpPr/>
-          <p:nvPr/>
-        </p:nvSpPr>
-        <p:spPr>
-          <a:xfrm>
-            <a:off x="3364992" y="5093208"/>
-            <a:ext cx="2231136" cy="729691"/>
+            <a:endParaRPr lang="en-US" sz="1300" dirty="0"/>
+          </a:p>
+        </p:txBody>
+      </p:sp>
+      <p:sp>
+        <p:nvSpPr>
+          <p:cNvPr id="43" name="Text 35"/>
+          <p:cNvSpPr/>
+          <p:nvPr/>
+        </p:nvSpPr>
+        <p:spPr>
+          <a:xfrm>
+            <a:off x="3401568" y="5266944"/>
+            <a:ext cx="2157984" cy="621792"/>
           </a:xfrm>
           <a:prstGeom prst="rect">
             <a:avLst/>
@@ -17742,14 +18898,14 @@
           <a:p>
             <a:pPr algn="ctr" indent="0" marL="0">
               <a:lnSpc>
-                <a:spcPct val="105000"/>
+                <a:spcPct val="100000"/>
               </a:lnSpc>
               <a:buNone/>
             </a:pPr>
             <a:r>
-              <a:rPr lang="en-US" sz="1000" dirty="0">
-                <a:solidFill>
-                  <a:srgbClr val="D0D4D7"/>
+              <a:rPr lang="en-US" sz="950" dirty="0">
+                <a:solidFill>
+                  <a:srgbClr val="D8DCE0"/>
                 </a:solidFill>
                 <a:latin typeface="Inter" pitchFamily="34" charset="0"/>
                 <a:ea typeface="Inter" pitchFamily="34" charset="-122"/>
@@ -17757,19 +18913,19 @@
               </a:rPr>
               <a:t>Anomaly detection</a:t>
             </a:r>
-            <a:endParaRPr lang="en-US" sz="1000" dirty="0"/>
+            <a:endParaRPr lang="en-US" sz="950" dirty="0"/>
           </a:p>
           <a:p>
             <a:pPr algn="ctr" indent="0" marL="0">
               <a:lnSpc>
-                <a:spcPct val="105000"/>
+                <a:spcPct val="100000"/>
               </a:lnSpc>
               <a:buNone/>
             </a:pPr>
             <a:r>
-              <a:rPr lang="en-US" sz="1000" dirty="0">
-                <a:solidFill>
-                  <a:srgbClr val="D0D4D7"/>
+              <a:rPr lang="en-US" sz="950" dirty="0">
+                <a:solidFill>
+                  <a:srgbClr val="D8DCE0"/>
                 </a:solidFill>
                 <a:latin typeface="Inter" pitchFamily="34" charset="0"/>
                 <a:ea typeface="Inter" pitchFamily="34" charset="-122"/>
@@ -17777,19 +18933,19 @@
               </a:rPr>
               <a:t>TransFrio spoilage</a:t>
             </a:r>
-            <a:endParaRPr lang="en-US" sz="1000" dirty="0"/>
+            <a:endParaRPr lang="en-US" sz="950" dirty="0"/>
           </a:p>
           <a:p>
             <a:pPr algn="ctr" indent="0" marL="0">
               <a:lnSpc>
-                <a:spcPct val="105000"/>
+                <a:spcPct val="100000"/>
               </a:lnSpc>
               <a:buNone/>
             </a:pPr>
             <a:r>
-              <a:rPr lang="en-US" sz="1000" dirty="0">
-                <a:solidFill>
-                  <a:srgbClr val="D0D4D7"/>
+              <a:rPr lang="en-US" sz="950" dirty="0">
+                <a:solidFill>
+                  <a:srgbClr val="D8DCE0"/>
                 </a:solidFill>
                 <a:latin typeface="Inter" pitchFamily="34" charset="0"/>
                 <a:ea typeface="Inter" pitchFamily="34" charset="-122"/>
@@ -17797,13 +18953,13 @@
               </a:rPr>
               <a:t>Proactive alerts</a:t>
             </a:r>
-            <a:endParaRPr lang="en-US" sz="1000" dirty="0"/>
-          </a:p>
-        </p:txBody>
-      </p:sp>
-      <p:sp>
-        <p:nvSpPr>
-          <p:cNvPr id="34" name="Shape 31"/>
+            <a:endParaRPr lang="en-US" sz="950" dirty="0"/>
+          </a:p>
+        </p:txBody>
+      </p:sp>
+      <p:sp>
+        <p:nvSpPr>
+          <p:cNvPr id="44" name="Shape 36"/>
           <p:cNvSpPr/>
           <p:nvPr/>
         </p:nvSpPr>
@@ -17837,30 +18993,86 @@
       </p:sp>
       <p:sp>
         <p:nvSpPr>
-          <p:cNvPr id="35" name="Text 32"/>
-          <p:cNvSpPr/>
-          <p:nvPr/>
-        </p:nvSpPr>
-        <p:spPr>
-          <a:xfrm>
-            <a:off x="5971032" y="4261104"/>
-            <a:ext cx="2231136" cy="868680"/>
-          </a:xfrm>
-          <a:prstGeom prst="rect">
-            <a:avLst/>
-          </a:prstGeom>
-          <a:noFill/>
-          <a:ln/>
-        </p:spPr>
-        <p:txBody>
-          <a:bodyPr wrap="square" rtlCol="0" anchor="b"/>
+          <p:cNvPr id="45" name="Shape 37"/>
+          <p:cNvSpPr/>
+          <p:nvPr/>
+        </p:nvSpPr>
+        <p:spPr>
+          <a:xfrm>
+            <a:off x="6812280" y="4352544"/>
+            <a:ext cx="548640" cy="548640"/>
+          </a:xfrm>
+          <a:prstGeom prst="ellipse">
+            <a:avLst/>
+          </a:prstGeom>
+          <a:solidFill>
+            <a:srgbClr val="FFFFFF"/>
+          </a:solidFill>
+          <a:ln w="12700">
+            <a:solidFill>
+              <a:srgbClr val="FFFFFF"/>
+            </a:solidFill>
+            <a:prstDash val="solid"/>
+          </a:ln>
+          <a:effectLst>
+            <a:outerShdw sx="100000" sy="100000" kx="0" ky="0" algn="bl" rotWithShape="0" blurRad="38100" dist="12700" dir="16200000">
+              <a:srgbClr val="000000">
+                <a:alpha val="15000"/>
+              </a:srgbClr>
+            </a:outerShdw>
+          </a:effectLst>
+        </p:spPr>
+      </p:sp>
+      <p:pic>
+        <p:nvPicPr>
+          <p:cNvPr id="46" name="Image 6" descr="C:\Claude\MCG Full Stack\generators\assets\icons\mcp.png">    </p:cNvPr>
+          <p:cNvPicPr>
+            <a:picLocks noChangeAspect="1"/>
+          </p:cNvPicPr>
+          <p:nvPr/>
+        </p:nvPicPr>
+        <p:blipFill>
+          <a:blip r:embed="rId7"/>
+          <a:stretch>
+            <a:fillRect/>
+          </a:stretch>
+        </p:blipFill>
+        <p:spPr>
+          <a:xfrm>
+            <a:off x="6916522" y="4456786"/>
+            <a:ext cx="340157" cy="340157"/>
+          </a:xfrm>
+          <a:prstGeom prst="rect">
+            <a:avLst/>
+          </a:prstGeom>
+        </p:spPr>
+      </p:pic>
+      <p:sp>
+        <p:nvSpPr>
+          <p:cNvPr id="47" name="Text 38"/>
+          <p:cNvSpPr/>
+          <p:nvPr/>
+        </p:nvSpPr>
+        <p:spPr>
+          <a:xfrm>
+            <a:off x="5989320" y="4937760"/>
+            <a:ext cx="2194560" cy="310896"/>
+          </a:xfrm>
+          <a:prstGeom prst="rect">
+            <a:avLst/>
+          </a:prstGeom>
+          <a:noFill/>
+          <a:ln/>
+        </p:spPr>
+        <p:txBody>
+          <a:bodyPr wrap="square" rtlCol="0" anchor="t"/>
           <a:lstStyle/>
           <a:p>
             <a:pPr algn="ctr" indent="0" marL="0">
               <a:buNone/>
             </a:pPr>
             <a:r>
-              <a:rPr lang="en-US" sz="1200" b="1" dirty="0">
+              <a:rPr lang="en-US" sz="1300" b="1" dirty="0">
                 <a:solidFill>
                   <a:srgbClr val="FFFFFF"/>
                 </a:solidFill>
@@ -17870,20 +19082,20 @@
               </a:rPr>
               <a:t>MCP Server</a:t>
             </a:r>
-            <a:endParaRPr lang="en-US" sz="1200" dirty="0"/>
-          </a:p>
-        </p:txBody>
-      </p:sp>
-      <p:sp>
-        <p:nvSpPr>
-          <p:cNvPr id="36" name="Text 33"/>
-          <p:cNvSpPr/>
-          <p:nvPr/>
-        </p:nvSpPr>
-        <p:spPr>
-          <a:xfrm>
-            <a:off x="5971032" y="5093208"/>
-            <a:ext cx="2231136" cy="729691"/>
+            <a:endParaRPr lang="en-US" sz="1300" dirty="0"/>
+          </a:p>
+        </p:txBody>
+      </p:sp>
+      <p:sp>
+        <p:nvSpPr>
+          <p:cNvPr id="48" name="Text 39"/>
+          <p:cNvSpPr/>
+          <p:nvPr/>
+        </p:nvSpPr>
+        <p:spPr>
+          <a:xfrm>
+            <a:off x="6007608" y="5266944"/>
+            <a:ext cx="2157984" cy="621792"/>
           </a:xfrm>
           <a:prstGeom prst="rect">
             <a:avLst/>
@@ -17897,14 +19109,14 @@
           <a:p>
             <a:pPr algn="ctr" indent="0" marL="0">
               <a:lnSpc>
-                <a:spcPct val="105000"/>
+                <a:spcPct val="100000"/>
               </a:lnSpc>
               <a:buNone/>
             </a:pPr>
             <a:r>
-              <a:rPr lang="en-US" sz="1000" dirty="0">
-                <a:solidFill>
-                  <a:srgbClr val="D0D4D7"/>
+              <a:rPr lang="en-US" sz="950" dirty="0">
+                <a:solidFill>
+                  <a:srgbClr val="D8DCE0"/>
                 </a:solidFill>
                 <a:latin typeface="Inter" pitchFamily="34" charset="0"/>
                 <a:ea typeface="Inter" pitchFamily="34" charset="-122"/>
@@ -17912,19 +19124,19 @@
               </a:rPr>
               <a:t>Claude integration</a:t>
             </a:r>
-            <a:endParaRPr lang="en-US" sz="1000" dirty="0"/>
+            <a:endParaRPr lang="en-US" sz="950" dirty="0"/>
           </a:p>
           <a:p>
             <a:pPr algn="ctr" indent="0" marL="0">
               <a:lnSpc>
-                <a:spcPct val="105000"/>
+                <a:spcPct val="100000"/>
               </a:lnSpc>
               <a:buNone/>
             </a:pPr>
             <a:r>
-              <a:rPr lang="en-US" sz="1000" dirty="0">
-                <a:solidFill>
-                  <a:srgbClr val="D0D4D7"/>
+              <a:rPr lang="en-US" sz="950" dirty="0">
+                <a:solidFill>
+                  <a:srgbClr val="D8DCE0"/>
                 </a:solidFill>
                 <a:latin typeface="Inter" pitchFamily="34" charset="0"/>
                 <a:ea typeface="Inter" pitchFamily="34" charset="-122"/>
@@ -17932,19 +19144,19 @@
               </a:rPr>
               <a:t>5 demo prompts</a:t>
             </a:r>
-            <a:endParaRPr lang="en-US" sz="1000" dirty="0"/>
+            <a:endParaRPr lang="en-US" sz="950" dirty="0"/>
           </a:p>
           <a:p>
             <a:pPr algn="ctr" indent="0" marL="0">
               <a:lnSpc>
-                <a:spcPct val="105000"/>
+                <a:spcPct val="100000"/>
               </a:lnSpc>
               <a:buNone/>
             </a:pPr>
             <a:r>
-              <a:rPr lang="en-US" sz="1000" dirty="0">
-                <a:solidFill>
-                  <a:srgbClr val="D0D4D7"/>
+              <a:rPr lang="en-US" sz="950" dirty="0">
+                <a:solidFill>
+                  <a:srgbClr val="D8DCE0"/>
                 </a:solidFill>
                 <a:latin typeface="Inter" pitchFamily="34" charset="0"/>
                 <a:ea typeface="Inter" pitchFamily="34" charset="-122"/>
@@ -17952,13 +19164,13 @@
               </a:rPr>
               <a:t>Data + docs</a:t>
             </a:r>
-            <a:endParaRPr lang="en-US" sz="1000" dirty="0"/>
-          </a:p>
-        </p:txBody>
-      </p:sp>
-      <p:sp>
-        <p:nvSpPr>
-          <p:cNvPr id="37" name="Shape 34"/>
+            <a:endParaRPr lang="en-US" sz="950" dirty="0"/>
+          </a:p>
+        </p:txBody>
+      </p:sp>
+      <p:sp>
+        <p:nvSpPr>
+          <p:cNvPr id="49" name="Shape 40"/>
           <p:cNvSpPr/>
           <p:nvPr/>
         </p:nvSpPr>
@@ -17992,30 +19204,86 @@
       </p:sp>
       <p:sp>
         <p:nvSpPr>
-          <p:cNvPr id="38" name="Text 35"/>
-          <p:cNvSpPr/>
-          <p:nvPr/>
-        </p:nvSpPr>
-        <p:spPr>
-          <a:xfrm>
-            <a:off x="8577072" y="4261104"/>
-            <a:ext cx="2231136" cy="868680"/>
-          </a:xfrm>
-          <a:prstGeom prst="rect">
-            <a:avLst/>
-          </a:prstGeom>
-          <a:noFill/>
-          <a:ln/>
-        </p:spPr>
-        <p:txBody>
-          <a:bodyPr wrap="square" rtlCol="0" anchor="b"/>
+          <p:cNvPr id="50" name="Shape 41"/>
+          <p:cNvSpPr/>
+          <p:nvPr/>
+        </p:nvSpPr>
+        <p:spPr>
+          <a:xfrm>
+            <a:off x="9418320" y="4352544"/>
+            <a:ext cx="548640" cy="548640"/>
+          </a:xfrm>
+          <a:prstGeom prst="ellipse">
+            <a:avLst/>
+          </a:prstGeom>
+          <a:solidFill>
+            <a:srgbClr val="FFFFFF"/>
+          </a:solidFill>
+          <a:ln w="12700">
+            <a:solidFill>
+              <a:srgbClr val="FFFFFF"/>
+            </a:solidFill>
+            <a:prstDash val="solid"/>
+          </a:ln>
+          <a:effectLst>
+            <a:outerShdw sx="100000" sy="100000" kx="0" ky="0" algn="bl" rotWithShape="0" blurRad="38100" dist="12700" dir="16200000">
+              <a:srgbClr val="000000">
+                <a:alpha val="15000"/>
+              </a:srgbClr>
+            </a:outerShdw>
+          </a:effectLst>
+        </p:spPr>
+      </p:sp>
+      <p:pic>
+        <p:nvPicPr>
+          <p:cNvPr id="51" name="Image 7" descr="C:\Claude\MCG Full Stack\generators\assets\icons\automation.png">    </p:cNvPr>
+          <p:cNvPicPr>
+            <a:picLocks noChangeAspect="1"/>
+          </p:cNvPicPr>
+          <p:nvPr/>
+        </p:nvPicPr>
+        <p:blipFill>
+          <a:blip r:embed="rId8"/>
+          <a:stretch>
+            <a:fillRect/>
+          </a:stretch>
+        </p:blipFill>
+        <p:spPr>
+          <a:xfrm>
+            <a:off x="9522562" y="4456786"/>
+            <a:ext cx="340157" cy="340157"/>
+          </a:xfrm>
+          <a:prstGeom prst="rect">
+            <a:avLst/>
+          </a:prstGeom>
+        </p:spPr>
+      </p:pic>
+      <p:sp>
+        <p:nvSpPr>
+          <p:cNvPr id="52" name="Text 42"/>
+          <p:cNvSpPr/>
+          <p:nvPr/>
+        </p:nvSpPr>
+        <p:spPr>
+          <a:xfrm>
+            <a:off x="8595360" y="4937760"/>
+            <a:ext cx="2194560" cy="310896"/>
+          </a:xfrm>
+          <a:prstGeom prst="rect">
+            <a:avLst/>
+          </a:prstGeom>
+          <a:noFill/>
+          <a:ln/>
+        </p:spPr>
+        <p:txBody>
+          <a:bodyPr wrap="square" rtlCol="0" anchor="t"/>
           <a:lstStyle/>
           <a:p>
             <a:pPr algn="ctr" indent="0" marL="0">
               <a:buNone/>
             </a:pPr>
             <a:r>
-              <a:rPr lang="en-US" sz="1200" b="1" dirty="0">
+              <a:rPr lang="en-US" sz="1300" b="1" dirty="0">
                 <a:solidFill>
                   <a:srgbClr val="FFFFFF"/>
                 </a:solidFill>
@@ -18025,20 +19293,20 @@
               </a:rPr>
               <a:t>Automations</a:t>
             </a:r>
-            <a:endParaRPr lang="en-US" sz="1200" dirty="0"/>
-          </a:p>
-        </p:txBody>
-      </p:sp>
-      <p:sp>
-        <p:nvSpPr>
-          <p:cNvPr id="39" name="Text 36"/>
-          <p:cNvSpPr/>
-          <p:nvPr/>
-        </p:nvSpPr>
-        <p:spPr>
-          <a:xfrm>
-            <a:off x="8577072" y="5093208"/>
-            <a:ext cx="2231136" cy="729691"/>
+            <a:endParaRPr lang="en-US" sz="1300" dirty="0"/>
+          </a:p>
+        </p:txBody>
+      </p:sp>
+      <p:sp>
+        <p:nvSpPr>
+          <p:cNvPr id="53" name="Text 43"/>
+          <p:cNvSpPr/>
+          <p:nvPr/>
+        </p:nvSpPr>
+        <p:spPr>
+          <a:xfrm>
+            <a:off x="8613648" y="5266944"/>
+            <a:ext cx="2157984" cy="621792"/>
           </a:xfrm>
           <a:prstGeom prst="rect">
             <a:avLst/>
@@ -18052,14 +19320,14 @@
           <a:p>
             <a:pPr algn="ctr" indent="0" marL="0">
               <a:lnSpc>
-                <a:spcPct val="105000"/>
+                <a:spcPct val="100000"/>
               </a:lnSpc>
               <a:buNone/>
             </a:pPr>
             <a:r>
-              <a:rPr lang="en-US" sz="1000" dirty="0">
-                <a:solidFill>
-                  <a:srgbClr val="D0D4D7"/>
+              <a:rPr lang="en-US" sz="950" dirty="0">
+                <a:solidFill>
+                  <a:srgbClr val="D8DCE0"/>
                 </a:solidFill>
                 <a:latin typeface="Inter" pitchFamily="34" charset="0"/>
                 <a:ea typeface="Inter" pitchFamily="34" charset="-122"/>
@@ -18067,19 +19335,19 @@
               </a:rPr>
               <a:t>5 automations</a:t>
             </a:r>
-            <a:endParaRPr lang="en-US" sz="1000" dirty="0"/>
+            <a:endParaRPr lang="en-US" sz="950" dirty="0"/>
           </a:p>
           <a:p>
             <a:pPr algn="ctr" indent="0" marL="0">
               <a:lnSpc>
-                <a:spcPct val="105000"/>
+                <a:spcPct val="100000"/>
               </a:lnSpc>
               <a:buNone/>
             </a:pPr>
             <a:r>
-              <a:rPr lang="en-US" sz="1000" dirty="0">
-                <a:solidFill>
-                  <a:srgbClr val="D0D4D7"/>
+              <a:rPr lang="en-US" sz="950" dirty="0">
+                <a:solidFill>
+                  <a:srgbClr val="D8DCE0"/>
                 </a:solidFill>
                 <a:latin typeface="Inter" pitchFamily="34" charset="0"/>
                 <a:ea typeface="Inter" pitchFamily="34" charset="-122"/>
@@ -18087,19 +19355,19 @@
               </a:rPr>
               <a:t>Teams integration</a:t>
             </a:r>
-            <a:endParaRPr lang="en-US" sz="1000" dirty="0"/>
+            <a:endParaRPr lang="en-US" sz="950" dirty="0"/>
           </a:p>
           <a:p>
             <a:pPr algn="ctr" indent="0" marL="0">
               <a:lnSpc>
-                <a:spcPct val="105000"/>
+                <a:spcPct val="100000"/>
               </a:lnSpc>
               <a:buNone/>
             </a:pPr>
             <a:r>
-              <a:rPr lang="en-US" sz="1000" dirty="0">
-                <a:solidFill>
-                  <a:srgbClr val="D0D4D7"/>
+              <a:rPr lang="en-US" sz="950" dirty="0">
+                <a:solidFill>
+                  <a:srgbClr val="D8DCE0"/>
                 </a:solidFill>
                 <a:latin typeface="Inter" pitchFamily="34" charset="0"/>
                 <a:ea typeface="Inter" pitchFamily="34" charset="-122"/>
@@ -18107,7 +19375,7 @@
               </a:rPr>
               <a:t>Talend job trigger</a:t>
             </a:r>
-            <a:endParaRPr lang="en-US" sz="1000" dirty="0"/>
+            <a:endParaRPr lang="en-US" sz="950" dirty="0"/>
           </a:p>
         </p:txBody>
       </p:sp>

</xml_diff>